<commit_message>
Week 7: remove em dashes and add notebook cues to L13 deck
Every em dash replaced with punctuation that reads naturally. Adds a green
'TO THE NOTEBOOK' pill on all 15 demo slides naming the exact Colab section
to switch to.

Co-Authored-By: Claude Opus 4.8 <noreply@anthropic.com>
</commit_message>
<xml_diff>
--- a/Week 7/L13_Support_Copilot.pptx
+++ b/Week 7/L13_Support_Copilot.pptx
@@ -3209,7 +3209,7 @@
                 </a:solidFill>
                 <a:latin typeface="Helvetica Neue"/>
               </a:rPr>
-              <a:t>Part 1 — the layer that reads</a:t>
+              <a:t>Part 1: the layer that reads</a:t>
             </a:r>
           </a:p>
         </p:txBody>
@@ -3872,6 +3872,86 @@
           </a:prstGeom>
         </p:spPr>
       </p:pic>
+      <p:sp>
+        <p:nvSpPr>
+          <p:cNvPr id="16" name="Rounded Rectangle 15"/>
+          <p:cNvSpPr/>
+          <p:nvPr/>
+        </p:nvSpPr>
+        <p:spPr>
+          <a:xfrm>
+            <a:off x="6830568" y="6382512"/>
+            <a:ext cx="4721047" cy="310896"/>
+          </a:xfrm>
+          <a:prstGeom prst="roundRect">
+            <a:avLst>
+              <a:gd name="adj" fmla="val 44000"/>
+            </a:avLst>
+          </a:prstGeom>
+          <a:solidFill>
+            <a:srgbClr val="059669"/>
+          </a:solidFill>
+          <a:ln>
+            <a:noFill/>
+          </a:ln>
+        </p:spPr>
+        <p:style>
+          <a:lnRef idx="1">
+            <a:schemeClr val="accent1"/>
+          </a:lnRef>
+          <a:fillRef idx="3">
+            <a:schemeClr val="accent1"/>
+          </a:fillRef>
+          <a:effectRef idx="2">
+            <a:schemeClr val="accent1"/>
+          </a:effectRef>
+          <a:fontRef idx="minor">
+            <a:schemeClr val="lt1"/>
+          </a:fontRef>
+        </p:style>
+        <p:txBody>
+          <a:bodyPr rtlCol="0" anchor="ctr"/>
+          <a:lstStyle/>
+          <a:p>
+            <a:pPr algn="ctr"/>
+          </a:p>
+        </p:txBody>
+      </p:sp>
+      <p:sp>
+        <p:nvSpPr>
+          <p:cNvPr id="17" name="TextBox 16"/>
+          <p:cNvSpPr txBox="1"/>
+          <p:nvPr/>
+        </p:nvSpPr>
+        <p:spPr>
+          <a:xfrm>
+            <a:off x="6830568" y="6432804"/>
+            <a:ext cx="4721047" cy="237744"/>
+          </a:xfrm>
+          <a:prstGeom prst="rect">
+            <a:avLst/>
+          </a:prstGeom>
+          <a:noFill/>
+        </p:spPr>
+        <p:txBody>
+          <a:bodyPr wrap="square">
+            <a:spAutoFit/>
+          </a:bodyPr>
+          <a:lstStyle/>
+          <a:p>
+            <a:pPr algn="ctr"/>
+            <a:r>
+              <a:rPr sz="1050" b="1" i="0">
+                <a:solidFill>
+                  <a:srgbClr val="FFFFFF"/>
+                </a:solidFill>
+                <a:latin typeface="Helvetica Neue"/>
+              </a:rPr>
+              <a:t>▶  TO THE NOTEBOOK      Act 1 · “The shape of the whole inbox”</a:t>
+            </a:r>
+          </a:p>
+        </p:txBody>
+      </p:sp>
     </p:spTree>
   </p:cSld>
   <p:clrMapOvr>
@@ -4382,6 +4462,86 @@
           </a:prstGeom>
         </p:spPr>
       </p:pic>
+      <p:sp>
+        <p:nvSpPr>
+          <p:cNvPr id="15" name="Rounded Rectangle 14"/>
+          <p:cNvSpPr/>
+          <p:nvPr/>
+        </p:nvSpPr>
+        <p:spPr>
+          <a:xfrm>
+            <a:off x="6480810" y="6382512"/>
+            <a:ext cx="5070805" cy="310896"/>
+          </a:xfrm>
+          <a:prstGeom prst="roundRect">
+            <a:avLst>
+              <a:gd name="adj" fmla="val 44000"/>
+            </a:avLst>
+          </a:prstGeom>
+          <a:solidFill>
+            <a:srgbClr val="059669"/>
+          </a:solidFill>
+          <a:ln>
+            <a:noFill/>
+          </a:ln>
+        </p:spPr>
+        <p:style>
+          <a:lnRef idx="1">
+            <a:schemeClr val="accent1"/>
+          </a:lnRef>
+          <a:fillRef idx="3">
+            <a:schemeClr val="accent1"/>
+          </a:fillRef>
+          <a:effectRef idx="2">
+            <a:schemeClr val="accent1"/>
+          </a:effectRef>
+          <a:fontRef idx="minor">
+            <a:schemeClr val="lt1"/>
+          </a:fontRef>
+        </p:style>
+        <p:txBody>
+          <a:bodyPr rtlCol="0" anchor="ctr"/>
+          <a:lstStyle/>
+          <a:p>
+            <a:pPr algn="ctr"/>
+          </a:p>
+        </p:txBody>
+      </p:sp>
+      <p:sp>
+        <p:nvSpPr>
+          <p:cNvPr id="16" name="TextBox 15"/>
+          <p:cNvSpPr txBox="1"/>
+          <p:nvPr/>
+        </p:nvSpPr>
+        <p:spPr>
+          <a:xfrm>
+            <a:off x="6480810" y="6432804"/>
+            <a:ext cx="5070805" cy="237744"/>
+          </a:xfrm>
+          <a:prstGeom prst="rect">
+            <a:avLst/>
+          </a:prstGeom>
+          <a:noFill/>
+        </p:spPr>
+        <p:txBody>
+          <a:bodyPr wrap="square">
+            <a:spAutoFit/>
+          </a:bodyPr>
+          <a:lstStyle/>
+          <a:p>
+            <a:pPr algn="ctr"/>
+            <a:r>
+              <a:rPr sz="1050" b="1" i="0">
+                <a:solidFill>
+                  <a:srgbClr val="FFFFFF"/>
+                </a:solidFill>
+                <a:latin typeface="Helvetica Neue"/>
+              </a:rPr>
+              <a:t>▶  TO THE NOTEBOOK      Act 2 · “Route with zero labelled examples”</a:t>
+            </a:r>
+          </a:p>
+        </p:txBody>
+      </p:sp>
     </p:spTree>
   </p:cSld>
   <p:clrMapOvr>
@@ -4929,7 +5089,87 @@
       </p:pic>
       <p:sp>
         <p:nvSpPr>
-          <p:cNvPr id="16" name="TextBox 15"/>
+          <p:cNvPr id="16" name="Rounded Rectangle 15"/>
+          <p:cNvSpPr/>
+          <p:nvPr/>
+        </p:nvSpPr>
+        <p:spPr>
+          <a:xfrm>
+            <a:off x="5571439" y="6382512"/>
+            <a:ext cx="5980176" cy="310896"/>
+          </a:xfrm>
+          <a:prstGeom prst="roundRect">
+            <a:avLst>
+              <a:gd name="adj" fmla="val 44000"/>
+            </a:avLst>
+          </a:prstGeom>
+          <a:solidFill>
+            <a:srgbClr val="059669"/>
+          </a:solidFill>
+          <a:ln>
+            <a:noFill/>
+          </a:ln>
+        </p:spPr>
+        <p:style>
+          <a:lnRef idx="1">
+            <a:schemeClr val="accent1"/>
+          </a:lnRef>
+          <a:fillRef idx="3">
+            <a:schemeClr val="accent1"/>
+          </a:fillRef>
+          <a:effectRef idx="2">
+            <a:schemeClr val="accent1"/>
+          </a:effectRef>
+          <a:fontRef idx="minor">
+            <a:schemeClr val="lt1"/>
+          </a:fontRef>
+        </p:style>
+        <p:txBody>
+          <a:bodyPr rtlCol="0" anchor="ctr"/>
+          <a:lstStyle/>
+          <a:p>
+            <a:pPr algn="ctr"/>
+          </a:p>
+        </p:txBody>
+      </p:sp>
+      <p:sp>
+        <p:nvSpPr>
+          <p:cNvPr id="17" name="TextBox 16"/>
+          <p:cNvSpPr txBox="1"/>
+          <p:nvPr/>
+        </p:nvSpPr>
+        <p:spPr>
+          <a:xfrm>
+            <a:off x="5571439" y="6432804"/>
+            <a:ext cx="5980176" cy="237744"/>
+          </a:xfrm>
+          <a:prstGeom prst="rect">
+            <a:avLst/>
+          </a:prstGeom>
+          <a:noFill/>
+        </p:spPr>
+        <p:txBody>
+          <a:bodyPr wrap="square">
+            <a:spAutoFit/>
+          </a:bodyPr>
+          <a:lstStyle/>
+          <a:p>
+            <a:pPr algn="ctr"/>
+            <a:r>
+              <a:rPr sz="1050" b="1" i="0">
+                <a:solidFill>
+                  <a:srgbClr val="FFFFFF"/>
+                </a:solidFill>
+                <a:latin typeface="Helvetica Neue"/>
+              </a:rPr>
+              <a:t>▶  TO THE NOTEBOOK      Act 2 · “Under the hood: zero-shot isn't classification”</a:t>
+            </a:r>
+          </a:p>
+        </p:txBody>
+      </p:sp>
+      <p:sp>
+        <p:nvSpPr>
+          <p:cNvPr id="18" name="TextBox 17"/>
           <p:cNvSpPr txBox="1"/>
           <p:nvPr/>
         </p:nvSpPr>
@@ -5472,6 +5712,86 @@
           </a:prstGeom>
         </p:spPr>
       </p:pic>
+      <p:sp>
+        <p:nvSpPr>
+          <p:cNvPr id="15" name="Rounded Rectangle 14"/>
+          <p:cNvSpPr/>
+          <p:nvPr/>
+        </p:nvSpPr>
+        <p:spPr>
+          <a:xfrm>
+            <a:off x="7110374" y="6382512"/>
+            <a:ext cx="4441240" cy="310896"/>
+          </a:xfrm>
+          <a:prstGeom prst="roundRect">
+            <a:avLst>
+              <a:gd name="adj" fmla="val 44000"/>
+            </a:avLst>
+          </a:prstGeom>
+          <a:solidFill>
+            <a:srgbClr val="059669"/>
+          </a:solidFill>
+          <a:ln>
+            <a:noFill/>
+          </a:ln>
+        </p:spPr>
+        <p:style>
+          <a:lnRef idx="1">
+            <a:schemeClr val="accent1"/>
+          </a:lnRef>
+          <a:fillRef idx="3">
+            <a:schemeClr val="accent1"/>
+          </a:fillRef>
+          <a:effectRef idx="2">
+            <a:schemeClr val="accent1"/>
+          </a:effectRef>
+          <a:fontRef idx="minor">
+            <a:schemeClr val="lt1"/>
+          </a:fontRef>
+        </p:style>
+        <p:txBody>
+          <a:bodyPr rtlCol="0" anchor="ctr"/>
+          <a:lstStyle/>
+          <a:p>
+            <a:pPr algn="ctr"/>
+          </a:p>
+        </p:txBody>
+      </p:sp>
+      <p:sp>
+        <p:nvSpPr>
+          <p:cNvPr id="16" name="TextBox 15"/>
+          <p:cNvSpPr txBox="1"/>
+          <p:nvPr/>
+        </p:nvSpPr>
+        <p:spPr>
+          <a:xfrm>
+            <a:off x="7110374" y="6432804"/>
+            <a:ext cx="4441240" cy="237744"/>
+          </a:xfrm>
+          <a:prstGeom prst="rect">
+            <a:avLst/>
+          </a:prstGeom>
+          <a:noFill/>
+        </p:spPr>
+        <p:txBody>
+          <a:bodyPr wrap="square">
+            <a:spAutoFit/>
+          </a:bodyPr>
+          <a:lstStyle/>
+          <a:p>
+            <a:pPr algn="ctr"/>
+            <a:r>
+              <a:rPr sz="1050" b="1" i="0">
+                <a:solidFill>
+                  <a:srgbClr val="FFFFFF"/>
+                </a:solidFill>
+                <a:latin typeface="Helvetica Neue"/>
+              </a:rPr>
+              <a:t>▶  TO THE NOTEBOOK      Act 2 · same cell, read the logits</a:t>
+            </a:r>
+          </a:p>
+        </p:txBody>
+      </p:sp>
     </p:spTree>
   </p:cSld>
   <p:clrMapOvr>
@@ -5982,6 +6302,86 @@
           </a:prstGeom>
         </p:spPr>
       </p:pic>
+      <p:sp>
+        <p:nvSpPr>
+          <p:cNvPr id="15" name="Rounded Rectangle 14"/>
+          <p:cNvSpPr/>
+          <p:nvPr/>
+        </p:nvSpPr>
+        <p:spPr>
+          <a:xfrm>
+            <a:off x="6480810" y="6382512"/>
+            <a:ext cx="5070805" cy="310896"/>
+          </a:xfrm>
+          <a:prstGeom prst="roundRect">
+            <a:avLst>
+              <a:gd name="adj" fmla="val 44000"/>
+            </a:avLst>
+          </a:prstGeom>
+          <a:solidFill>
+            <a:srgbClr val="059669"/>
+          </a:solidFill>
+          <a:ln>
+            <a:noFill/>
+          </a:ln>
+        </p:spPr>
+        <p:style>
+          <a:lnRef idx="1">
+            <a:schemeClr val="accent1"/>
+          </a:lnRef>
+          <a:fillRef idx="3">
+            <a:schemeClr val="accent1"/>
+          </a:fillRef>
+          <a:effectRef idx="2">
+            <a:schemeClr val="accent1"/>
+          </a:effectRef>
+          <a:fontRef idx="minor">
+            <a:schemeClr val="lt1"/>
+          </a:fontRef>
+        </p:style>
+        <p:txBody>
+          <a:bodyPr rtlCol="0" anchor="ctr"/>
+          <a:lstStyle/>
+          <a:p>
+            <a:pPr algn="ctr"/>
+          </a:p>
+        </p:txBody>
+      </p:sp>
+      <p:sp>
+        <p:nvSpPr>
+          <p:cNvPr id="16" name="TextBox 15"/>
+          <p:cNvSpPr txBox="1"/>
+          <p:nvPr/>
+        </p:nvSpPr>
+        <p:spPr>
+          <a:xfrm>
+            <a:off x="6480810" y="6432804"/>
+            <a:ext cx="5070805" cy="237744"/>
+          </a:xfrm>
+          <a:prstGeom prst="rect">
+            <a:avLst/>
+          </a:prstGeom>
+          <a:noFill/>
+        </p:spPr>
+        <p:txBody>
+          <a:bodyPr wrap="square">
+            <a:spAutoFit/>
+          </a:bodyPr>
+          <a:lstStyle/>
+          <a:p>
+            <a:pPr algn="ctr"/>
+            <a:r>
+              <a:rPr sz="1050" b="1" i="0">
+                <a:solidFill>
+                  <a:srgbClr val="FFFFFF"/>
+                </a:solidFill>
+                <a:latin typeface="Helvetica Neue"/>
+              </a:rPr>
+              <a:t>▶  TO THE NOTEBOOK      Act 2 · YOUR KNOB: rewrite the descriptions</a:t>
+            </a:r>
+          </a:p>
+        </p:txBody>
+      </p:sp>
     </p:spTree>
   </p:cSld>
   <p:clrMapOvr>
@@ -6529,7 +6929,87 @@
       </p:pic>
       <p:sp>
         <p:nvSpPr>
-          <p:cNvPr id="16" name="TextBox 15"/>
+          <p:cNvPr id="16" name="Rounded Rectangle 15"/>
+          <p:cNvSpPr/>
+          <p:nvPr/>
+        </p:nvSpPr>
+        <p:spPr>
+          <a:xfrm>
+            <a:off x="7739938" y="6382512"/>
+            <a:ext cx="3811676" cy="310896"/>
+          </a:xfrm>
+          <a:prstGeom prst="roundRect">
+            <a:avLst>
+              <a:gd name="adj" fmla="val 44000"/>
+            </a:avLst>
+          </a:prstGeom>
+          <a:solidFill>
+            <a:srgbClr val="059669"/>
+          </a:solidFill>
+          <a:ln>
+            <a:noFill/>
+          </a:ln>
+        </p:spPr>
+        <p:style>
+          <a:lnRef idx="1">
+            <a:schemeClr val="accent1"/>
+          </a:lnRef>
+          <a:fillRef idx="3">
+            <a:schemeClr val="accent1"/>
+          </a:fillRef>
+          <a:effectRef idx="2">
+            <a:schemeClr val="accent1"/>
+          </a:effectRef>
+          <a:fontRef idx="minor">
+            <a:schemeClr val="lt1"/>
+          </a:fontRef>
+        </p:style>
+        <p:txBody>
+          <a:bodyPr rtlCol="0" anchor="ctr"/>
+          <a:lstStyle/>
+          <a:p>
+            <a:pPr algn="ctr"/>
+          </a:p>
+        </p:txBody>
+      </p:sp>
+      <p:sp>
+        <p:nvSpPr>
+          <p:cNvPr id="17" name="TextBox 16"/>
+          <p:cNvSpPr txBox="1"/>
+          <p:nvPr/>
+        </p:nvSpPr>
+        <p:spPr>
+          <a:xfrm>
+            <a:off x="7739938" y="6432804"/>
+            <a:ext cx="3811676" cy="237744"/>
+          </a:xfrm>
+          <a:prstGeom prst="rect">
+            <a:avLst/>
+          </a:prstGeom>
+          <a:noFill/>
+        </p:spPr>
+        <p:txBody>
+          <a:bodyPr wrap="square">
+            <a:spAutoFit/>
+          </a:bodyPr>
+          <a:lstStyle/>
+          <a:p>
+            <a:pPr algn="ctr"/>
+            <a:r>
+              <a:rPr sz="1050" b="1" i="0">
+                <a:solidFill>
+                  <a:srgbClr val="FFFFFF"/>
+                </a:solidFill>
+                <a:latin typeface="Helvetica Neue"/>
+              </a:rPr>
+              <a:t>▶  TO THE NOTEBOOK      Act 3 · “Where v1 breaks”</a:t>
+            </a:r>
+          </a:p>
+        </p:txBody>
+      </p:sp>
+      <p:sp>
+        <p:nvSpPr>
+          <p:cNvPr id="18" name="TextBox 17"/>
           <p:cNvSpPr txBox="1"/>
           <p:nvPr/>
         </p:nvSpPr>
@@ -7072,6 +7552,86 @@
           </a:prstGeom>
         </p:spPr>
       </p:pic>
+      <p:sp>
+        <p:nvSpPr>
+          <p:cNvPr id="15" name="Rounded Rectangle 14"/>
+          <p:cNvSpPr/>
+          <p:nvPr/>
+        </p:nvSpPr>
+        <p:spPr>
+          <a:xfrm>
+            <a:off x="6690664" y="6382512"/>
+            <a:ext cx="4860950" cy="310896"/>
+          </a:xfrm>
+          <a:prstGeom prst="roundRect">
+            <a:avLst>
+              <a:gd name="adj" fmla="val 44000"/>
+            </a:avLst>
+          </a:prstGeom>
+          <a:solidFill>
+            <a:srgbClr val="059669"/>
+          </a:solidFill>
+          <a:ln>
+            <a:noFill/>
+          </a:ln>
+        </p:spPr>
+        <p:style>
+          <a:lnRef idx="1">
+            <a:schemeClr val="accent1"/>
+          </a:lnRef>
+          <a:fillRef idx="3">
+            <a:schemeClr val="accent1"/>
+          </a:fillRef>
+          <a:effectRef idx="2">
+            <a:schemeClr val="accent1"/>
+          </a:effectRef>
+          <a:fontRef idx="minor">
+            <a:schemeClr val="lt1"/>
+          </a:fontRef>
+        </p:style>
+        <p:txBody>
+          <a:bodyPr rtlCol="0" anchor="ctr"/>
+          <a:lstStyle/>
+          <a:p>
+            <a:pPr algn="ctr"/>
+          </a:p>
+        </p:txBody>
+      </p:sp>
+      <p:sp>
+        <p:nvSpPr>
+          <p:cNvPr id="16" name="TextBox 15"/>
+          <p:cNvSpPr txBox="1"/>
+          <p:nvPr/>
+        </p:nvSpPr>
+        <p:spPr>
+          <a:xfrm>
+            <a:off x="6690664" y="6432804"/>
+            <a:ext cx="4860950" cy="237744"/>
+          </a:xfrm>
+          <a:prstGeom prst="rect">
+            <a:avLst/>
+          </a:prstGeom>
+          <a:noFill/>
+        </p:spPr>
+        <p:txBody>
+          <a:bodyPr wrap="square">
+            <a:spAutoFit/>
+          </a:bodyPr>
+          <a:lstStyle/>
+          <a:p>
+            <a:pPr algn="ctr"/>
+            <a:r>
+              <a:rPr sz="1050" b="1" i="0">
+                <a:solidFill>
+                  <a:srgbClr val="FFFFFF"/>
+                </a:solidFill>
+                <a:latin typeface="Helvetica Neue"/>
+              </a:rPr>
+              <a:t>▶  TO THE NOTEBOOK      Act 3 · “Why was it 99% sure and wrong?”</a:t>
+            </a:r>
+          </a:p>
+        </p:txBody>
+      </p:sp>
     </p:spTree>
   </p:cSld>
   <p:clrMapOvr>
@@ -7582,6 +8142,86 @@
           </a:prstGeom>
         </p:spPr>
       </p:pic>
+      <p:sp>
+        <p:nvSpPr>
+          <p:cNvPr id="15" name="Rounded Rectangle 14"/>
+          <p:cNvSpPr/>
+          <p:nvPr/>
+        </p:nvSpPr>
+        <p:spPr>
+          <a:xfrm>
+            <a:off x="7180326" y="6382512"/>
+            <a:ext cx="4371289" cy="310896"/>
+          </a:xfrm>
+          <a:prstGeom prst="roundRect">
+            <a:avLst>
+              <a:gd name="adj" fmla="val 44000"/>
+            </a:avLst>
+          </a:prstGeom>
+          <a:solidFill>
+            <a:srgbClr val="059669"/>
+          </a:solidFill>
+          <a:ln>
+            <a:noFill/>
+          </a:ln>
+        </p:spPr>
+        <p:style>
+          <a:lnRef idx="1">
+            <a:schemeClr val="accent1"/>
+          </a:lnRef>
+          <a:fillRef idx="3">
+            <a:schemeClr val="accent1"/>
+          </a:fillRef>
+          <a:effectRef idx="2">
+            <a:schemeClr val="accent1"/>
+          </a:effectRef>
+          <a:fontRef idx="minor">
+            <a:schemeClr val="lt1"/>
+          </a:fontRef>
+        </p:style>
+        <p:txBody>
+          <a:bodyPr rtlCol="0" anchor="ctr"/>
+          <a:lstStyle/>
+          <a:p>
+            <a:pPr algn="ctr"/>
+          </a:p>
+        </p:txBody>
+      </p:sp>
+      <p:sp>
+        <p:nvSpPr>
+          <p:cNvPr id="16" name="TextBox 15"/>
+          <p:cNvSpPr txBox="1"/>
+          <p:nvPr/>
+        </p:nvSpPr>
+        <p:spPr>
+          <a:xfrm>
+            <a:off x="7180326" y="6432804"/>
+            <a:ext cx="4371289" cy="237744"/>
+          </a:xfrm>
+          <a:prstGeom prst="rect">
+            <a:avLst/>
+          </a:prstGeom>
+          <a:noFill/>
+        </p:spPr>
+        <p:txBody>
+          <a:bodyPr wrap="square">
+            <a:spAutoFit/>
+          </a:bodyPr>
+          <a:lstStyle/>
+          <a:p>
+            <a:pPr algn="ctr"/>
+            <a:r>
+              <a:rPr sz="1050" b="1" i="0">
+                <a:solidFill>
+                  <a:srgbClr val="FFFFFF"/>
+                </a:solidFill>
+                <a:latin typeface="Helvetica Neue"/>
+              </a:rPr>
+              <a:t>▶  TO THE NOTEBOOK      Act 3 · the two one-line defences</a:t>
+            </a:r>
+          </a:p>
+        </p:txBody>
+      </p:sp>
     </p:spTree>
   </p:cSld>
   <p:clrMapOvr>
@@ -8129,7 +8769,87 @@
       </p:pic>
       <p:sp>
         <p:nvSpPr>
-          <p:cNvPr id="16" name="TextBox 15"/>
+          <p:cNvPr id="16" name="Rounded Rectangle 15"/>
+          <p:cNvSpPr/>
+          <p:nvPr/>
+        </p:nvSpPr>
+        <p:spPr>
+          <a:xfrm>
+            <a:off x="7180326" y="6382512"/>
+            <a:ext cx="4371289" cy="310896"/>
+          </a:xfrm>
+          <a:prstGeom prst="roundRect">
+            <a:avLst>
+              <a:gd name="adj" fmla="val 44000"/>
+            </a:avLst>
+          </a:prstGeom>
+          <a:solidFill>
+            <a:srgbClr val="059669"/>
+          </a:solidFill>
+          <a:ln>
+            <a:noFill/>
+          </a:ln>
+        </p:spPr>
+        <p:style>
+          <a:lnRef idx="1">
+            <a:schemeClr val="accent1"/>
+          </a:lnRef>
+          <a:fillRef idx="3">
+            <a:schemeClr val="accent1"/>
+          </a:fillRef>
+          <a:effectRef idx="2">
+            <a:schemeClr val="accent1"/>
+          </a:effectRef>
+          <a:fontRef idx="minor">
+            <a:schemeClr val="lt1"/>
+          </a:fontRef>
+        </p:style>
+        <p:txBody>
+          <a:bodyPr rtlCol="0" anchor="ctr"/>
+          <a:lstStyle/>
+          <a:p>
+            <a:pPr algn="ctr"/>
+          </a:p>
+        </p:txBody>
+      </p:sp>
+      <p:sp>
+        <p:nvSpPr>
+          <p:cNvPr id="17" name="TextBox 16"/>
+          <p:cNvSpPr txBox="1"/>
+          <p:nvPr/>
+        </p:nvSpPr>
+        <p:spPr>
+          <a:xfrm>
+            <a:off x="7180326" y="6432804"/>
+            <a:ext cx="4371289" cy="237744"/>
+          </a:xfrm>
+          <a:prstGeom prst="rect">
+            <a:avLst/>
+          </a:prstGeom>
+          <a:noFill/>
+        </p:spPr>
+        <p:txBody>
+          <a:bodyPr wrap="square">
+            <a:spAutoFit/>
+          </a:bodyPr>
+          <a:lstStyle/>
+          <a:p>
+            <a:pPr algn="ctr"/>
+            <a:r>
+              <a:rPr sz="1050" b="1" i="0">
+                <a:solidFill>
+                  <a:srgbClr val="FFFFFF"/>
+                </a:solidFill>
+                <a:latin typeface="Helvetica Neue"/>
+              </a:rPr>
+              <a:t>▶  TO THE NOTEBOOK      Act 3 · YOUR KNOB: move THRESHOLD</a:t>
+            </a:r>
+          </a:p>
+        </p:txBody>
+      </p:sp>
+      <p:sp>
+        <p:nvSpPr>
+          <p:cNvPr id="18" name="TextBox 17"/>
           <p:cNvSpPr txBox="1"/>
           <p:nvPr/>
         </p:nvSpPr>
@@ -8157,7 +8877,7 @@
                 </a:solidFill>
                 <a:latin typeface="Helvetica Neue"/>
               </a:rPr>
-              <a:t>"We can automate 39% of the inbox at 87% accuracy — or cover far more, and be less right." That is a decision an executive can actually make.</a:t>
+              <a:t>"We can automate 39% of the inbox at 87% accuracy, or cover far more, and be less right." That is a decision an executive can actually make.</a:t>
             </a:r>
           </a:p>
         </p:txBody>
@@ -8672,6 +9392,86 @@
           </a:prstGeom>
         </p:spPr>
       </p:pic>
+      <p:sp>
+        <p:nvSpPr>
+          <p:cNvPr id="15" name="Rounded Rectangle 14"/>
+          <p:cNvSpPr/>
+          <p:nvPr/>
+        </p:nvSpPr>
+        <p:spPr>
+          <a:xfrm>
+            <a:off x="6410858" y="6382512"/>
+            <a:ext cx="5140756" cy="310896"/>
+          </a:xfrm>
+          <a:prstGeom prst="roundRect">
+            <a:avLst>
+              <a:gd name="adj" fmla="val 44000"/>
+            </a:avLst>
+          </a:prstGeom>
+          <a:solidFill>
+            <a:srgbClr val="059669"/>
+          </a:solidFill>
+          <a:ln>
+            <a:noFill/>
+          </a:ln>
+        </p:spPr>
+        <p:style>
+          <a:lnRef idx="1">
+            <a:schemeClr val="accent1"/>
+          </a:lnRef>
+          <a:fillRef idx="3">
+            <a:schemeClr val="accent1"/>
+          </a:fillRef>
+          <a:effectRef idx="2">
+            <a:schemeClr val="accent1"/>
+          </a:effectRef>
+          <a:fontRef idx="minor">
+            <a:schemeClr val="lt1"/>
+          </a:fontRef>
+        </p:style>
+        <p:txBody>
+          <a:bodyPr rtlCol="0" anchor="ctr"/>
+          <a:lstStyle/>
+          <a:p>
+            <a:pPr algn="ctr"/>
+          </a:p>
+        </p:txBody>
+      </p:sp>
+      <p:sp>
+        <p:nvSpPr>
+          <p:cNvPr id="16" name="TextBox 15"/>
+          <p:cNvSpPr txBox="1"/>
+          <p:nvPr/>
+        </p:nvSpPr>
+        <p:spPr>
+          <a:xfrm>
+            <a:off x="6410858" y="6432804"/>
+            <a:ext cx="5140756" cy="237744"/>
+          </a:xfrm>
+          <a:prstGeom prst="rect">
+            <a:avLst/>
+          </a:prstGeom>
+          <a:noFill/>
+        </p:spPr>
+        <p:txBody>
+          <a:bodyPr wrap="square">
+            <a:spAutoFit/>
+          </a:bodyPr>
+          <a:lstStyle/>
+          <a:p>
+            <a:pPr algn="ctr"/>
+            <a:r>
+              <a:rPr sz="1050" b="1" i="0">
+                <a:solidFill>
+                  <a:srgbClr val="FFFFFF"/>
+                </a:solidFill>
+                <a:latin typeface="Helvetica Neue"/>
+              </a:rPr>
+              <a:t>▶  TO THE NOTEBOOK      Act 3 · same cell, read the business numbers</a:t>
+            </a:r>
+          </a:p>
+        </p:txBody>
+      </p:sp>
     </p:spTree>
   </p:cSld>
   <p:clrMapOvr>
@@ -9323,7 +10123,7 @@
                 </a:solidFill>
                 <a:latin typeface="Helvetica Neue"/>
               </a:rPr>
-              <a:t>What we shipped today — for $0.</a:t>
+              <a:t>What we shipped today, for $0.</a:t>
             </a:r>
           </a:p>
         </p:txBody>
@@ -9452,7 +10252,7 @@
                 </a:solidFill>
                 <a:latin typeface="Helvetica Neue"/>
               </a:rPr>
-              <a:t>Someone else already spent millions teaching a model to read English. Your job is not to build intelligence — it is to point it at your problem, cheaply, and know where it breaks.</a:t>
+              <a:t>Someone else already spent millions teaching a model to read English. Your job is not to build intelligence. It is to point it at your problem, cheaply, and know where it breaks.</a:t>
             </a:r>
           </a:p>
         </p:txBody>
@@ -10244,7 +11044,7 @@
                 </a:solidFill>
                 <a:latin typeface="Helvetica Neue"/>
               </a:rPr>
-              <a:t>Notebook: L13_Cobalt_Support_Copilot.ipynb — run it, turn the knobs, break it.</a:t>
+              <a:t>Notebook: L13_Cobalt_Support_Copilot.ipynb. Run it, turn the knobs, break it.</a:t>
             </a:r>
           </a:p>
         </p:txBody>
@@ -10367,7 +11167,7 @@
                 </a:solidFill>
                 <a:latin typeface="Helvetica Neue"/>
               </a:rPr>
-              <a:t>A B2B analytics platform. The inbox is the product problem — and nobody has ever labelled a single ticket.</a:t>
+              <a:t>A B2B analytics platform. The inbox is the product problem, and nobody has ever labelled a single ticket.</a:t>
             </a:r>
           </a:p>
         </p:txBody>
@@ -10897,7 +11697,7 @@
                 </a:solidFill>
                 <a:latin typeface="Helvetica Neue"/>
               </a:rPr>
-              <a:t>Today we build the part that READS the inbox — search it, sort it, and decide what a human actually needs to see. Next lecture we make it act.</a:t>
+              <a:t>Today we build the part that READS the inbox: search it, sort it, and decide what a human actually needs to see. Next lecture we make it act.</a:t>
             </a:r>
           </a:p>
         </p:txBody>
@@ -11629,6 +12429,86 @@
           </a:prstGeom>
         </p:spPr>
       </p:pic>
+      <p:sp>
+        <p:nvSpPr>
+          <p:cNvPr id="15" name="Rounded Rectangle 14"/>
+          <p:cNvSpPr/>
+          <p:nvPr/>
+        </p:nvSpPr>
+        <p:spPr>
+          <a:xfrm>
+            <a:off x="6830568" y="6382512"/>
+            <a:ext cx="4721047" cy="310896"/>
+          </a:xfrm>
+          <a:prstGeom prst="roundRect">
+            <a:avLst>
+              <a:gd name="adj" fmla="val 44000"/>
+            </a:avLst>
+          </a:prstGeom>
+          <a:solidFill>
+            <a:srgbClr val="059669"/>
+          </a:solidFill>
+          <a:ln>
+            <a:noFill/>
+          </a:ln>
+        </p:spPr>
+        <p:style>
+          <a:lnRef idx="1">
+            <a:schemeClr val="accent1"/>
+          </a:lnRef>
+          <a:fillRef idx="3">
+            <a:schemeClr val="accent1"/>
+          </a:fillRef>
+          <a:effectRef idx="2">
+            <a:schemeClr val="accent1"/>
+          </a:effectRef>
+          <a:fontRef idx="minor">
+            <a:schemeClr val="lt1"/>
+          </a:fontRef>
+        </p:style>
+        <p:txBody>
+          <a:bodyPr rtlCol="0" anchor="ctr"/>
+          <a:lstStyle/>
+          <a:p>
+            <a:pPr algn="ctr"/>
+          </a:p>
+        </p:txBody>
+      </p:sp>
+      <p:sp>
+        <p:nvSpPr>
+          <p:cNvPr id="16" name="TextBox 15"/>
+          <p:cNvSpPr txBox="1"/>
+          <p:nvPr/>
+        </p:nvSpPr>
+        <p:spPr>
+          <a:xfrm>
+            <a:off x="6830568" y="6432804"/>
+            <a:ext cx="4721047" cy="237744"/>
+          </a:xfrm>
+          <a:prstGeom prst="rect">
+            <a:avLst/>
+          </a:prstGeom>
+          <a:noFill/>
+        </p:spPr>
+        <p:txBody>
+          <a:bodyPr wrap="square">
+            <a:spAutoFit/>
+          </a:bodyPr>
+          <a:lstStyle/>
+          <a:p>
+            <a:pPr algn="ctr"/>
+            <a:r>
+              <a:rPr sz="1050" b="1" i="0">
+                <a:solidFill>
+                  <a:srgbClr val="FFFFFF"/>
+                </a:solidFill>
+                <a:latin typeface="Helvetica Neue"/>
+              </a:rPr>
+              <a:t>▶  TO THE NOTEBOOK      Under the hood · “text → tokens → ids”</a:t>
+            </a:r>
+          </a:p>
+        </p:txBody>
+      </p:sp>
     </p:spTree>
   </p:cSld>
   <p:clrMapOvr>
@@ -12139,6 +13019,86 @@
           </a:prstGeom>
         </p:spPr>
       </p:pic>
+      <p:sp>
+        <p:nvSpPr>
+          <p:cNvPr id="15" name="Rounded Rectangle 14"/>
+          <p:cNvSpPr/>
+          <p:nvPr/>
+        </p:nvSpPr>
+        <p:spPr>
+          <a:xfrm>
+            <a:off x="6131052" y="6382512"/>
+            <a:ext cx="5420563" cy="310896"/>
+          </a:xfrm>
+          <a:prstGeom prst="roundRect">
+            <a:avLst>
+              <a:gd name="adj" fmla="val 44000"/>
+            </a:avLst>
+          </a:prstGeom>
+          <a:solidFill>
+            <a:srgbClr val="059669"/>
+          </a:solidFill>
+          <a:ln>
+            <a:noFill/>
+          </a:ln>
+        </p:spPr>
+        <p:style>
+          <a:lnRef idx="1">
+            <a:schemeClr val="accent1"/>
+          </a:lnRef>
+          <a:fillRef idx="3">
+            <a:schemeClr val="accent1"/>
+          </a:fillRef>
+          <a:effectRef idx="2">
+            <a:schemeClr val="accent1"/>
+          </a:effectRef>
+          <a:fontRef idx="minor">
+            <a:schemeClr val="lt1"/>
+          </a:fontRef>
+        </p:style>
+        <p:txBody>
+          <a:bodyPr rtlCol="0" anchor="ctr"/>
+          <a:lstStyle/>
+          <a:p>
+            <a:pPr algn="ctr"/>
+          </a:p>
+        </p:txBody>
+      </p:sp>
+      <p:sp>
+        <p:nvSpPr>
+          <p:cNvPr id="16" name="TextBox 15"/>
+          <p:cNvSpPr txBox="1"/>
+          <p:nvPr/>
+        </p:nvSpPr>
+        <p:spPr>
+          <a:xfrm>
+            <a:off x="6131052" y="6432804"/>
+            <a:ext cx="5420563" cy="237744"/>
+          </a:xfrm>
+          <a:prstGeom prst="rect">
+            <a:avLst/>
+          </a:prstGeom>
+          <a:noFill/>
+        </p:spPr>
+        <p:txBody>
+          <a:bodyPr wrap="square">
+            <a:spAutoFit/>
+          </a:bodyPr>
+          <a:lstStyle/>
+          <a:p>
+            <a:pPr algn="ctr"/>
+            <a:r>
+              <a:rPr sz="1050" b="1" i="0">
+                <a:solidFill>
+                  <a:srgbClr val="FFFFFF"/>
+                </a:solidFill>
+                <a:latin typeface="Helvetica Neue"/>
+              </a:rPr>
+              <a:t>▶  TO THE NOTEBOOK      Under the hood · “does your vocabulary survive?”</a:t>
+            </a:r>
+          </a:p>
+        </p:txBody>
+      </p:sp>
     </p:spTree>
   </p:cSld>
   <p:clrMapOvr>
@@ -12222,7 +13182,7 @@
                 </a:solidFill>
                 <a:latin typeface="Helvetica Neue"/>
               </a:rPr>
-              <a:t>One ticket becomes one vector — by averaging.</a:t>
+              <a:t>One ticket becomes one vector, by averaging.</a:t>
             </a:r>
           </a:p>
         </p:txBody>
@@ -12649,6 +13609,86 @@
           </a:prstGeom>
         </p:spPr>
       </p:pic>
+      <p:sp>
+        <p:nvSpPr>
+          <p:cNvPr id="15" name="Rounded Rectangle 14"/>
+          <p:cNvSpPr/>
+          <p:nvPr/>
+        </p:nvSpPr>
+        <p:spPr>
+          <a:xfrm>
+            <a:off x="6410858" y="6382512"/>
+            <a:ext cx="5140756" cy="310896"/>
+          </a:xfrm>
+          <a:prstGeom prst="roundRect">
+            <a:avLst>
+              <a:gd name="adj" fmla="val 44000"/>
+            </a:avLst>
+          </a:prstGeom>
+          <a:solidFill>
+            <a:srgbClr val="059669"/>
+          </a:solidFill>
+          <a:ln>
+            <a:noFill/>
+          </a:ln>
+        </p:spPr>
+        <p:style>
+          <a:lnRef idx="1">
+            <a:schemeClr val="accent1"/>
+          </a:lnRef>
+          <a:fillRef idx="3">
+            <a:schemeClr val="accent1"/>
+          </a:fillRef>
+          <a:effectRef idx="2">
+            <a:schemeClr val="accent1"/>
+          </a:effectRef>
+          <a:fontRef idx="minor">
+            <a:schemeClr val="lt1"/>
+          </a:fontRef>
+        </p:style>
+        <p:txBody>
+          <a:bodyPr rtlCol="0" anchor="ctr"/>
+          <a:lstStyle/>
+          <a:p>
+            <a:pPr algn="ctr"/>
+          </a:p>
+        </p:txBody>
+      </p:sp>
+      <p:sp>
+        <p:nvSpPr>
+          <p:cNvPr id="16" name="TextBox 15"/>
+          <p:cNvSpPr txBox="1"/>
+          <p:nvPr/>
+        </p:nvSpPr>
+        <p:spPr>
+          <a:xfrm>
+            <a:off x="6410858" y="6432804"/>
+            <a:ext cx="5140756" cy="237744"/>
+          </a:xfrm>
+          <a:prstGeom prst="rect">
+            <a:avLst/>
+          </a:prstGeom>
+          <a:noFill/>
+        </p:spPr>
+        <p:txBody>
+          <a:bodyPr wrap="square">
+            <a:spAutoFit/>
+          </a:bodyPr>
+          <a:lstStyle/>
+          <a:p>
+            <a:pPr algn="ctr"/>
+            <a:r>
+              <a:rPr sz="1050" b="1" i="0">
+                <a:solidFill>
+                  <a:srgbClr val="FFFFFF"/>
+                </a:solidFill>
+                <a:latin typeface="Helvetica Neue"/>
+              </a:rPr>
+              <a:t>▶  TO THE NOTEBOOK      Under the hood · “from tokens to ONE vector”</a:t>
+            </a:r>
+          </a:p>
+        </p:txBody>
+      </p:sp>
     </p:spTree>
   </p:cSld>
   <p:clrMapOvr>
@@ -13159,6 +14199,86 @@
           </a:prstGeom>
         </p:spPr>
       </p:pic>
+      <p:sp>
+        <p:nvSpPr>
+          <p:cNvPr id="15" name="Rounded Rectangle 14"/>
+          <p:cNvSpPr/>
+          <p:nvPr/>
+        </p:nvSpPr>
+        <p:spPr>
+          <a:xfrm>
+            <a:off x="5851245" y="6382512"/>
+            <a:ext cx="5700369" cy="310896"/>
+          </a:xfrm>
+          <a:prstGeom prst="roundRect">
+            <a:avLst>
+              <a:gd name="adj" fmla="val 44000"/>
+            </a:avLst>
+          </a:prstGeom>
+          <a:solidFill>
+            <a:srgbClr val="059669"/>
+          </a:solidFill>
+          <a:ln>
+            <a:noFill/>
+          </a:ln>
+        </p:spPr>
+        <p:style>
+          <a:lnRef idx="1">
+            <a:schemeClr val="accent1"/>
+          </a:lnRef>
+          <a:fillRef idx="3">
+            <a:schemeClr val="accent1"/>
+          </a:fillRef>
+          <a:effectRef idx="2">
+            <a:schemeClr val="accent1"/>
+          </a:effectRef>
+          <a:fontRef idx="minor">
+            <a:schemeClr val="lt1"/>
+          </a:fontRef>
+        </p:style>
+        <p:txBody>
+          <a:bodyPr rtlCol="0" anchor="ctr"/>
+          <a:lstStyle/>
+          <a:p>
+            <a:pPr algn="ctr"/>
+          </a:p>
+        </p:txBody>
+      </p:sp>
+      <p:sp>
+        <p:nvSpPr>
+          <p:cNvPr id="16" name="TextBox 15"/>
+          <p:cNvSpPr txBox="1"/>
+          <p:nvPr/>
+        </p:nvSpPr>
+        <p:spPr>
+          <a:xfrm>
+            <a:off x="5851245" y="6432804"/>
+            <a:ext cx="5700369" cy="237744"/>
+          </a:xfrm>
+          <a:prstGeom prst="rect">
+            <a:avLst/>
+          </a:prstGeom>
+          <a:noFill/>
+        </p:spPr>
+        <p:txBody>
+          <a:bodyPr wrap="square">
+            <a:spAutoFit/>
+          </a:bodyPr>
+          <a:lstStyle/>
+          <a:p>
+            <a:pPr algn="ctr"/>
+            <a:r>
+              <a:rPr sz="1050" b="1" i="0">
+                <a:solidFill>
+                  <a:srgbClr val="FFFFFF"/>
+                </a:solidFill>
+                <a:latin typeface="Helvetica Neue"/>
+              </a:rPr>
+              <a:t>▶  TO THE NOTEBOOK      Under the hood · “similarity is just multiplication”</a:t>
+            </a:r>
+          </a:p>
+        </p:txBody>
+      </p:sp>
     </p:spTree>
   </p:cSld>
   <p:clrMapOvr>
@@ -13669,6 +14789,86 @@
           </a:prstGeom>
         </p:spPr>
       </p:pic>
+      <p:sp>
+        <p:nvSpPr>
+          <p:cNvPr id="15" name="Rounded Rectangle 14"/>
+          <p:cNvSpPr/>
+          <p:nvPr/>
+        </p:nvSpPr>
+        <p:spPr>
+          <a:xfrm>
+            <a:off x="6970471" y="6382512"/>
+            <a:ext cx="4581144" cy="310896"/>
+          </a:xfrm>
+          <a:prstGeom prst="roundRect">
+            <a:avLst>
+              <a:gd name="adj" fmla="val 44000"/>
+            </a:avLst>
+          </a:prstGeom>
+          <a:solidFill>
+            <a:srgbClr val="059669"/>
+          </a:solidFill>
+          <a:ln>
+            <a:noFill/>
+          </a:ln>
+        </p:spPr>
+        <p:style>
+          <a:lnRef idx="1">
+            <a:schemeClr val="accent1"/>
+          </a:lnRef>
+          <a:fillRef idx="3">
+            <a:schemeClr val="accent1"/>
+          </a:fillRef>
+          <a:effectRef idx="2">
+            <a:schemeClr val="accent1"/>
+          </a:effectRef>
+          <a:fontRef idx="minor">
+            <a:schemeClr val="lt1"/>
+          </a:fontRef>
+        </p:style>
+        <p:txBody>
+          <a:bodyPr rtlCol="0" anchor="ctr"/>
+          <a:lstStyle/>
+          <a:p>
+            <a:pPr algn="ctr"/>
+          </a:p>
+        </p:txBody>
+      </p:sp>
+      <p:sp>
+        <p:nvSpPr>
+          <p:cNvPr id="16" name="TextBox 15"/>
+          <p:cNvSpPr txBox="1"/>
+          <p:nvPr/>
+        </p:nvSpPr>
+        <p:spPr>
+          <a:xfrm>
+            <a:off x="6970471" y="6432804"/>
+            <a:ext cx="4581144" cy="237744"/>
+          </a:xfrm>
+          <a:prstGeom prst="rect">
+            <a:avLst/>
+          </a:prstGeom>
+          <a:noFill/>
+        </p:spPr>
+        <p:txBody>
+          <a:bodyPr wrap="square">
+            <a:spAutoFit/>
+          </a:bodyPr>
+          <a:lstStyle/>
+          <a:p>
+            <a:pPr algn="ctr"/>
+            <a:r>
+              <a:rPr sz="1050" b="1" i="0">
+                <a:solidFill>
+                  <a:srgbClr val="FFFFFF"/>
+                </a:solidFill>
+                <a:latin typeface="Helvetica Neue"/>
+              </a:rPr>
+              <a:t>▶  TO THE NOTEBOOK      Act 1 · “Teach the computer to read”</a:t>
+            </a:r>
+          </a:p>
+        </p:txBody>
+      </p:sp>
     </p:spTree>
   </p:cSld>
   <p:clrMapOvr>

</xml_diff>

<commit_message>
Week 7: L13 speaker package (HTML slideshow + script + pptx notes)
L13_Slides.html is a self-contained slideshow for toggling between a Chrome
tab and the Colab notebook (arrow keys, T contents, N notebook, F fullscreen),
with a green cue on the 15 slides that have a matching notebook section.
The deck now also carries real PowerPoint speaker notes with timing, the
notebook cue and the verbatim script.

Co-Authored-By: Claude Opus 4.8 <noreply@anthropic.com>
</commit_message>
<xml_diff>
--- a/Week 7/L13_Support_Copilot.pptx
+++ b/Week 7/L13_Support_Copilot.pptx
@@ -126,6 +126,2473 @@
     </a:lvl9pPr>
   </p:defaultTextStyle>
 </p:presentation>
+</file>
+
+<file path=ppt/notesMasters/notesMaster1.xml><?xml version="1.0" encoding="utf-8"?>
+<p:notesMaster xmlns:a="http://schemas.openxmlformats.org/drawingml/2006/main" xmlns:p="http://schemas.openxmlformats.org/presentationml/2006/main" xmlns:r="http://schemas.openxmlformats.org/officeDocument/2006/relationships">
+  <p:cSld>
+    <p:bg>
+      <p:bgRef idx="1001">
+        <a:schemeClr val="bg1"/>
+      </p:bgRef>
+    </p:bg>
+    <p:spTree>
+      <p:nvGrpSpPr>
+        <p:cNvPr id="1" name=""/>
+        <p:cNvGrpSpPr/>
+        <p:nvPr/>
+      </p:nvGrpSpPr>
+      <p:grpSpPr>
+        <a:xfrm>
+          <a:off x="0" y="0"/>
+          <a:ext cx="0" cy="0"/>
+          <a:chOff x="0" y="0"/>
+          <a:chExt cx="0" cy="0"/>
+        </a:xfrm>
+      </p:grpSpPr>
+      <p:sp>
+        <p:nvSpPr>
+          <p:cNvPr id="2" name="Header Placeholder 1"/>
+          <p:cNvSpPr>
+            <a:spLocks noGrp="1"/>
+          </p:cNvSpPr>
+          <p:nvPr>
+            <p:ph type="hdr" sz="quarter"/>
+          </p:nvPr>
+        </p:nvSpPr>
+        <p:spPr>
+          <a:xfrm>
+            <a:off x="0" y="0"/>
+            <a:ext cx="2971800" cy="457200"/>
+          </a:xfrm>
+          <a:prstGeom prst="rect">
+            <a:avLst/>
+          </a:prstGeom>
+        </p:spPr>
+        <p:txBody>
+          <a:bodyPr vert="horz" lIns="91440" tIns="45720" rIns="91440" bIns="45720" rtlCol="0"/>
+          <a:lstStyle>
+            <a:lvl1pPr algn="l">
+              <a:defRPr sz="1200"/>
+            </a:lvl1pPr>
+          </a:lstStyle>
+          <a:p>
+            <a:endParaRPr lang="en-US"/>
+          </a:p>
+        </p:txBody>
+      </p:sp>
+      <p:sp>
+        <p:nvSpPr>
+          <p:cNvPr id="3" name="Date Placeholder 2"/>
+          <p:cNvSpPr>
+            <a:spLocks noGrp="1"/>
+          </p:cNvSpPr>
+          <p:nvPr>
+            <p:ph type="dt" idx="1"/>
+          </p:nvPr>
+        </p:nvSpPr>
+        <p:spPr>
+          <a:xfrm>
+            <a:off x="3884613" y="0"/>
+            <a:ext cx="2971800" cy="457200"/>
+          </a:xfrm>
+          <a:prstGeom prst="rect">
+            <a:avLst/>
+          </a:prstGeom>
+        </p:spPr>
+        <p:txBody>
+          <a:bodyPr vert="horz" lIns="91440" tIns="45720" rIns="91440" bIns="45720" rtlCol="0"/>
+          <a:lstStyle>
+            <a:lvl1pPr algn="r">
+              <a:defRPr sz="1200"/>
+            </a:lvl1pPr>
+          </a:lstStyle>
+          <a:p>
+            <a:fld id="{0F89C1C7-3DCD-1040-A9CF-14679D8B5DDD}" type="datetimeFigureOut">
+              <a:rPr lang="en-US" smtClean="0"/>
+              <a:t>10/17/16</a:t>
+            </a:fld>
+            <a:endParaRPr lang="en-US"/>
+          </a:p>
+        </p:txBody>
+      </p:sp>
+      <p:sp>
+        <p:nvSpPr>
+          <p:cNvPr id="4" name="Slide Image Placeholder 3"/>
+          <p:cNvSpPr>
+            <a:spLocks noGrp="1" noRot="1" noChangeAspect="1"/>
+          </p:cNvSpPr>
+          <p:nvPr>
+            <p:ph type="sldImg" idx="2"/>
+          </p:nvPr>
+        </p:nvSpPr>
+        <p:spPr>
+          <a:xfrm>
+            <a:off x="1143000" y="685800"/>
+            <a:ext cx="4572000" cy="3429000"/>
+          </a:xfrm>
+          <a:prstGeom prst="rect">
+            <a:avLst/>
+          </a:prstGeom>
+          <a:noFill/>
+          <a:ln w="12700">
+            <a:solidFill>
+              <a:prstClr val="black"/>
+            </a:solidFill>
+          </a:ln>
+        </p:spPr>
+        <p:txBody>
+          <a:bodyPr vert="horz" lIns="91440" tIns="45720" rIns="91440" bIns="45720" rtlCol="0" anchor="ctr"/>
+          <a:lstStyle/>
+          <a:p>
+            <a:endParaRPr lang="en-US"/>
+          </a:p>
+        </p:txBody>
+      </p:sp>
+      <p:sp>
+        <p:nvSpPr>
+          <p:cNvPr id="5" name="Notes Placeholder 4"/>
+          <p:cNvSpPr>
+            <a:spLocks noGrp="1"/>
+          </p:cNvSpPr>
+          <p:nvPr>
+            <p:ph type="body" sz="quarter" idx="3"/>
+          </p:nvPr>
+        </p:nvSpPr>
+        <p:spPr>
+          <a:xfrm>
+            <a:off x="685800" y="4343400"/>
+            <a:ext cx="5486400" cy="4114800"/>
+          </a:xfrm>
+          <a:prstGeom prst="rect">
+            <a:avLst/>
+          </a:prstGeom>
+        </p:spPr>
+        <p:txBody>
+          <a:bodyPr vert="horz" lIns="91440" tIns="45720" rIns="91440" bIns="45720" rtlCol="0"/>
+          <a:lstStyle/>
+          <a:p>
+            <a:pPr lvl="0"/>
+            <a:r>
+              <a:rPr lang="en-US" smtClean="0"/>
+              <a:t>Click to edit Master text styles</a:t>
+            </a:r>
+          </a:p>
+          <a:p>
+            <a:pPr lvl="1"/>
+            <a:r>
+              <a:rPr lang="en-US" smtClean="0"/>
+              <a:t>Second level</a:t>
+            </a:r>
+          </a:p>
+          <a:p>
+            <a:pPr lvl="2"/>
+            <a:r>
+              <a:rPr lang="en-US" smtClean="0"/>
+              <a:t>Third level</a:t>
+            </a:r>
+          </a:p>
+          <a:p>
+            <a:pPr lvl="3"/>
+            <a:r>
+              <a:rPr lang="en-US" smtClean="0"/>
+              <a:t>Fourth level</a:t>
+            </a:r>
+          </a:p>
+          <a:p>
+            <a:pPr lvl="4"/>
+            <a:r>
+              <a:rPr lang="en-US" smtClean="0"/>
+              <a:t>Fifth level</a:t>
+            </a:r>
+            <a:endParaRPr lang="en-US"/>
+          </a:p>
+        </p:txBody>
+      </p:sp>
+      <p:sp>
+        <p:nvSpPr>
+          <p:cNvPr id="6" name="Footer Placeholder 5"/>
+          <p:cNvSpPr>
+            <a:spLocks noGrp="1"/>
+          </p:cNvSpPr>
+          <p:nvPr>
+            <p:ph type="ftr" sz="quarter" idx="4"/>
+          </p:nvPr>
+        </p:nvSpPr>
+        <p:spPr>
+          <a:xfrm>
+            <a:off x="0" y="8685213"/>
+            <a:ext cx="2971800" cy="457200"/>
+          </a:xfrm>
+          <a:prstGeom prst="rect">
+            <a:avLst/>
+          </a:prstGeom>
+        </p:spPr>
+        <p:txBody>
+          <a:bodyPr vert="horz" lIns="91440" tIns="45720" rIns="91440" bIns="45720" rtlCol="0" anchor="b"/>
+          <a:lstStyle>
+            <a:lvl1pPr algn="l">
+              <a:defRPr sz="1200"/>
+            </a:lvl1pPr>
+          </a:lstStyle>
+          <a:p>
+            <a:endParaRPr lang="en-US"/>
+          </a:p>
+        </p:txBody>
+      </p:sp>
+      <p:sp>
+        <p:nvSpPr>
+          <p:cNvPr id="7" name="Slide Number Placeholder 6"/>
+          <p:cNvSpPr>
+            <a:spLocks noGrp="1"/>
+          </p:cNvSpPr>
+          <p:nvPr>
+            <p:ph type="sldNum" sz="quarter" idx="5"/>
+          </p:nvPr>
+        </p:nvSpPr>
+        <p:spPr>
+          <a:xfrm>
+            <a:off x="3884613" y="8685213"/>
+            <a:ext cx="2971800" cy="457200"/>
+          </a:xfrm>
+          <a:prstGeom prst="rect">
+            <a:avLst/>
+          </a:prstGeom>
+        </p:spPr>
+        <p:txBody>
+          <a:bodyPr vert="horz" lIns="91440" tIns="45720" rIns="91440" bIns="45720" rtlCol="0" anchor="b"/>
+          <a:lstStyle>
+            <a:lvl1pPr algn="r">
+              <a:defRPr sz="1200"/>
+            </a:lvl1pPr>
+          </a:lstStyle>
+          <a:p>
+            <a:fld id="{BB5E49A5-4136-284D-997B-48E1D791AD67}" type="slidenum">
+              <a:rPr lang="en-US" smtClean="0"/>
+              <a:t>‹#›</a:t>
+            </a:fld>
+            <a:endParaRPr lang="en-US"/>
+          </a:p>
+        </p:txBody>
+      </p:sp>
+    </p:spTree>
+    <p:extLst>
+      <p:ext uri="{BB962C8B-B14F-4D97-AF65-F5344CB8AC3E}">
+        <p14:creationId xmlns:p14="http://schemas.microsoft.com/office/powerpoint/2010/main" val="2623252185"/>
+      </p:ext>
+    </p:extLst>
+  </p:cSld>
+  <p:clrMap bg1="lt1" tx1="dk1" bg2="lt2" tx2="dk2" accent1="accent1" accent2="accent2" accent3="accent3" accent4="accent4" accent5="accent5" accent6="accent6" hlink="hlink" folHlink="folHlink"/>
+  <p:notesStyle>
+    <a:lvl1pPr marL="0" algn="l" defTabSz="457200" rtl="0" eaLnBrk="1" latinLnBrk="0" hangingPunct="1">
+      <a:defRPr sz="1200" kern="1200">
+        <a:solidFill>
+          <a:schemeClr val="tx1"/>
+        </a:solidFill>
+        <a:latin typeface="+mn-lt"/>
+        <a:ea typeface="+mn-ea"/>
+        <a:cs typeface="+mn-cs"/>
+      </a:defRPr>
+    </a:lvl1pPr>
+    <a:lvl2pPr marL="457200" algn="l" defTabSz="457200" rtl="0" eaLnBrk="1" latinLnBrk="0" hangingPunct="1">
+      <a:defRPr sz="1200" kern="1200">
+        <a:solidFill>
+          <a:schemeClr val="tx1"/>
+        </a:solidFill>
+        <a:latin typeface="+mn-lt"/>
+        <a:ea typeface="+mn-ea"/>
+        <a:cs typeface="+mn-cs"/>
+      </a:defRPr>
+    </a:lvl2pPr>
+    <a:lvl3pPr marL="914400" algn="l" defTabSz="457200" rtl="0" eaLnBrk="1" latinLnBrk="0" hangingPunct="1">
+      <a:defRPr sz="1200" kern="1200">
+        <a:solidFill>
+          <a:schemeClr val="tx1"/>
+        </a:solidFill>
+        <a:latin typeface="+mn-lt"/>
+        <a:ea typeface="+mn-ea"/>
+        <a:cs typeface="+mn-cs"/>
+      </a:defRPr>
+    </a:lvl3pPr>
+    <a:lvl4pPr marL="1371600" algn="l" defTabSz="457200" rtl="0" eaLnBrk="1" latinLnBrk="0" hangingPunct="1">
+      <a:defRPr sz="1200" kern="1200">
+        <a:solidFill>
+          <a:schemeClr val="tx1"/>
+        </a:solidFill>
+        <a:latin typeface="+mn-lt"/>
+        <a:ea typeface="+mn-ea"/>
+        <a:cs typeface="+mn-cs"/>
+      </a:defRPr>
+    </a:lvl4pPr>
+    <a:lvl5pPr marL="1828800" algn="l" defTabSz="457200" rtl="0" eaLnBrk="1" latinLnBrk="0" hangingPunct="1">
+      <a:defRPr sz="1200" kern="1200">
+        <a:solidFill>
+          <a:schemeClr val="tx1"/>
+        </a:solidFill>
+        <a:latin typeface="+mn-lt"/>
+        <a:ea typeface="+mn-ea"/>
+        <a:cs typeface="+mn-cs"/>
+      </a:defRPr>
+    </a:lvl5pPr>
+    <a:lvl6pPr marL="2286000" algn="l" defTabSz="457200" rtl="0" eaLnBrk="1" latinLnBrk="0" hangingPunct="1">
+      <a:defRPr sz="1200" kern="1200">
+        <a:solidFill>
+          <a:schemeClr val="tx1"/>
+        </a:solidFill>
+        <a:latin typeface="+mn-lt"/>
+        <a:ea typeface="+mn-ea"/>
+        <a:cs typeface="+mn-cs"/>
+      </a:defRPr>
+    </a:lvl6pPr>
+    <a:lvl7pPr marL="2743200" algn="l" defTabSz="457200" rtl="0" eaLnBrk="1" latinLnBrk="0" hangingPunct="1">
+      <a:defRPr sz="1200" kern="1200">
+        <a:solidFill>
+          <a:schemeClr val="tx1"/>
+        </a:solidFill>
+        <a:latin typeface="+mn-lt"/>
+        <a:ea typeface="+mn-ea"/>
+        <a:cs typeface="+mn-cs"/>
+      </a:defRPr>
+    </a:lvl7pPr>
+    <a:lvl8pPr marL="3200400" algn="l" defTabSz="457200" rtl="0" eaLnBrk="1" latinLnBrk="0" hangingPunct="1">
+      <a:defRPr sz="1200" kern="1200">
+        <a:solidFill>
+          <a:schemeClr val="tx1"/>
+        </a:solidFill>
+        <a:latin typeface="+mn-lt"/>
+        <a:ea typeface="+mn-ea"/>
+        <a:cs typeface="+mn-cs"/>
+      </a:defRPr>
+    </a:lvl8pPr>
+    <a:lvl9pPr marL="3657600" algn="l" defTabSz="457200" rtl="0" eaLnBrk="1" latinLnBrk="0" hangingPunct="1">
+      <a:defRPr sz="1200" kern="1200">
+        <a:solidFill>
+          <a:schemeClr val="tx1"/>
+        </a:solidFill>
+        <a:latin typeface="+mn-lt"/>
+        <a:ea typeface="+mn-ea"/>
+        <a:cs typeface="+mn-cs"/>
+      </a:defRPr>
+    </a:lvl9pPr>
+  </p:notesStyle>
+</p:notesMaster>
+</file>
+
+<file path=ppt/notesSlides/notesSlide1.xml><?xml version="1.0" encoding="utf-8"?>
+<p:notes xmlns:a="http://schemas.openxmlformats.org/drawingml/2006/main" xmlns:p="http://schemas.openxmlformats.org/presentationml/2006/main" xmlns:r="http://schemas.openxmlformats.org/officeDocument/2006/relationships">
+  <p:cSld>
+    <p:spTree>
+      <p:nvGrpSpPr>
+        <p:cNvPr id="1" name=""/>
+        <p:cNvGrpSpPr/>
+        <p:nvPr/>
+      </p:nvGrpSpPr>
+      <p:grpSpPr>
+        <a:xfrm>
+          <a:off x="0" y="0"/>
+          <a:ext cx="0" cy="0"/>
+          <a:chOff x="0" y="0"/>
+          <a:chExt cx="0" cy="0"/>
+        </a:xfrm>
+      </p:grpSpPr>
+      <p:sp>
+        <p:nvSpPr>
+          <p:cNvPr id="2" name="Slide Image Placeholder 1"/>
+          <p:cNvSpPr>
+            <a:spLocks noGrp="1"/>
+          </p:cNvSpPr>
+          <p:nvPr>
+            <p:ph type="sldImg" idx="2"/>
+          </p:nvPr>
+        </p:nvSpPr>
+        <p:spPr/>
+      </p:sp>
+      <p:sp>
+        <p:nvSpPr>
+          <p:cNvPr id="3" name="Notes Placeholder 2"/>
+          <p:cNvSpPr>
+            <a:spLocks noGrp="1"/>
+          </p:cNvSpPr>
+          <p:nvPr>
+            <p:ph type="body" idx="3" sz="quarter"/>
+          </p:nvPr>
+        </p:nvSpPr>
+        <p:spPr/>
+        <p:txBody>
+          <a:bodyPr/>
+          <a:lstStyle/>
+          <a:p>
+            <a:r>
+              <a:t>[5:45 PM to 5:47 PM  ~2 min]</a:t>
+            </a:r>
+          </a:p>
+          <a:p/>
+          <a:p>
+            <a:r>
+              <a:t>Good evening. Last week we took a transformer apart to see how it works. Tonight we do the opposite: we build something with one.</a:t>
+            </a:r>
+          </a:p>
+          <a:p>
+            <a:r>
+              <a:t>By the end of these two lectures you will have a working support copilot, and more importantly you will know which parts of it you can trust.</a:t>
+            </a:r>
+          </a:p>
+          <a:p>
+            <a:r>
+              <a:t>Here is the situation we are walking into. Five thousand support tickets a week, three agents, and not one labelled example. Most people would tell you that you need to hire a labelling team before AI can help at all. We are going to ship something useful tonight without labelling a single ticket.</a:t>
+            </a:r>
+          </a:p>
+        </p:txBody>
+      </p:sp>
+      <p:sp>
+        <p:nvSpPr>
+          <p:cNvPr id="4" name="Slide Number Placeholder 3"/>
+          <p:cNvSpPr>
+            <a:spLocks noGrp="1"/>
+          </p:cNvSpPr>
+          <p:nvPr>
+            <p:ph type="sldNum" idx="5" sz="quarter"/>
+          </p:nvPr>
+        </p:nvSpPr>
+        <p:spPr/>
+      </p:sp>
+    </p:spTree>
+  </p:cSld>
+  <p:clrMapOvr>
+    <a:masterClrMapping/>
+  </p:clrMapOvr>
+</p:notes>
+</file>
+
+<file path=ppt/notesSlides/notesSlide10.xml><?xml version="1.0" encoding="utf-8"?>
+<p:notes xmlns:a="http://schemas.openxmlformats.org/drawingml/2006/main" xmlns:p="http://schemas.openxmlformats.org/presentationml/2006/main" xmlns:r="http://schemas.openxmlformats.org/officeDocument/2006/relationships">
+  <p:cSld>
+    <p:spTree>
+      <p:nvGrpSpPr>
+        <p:cNvPr id="1" name=""/>
+        <p:cNvGrpSpPr/>
+        <p:nvPr/>
+      </p:nvGrpSpPr>
+      <p:grpSpPr>
+        <a:xfrm>
+          <a:off x="0" y="0"/>
+          <a:ext cx="0" cy="0"/>
+          <a:chOff x="0" y="0"/>
+          <a:chExt cx="0" cy="0"/>
+        </a:xfrm>
+      </p:grpSpPr>
+      <p:sp>
+        <p:nvSpPr>
+          <p:cNvPr id="2" name="Slide Image Placeholder 1"/>
+          <p:cNvSpPr>
+            <a:spLocks noGrp="1"/>
+          </p:cNvSpPr>
+          <p:nvPr>
+            <p:ph type="sldImg" idx="2"/>
+          </p:nvPr>
+        </p:nvSpPr>
+        <p:spPr/>
+      </p:sp>
+      <p:sp>
+        <p:nvSpPr>
+          <p:cNvPr id="3" name="Notes Placeholder 2"/>
+          <p:cNvSpPr>
+            <a:spLocks noGrp="1"/>
+          </p:cNvSpPr>
+          <p:nvPr>
+            <p:ph type="body" idx="3" sz="quarter"/>
+          </p:nvPr>
+        </p:nvSpPr>
+        <p:spPr/>
+        <p:txBody>
+          <a:bodyPr/>
+          <a:lstStyle/>
+          <a:p>
+            <a:r>
+              <a:t>[6:19 PM to 6:23 PM  ~4 min]</a:t>
+            </a:r>
+          </a:p>
+          <a:p>
+            <a:r>
+              <a:t>TO THE NOTEBOOK: Act 1: "The shape of the whole inbox"</a:t>
+            </a:r>
+          </a:p>
+          <a:p/>
+          <a:p>
+            <a:r>
+              <a:t>One more thing before we move on. If every ticket is a point, we can flatten those points onto a page and look at the entire inbox at once.</a:t>
+            </a:r>
+          </a:p>
+          <a:p>
+            <a:r>
+              <a:t>Here are all one hundred and sixty. The grey dots are every ticket. Then I asked for the fourteen nearest neighbours of four different phrases and coloured those in.</a:t>
+            </a:r>
+          </a:p>
+          <a:p>
+            <a:r>
+              <a:t>Look at what happened. The billing tickets cluster together. The sign-in tickets cluster. The slow-and-broken tickets cluster. Nobody labelled any of this. I never told the model these categories existed. That structure was already sitting in the text, and all we did was make it visible.</a:t>
+            </a:r>
+          </a:p>
+          <a:p>
+            <a:r>
+              <a:t>The practical version: you can walk into a leadership meeting and show them what is inside a pile of feedback before spending one dollar on labelling.</a:t>
+            </a:r>
+          </a:p>
+        </p:txBody>
+      </p:sp>
+      <p:sp>
+        <p:nvSpPr>
+          <p:cNvPr id="4" name="Slide Number Placeholder 3"/>
+          <p:cNvSpPr>
+            <a:spLocks noGrp="1"/>
+          </p:cNvSpPr>
+          <p:nvPr>
+            <p:ph type="sldNum" idx="5" sz="quarter"/>
+          </p:nvPr>
+        </p:nvSpPr>
+        <p:spPr/>
+      </p:sp>
+    </p:spTree>
+  </p:cSld>
+  <p:clrMapOvr>
+    <a:masterClrMapping/>
+  </p:clrMapOvr>
+</p:notes>
+</file>
+
+<file path=ppt/notesSlides/notesSlide11.xml><?xml version="1.0" encoding="utf-8"?>
+<p:notes xmlns:a="http://schemas.openxmlformats.org/drawingml/2006/main" xmlns:p="http://schemas.openxmlformats.org/presentationml/2006/main" xmlns:r="http://schemas.openxmlformats.org/officeDocument/2006/relationships">
+  <p:cSld>
+    <p:spTree>
+      <p:nvGrpSpPr>
+        <p:cNvPr id="1" name=""/>
+        <p:cNvGrpSpPr/>
+        <p:nvPr/>
+      </p:nvGrpSpPr>
+      <p:grpSpPr>
+        <a:xfrm>
+          <a:off x="0" y="0"/>
+          <a:ext cx="0" cy="0"/>
+          <a:chOff x="0" y="0"/>
+          <a:chExt cx="0" cy="0"/>
+        </a:xfrm>
+      </p:grpSpPr>
+      <p:sp>
+        <p:nvSpPr>
+          <p:cNvPr id="2" name="Slide Image Placeholder 1"/>
+          <p:cNvSpPr>
+            <a:spLocks noGrp="1"/>
+          </p:cNvSpPr>
+          <p:nvPr>
+            <p:ph type="sldImg" idx="2"/>
+          </p:nvPr>
+        </p:nvSpPr>
+        <p:spPr/>
+      </p:sp>
+      <p:sp>
+        <p:nvSpPr>
+          <p:cNvPr id="3" name="Notes Placeholder 2"/>
+          <p:cNvSpPr>
+            <a:spLocks noGrp="1"/>
+          </p:cNvSpPr>
+          <p:nvPr>
+            <p:ph type="body" idx="3" sz="quarter"/>
+          </p:nvPr>
+        </p:nvSpPr>
+        <p:spPr/>
+        <p:txBody>
+          <a:bodyPr/>
+          <a:lstStyle/>
+          <a:p>
+            <a:r>
+              <a:t>[6:23 PM to 6:29 PM  ~6 min]</a:t>
+            </a:r>
+          </a:p>
+          <a:p>
+            <a:r>
+              <a:t>TO THE NOTEBOOK: Act 2: "Route with zero labelled examples"</a:t>
+            </a:r>
+          </a:p>
+          <a:p/>
+          <a:p>
+            <a:r>
+              <a:t>Now the interesting part. We want to sort the inbox into the buckets our support team actually uses. The textbook answer is: label a few thousand tickets, then train a classifier. That is weeks of work and money Cobalt does not have.</a:t>
+            </a:r>
+          </a:p>
+          <a:p>
+            <a:r>
+              <a:t>So we do it differently. Watch what the program looks like. I write out each bucket as a description in plain English. "An invoice, payment, refund or pricing question." "The product being slow, timing out or hanging." That is the code. That is the whole program. Then one pipeline call. There is no training step anywhere.</a:t>
+            </a:r>
+          </a:p>
+          <a:p>
+            <a:r>
+              <a:t>Before I run it, commit to a prediction. Eight buckets, so random guessing is twelve and a half percent. What would you bet on?</a:t>
+            </a:r>
+          </a:p>
+          <a:p>
+            <a:r>
+              <a:t>[run it] Sixty four percent on its single best guess, and eighty percent if you let it offer two. Zero labelled examples. Zero training. Zero dollars.</a:t>
+            </a:r>
+          </a:p>
+          <a:p>
+            <a:r>
+              <a:t>Now read that eighty percent as a product instead of a metric. It means you show your agent two buttons instead of eight.</a:t>
+            </a:r>
+          </a:p>
+        </p:txBody>
+      </p:sp>
+      <p:sp>
+        <p:nvSpPr>
+          <p:cNvPr id="4" name="Slide Number Placeholder 3"/>
+          <p:cNvSpPr>
+            <a:spLocks noGrp="1"/>
+          </p:cNvSpPr>
+          <p:nvPr>
+            <p:ph type="sldNum" idx="5" sz="quarter"/>
+          </p:nvPr>
+        </p:nvSpPr>
+        <p:spPr/>
+      </p:sp>
+    </p:spTree>
+  </p:cSld>
+  <p:clrMapOvr>
+    <a:masterClrMapping/>
+  </p:clrMapOvr>
+</p:notes>
+</file>
+
+<file path=ppt/notesSlides/notesSlide12.xml><?xml version="1.0" encoding="utf-8"?>
+<p:notes xmlns:a="http://schemas.openxmlformats.org/drawingml/2006/main" xmlns:p="http://schemas.openxmlformats.org/presentationml/2006/main" xmlns:r="http://schemas.openxmlformats.org/officeDocument/2006/relationships">
+  <p:cSld>
+    <p:spTree>
+      <p:nvGrpSpPr>
+        <p:cNvPr id="1" name=""/>
+        <p:cNvGrpSpPr/>
+        <p:nvPr/>
+      </p:nvGrpSpPr>
+      <p:grpSpPr>
+        <a:xfrm>
+          <a:off x="0" y="0"/>
+          <a:ext cx="0" cy="0"/>
+          <a:chOff x="0" y="0"/>
+          <a:chExt cx="0" cy="0"/>
+        </a:xfrm>
+      </p:grpSpPr>
+      <p:sp>
+        <p:nvSpPr>
+          <p:cNvPr id="2" name="Slide Image Placeholder 1"/>
+          <p:cNvSpPr>
+            <a:spLocks noGrp="1"/>
+          </p:cNvSpPr>
+          <p:nvPr>
+            <p:ph type="sldImg" idx="2"/>
+          </p:nvPr>
+        </p:nvSpPr>
+        <p:spPr/>
+      </p:sp>
+      <p:sp>
+        <p:nvSpPr>
+          <p:cNvPr id="3" name="Notes Placeholder 2"/>
+          <p:cNvSpPr>
+            <a:spLocks noGrp="1"/>
+          </p:cNvSpPr>
+          <p:nvPr>
+            <p:ph type="body" idx="3" sz="quarter"/>
+          </p:nvPr>
+        </p:nvSpPr>
+        <p:spPr/>
+        <p:txBody>
+          <a:bodyPr/>
+          <a:lstStyle/>
+          <a:p>
+            <a:r>
+              <a:t>[6:29 PM to 6:34 PM  ~5 min]</a:t>
+            </a:r>
+          </a:p>
+          <a:p>
+            <a:r>
+              <a:t>TO THE NOTEBOOK: Act 2: "Under the hood: zero-shot isn't classification"</a:t>
+            </a:r>
+          </a:p>
+          <a:p/>
+          <a:p>
+            <a:r>
+              <a:t>You should be slightly suspicious right now. How can a model sort tickets into categories it has never seen before? Here is the answer, and it is my favourite thing in this lecture.</a:t>
+            </a:r>
+          </a:p>
+          <a:p>
+            <a:r>
+              <a:t>It is not a classifier. It is a fact-checker.</a:t>
+            </a:r>
+          </a:p>
+          <a:p>
+            <a:r>
+              <a:t>This model was trained on a task called natural language inference. You give it two sentences and it decides whether the first one makes the second one true. Entailment, or not. That is all it does.</a:t>
+            </a:r>
+          </a:p>
+          <a:p>
+            <a:r>
+              <a:t>The zero-shot trick is to smuggle classification into that format. The premise is the ticket. The hypothesis is a sentence we build: "This example is", plus your description. Then it just answers true or false.</a:t>
+            </a:r>
+          </a:p>
+          <a:p>
+            <a:r>
+              <a:t>Look at the two rows. For the billing description the entailment score is plus three point two nine, strongly true. For the slow-and-timing-out description it is minus three point eight six. The sign flips. It scores all eight sentences and picks whichever one it believes most.</a:t>
+            </a:r>
+          </a:p>
+        </p:txBody>
+      </p:sp>
+      <p:sp>
+        <p:nvSpPr>
+          <p:cNvPr id="4" name="Slide Number Placeholder 3"/>
+          <p:cNvSpPr>
+            <a:spLocks noGrp="1"/>
+          </p:cNvSpPr>
+          <p:nvPr>
+            <p:ph type="sldNum" idx="5" sz="quarter"/>
+          </p:nvPr>
+        </p:nvSpPr>
+        <p:spPr/>
+      </p:sp>
+    </p:spTree>
+  </p:cSld>
+  <p:clrMapOvr>
+    <a:masterClrMapping/>
+  </p:clrMapOvr>
+</p:notes>
+</file>
+
+<file path=ppt/notesSlides/notesSlide13.xml><?xml version="1.0" encoding="utf-8"?>
+<p:notes xmlns:a="http://schemas.openxmlformats.org/drawingml/2006/main" xmlns:p="http://schemas.openxmlformats.org/presentationml/2006/main" xmlns:r="http://schemas.openxmlformats.org/officeDocument/2006/relationships">
+  <p:cSld>
+    <p:spTree>
+      <p:nvGrpSpPr>
+        <p:cNvPr id="1" name=""/>
+        <p:cNvGrpSpPr/>
+        <p:nvPr/>
+      </p:nvGrpSpPr>
+      <p:grpSpPr>
+        <a:xfrm>
+          <a:off x="0" y="0"/>
+          <a:ext cx="0" cy="0"/>
+          <a:chOff x="0" y="0"/>
+          <a:chExt cx="0" cy="0"/>
+        </a:xfrm>
+      </p:grpSpPr>
+      <p:sp>
+        <p:nvSpPr>
+          <p:cNvPr id="2" name="Slide Image Placeholder 1"/>
+          <p:cNvSpPr>
+            <a:spLocks noGrp="1"/>
+          </p:cNvSpPr>
+          <p:nvPr>
+            <p:ph type="sldImg" idx="2"/>
+          </p:nvPr>
+        </p:nvSpPr>
+        <p:spPr/>
+      </p:sp>
+      <p:sp>
+        <p:nvSpPr>
+          <p:cNvPr id="3" name="Notes Placeholder 2"/>
+          <p:cNvSpPr>
+            <a:spLocks noGrp="1"/>
+          </p:cNvSpPr>
+          <p:nvPr>
+            <p:ph type="body" idx="3" sz="quarter"/>
+          </p:nvPr>
+        </p:nvSpPr>
+        <p:spPr/>
+        <p:txBody>
+          <a:bodyPr/>
+          <a:lstStyle/>
+          <a:p>
+            <a:r>
+              <a:t>[6:34 PM to 6:37 PM  ~3 min]</a:t>
+            </a:r>
+          </a:p>
+          <a:p>
+            <a:r>
+              <a:t>TO THE NOTEBOOK: Act 2: same cell, read the logits</a:t>
+            </a:r>
+          </a:p>
+          <a:p/>
+          <a:p>
+            <a:r>
+              <a:t>Here is what that looks like underneath the one-line pipeline. You tokenize the ticket and the hypothesis together as a pair, run the model, and read two numbers. The model's own output labels are literally "entailment" and "not entailment".</a:t>
+            </a:r>
+          </a:p>
+          <a:p>
+            <a:r>
+              <a:t>That is the whole mechanism.</a:t>
+            </a:r>
+          </a:p>
+          <a:p>
+            <a:r>
+              <a:t>So when you meet one of those "just describe what you want" AI tools, and there are a lot of them now, this is usually what is happening underneath. A model is scoring your words.</a:t>
+            </a:r>
+          </a:p>
+        </p:txBody>
+      </p:sp>
+      <p:sp>
+        <p:nvSpPr>
+          <p:cNvPr id="4" name="Slide Number Placeholder 3"/>
+          <p:cNvSpPr>
+            <a:spLocks noGrp="1"/>
+          </p:cNvSpPr>
+          <p:nvPr>
+            <p:ph type="sldNum" idx="5" sz="quarter"/>
+          </p:nvPr>
+        </p:nvSpPr>
+        <p:spPr/>
+      </p:sp>
+    </p:spTree>
+  </p:cSld>
+  <p:clrMapOvr>
+    <a:masterClrMapping/>
+  </p:clrMapOvr>
+</p:notes>
+</file>
+
+<file path=ppt/notesSlides/notesSlide14.xml><?xml version="1.0" encoding="utf-8"?>
+<p:notes xmlns:a="http://schemas.openxmlformats.org/drawingml/2006/main" xmlns:p="http://schemas.openxmlformats.org/presentationml/2006/main" xmlns:r="http://schemas.openxmlformats.org/officeDocument/2006/relationships">
+  <p:cSld>
+    <p:spTree>
+      <p:nvGrpSpPr>
+        <p:cNvPr id="1" name=""/>
+        <p:cNvGrpSpPr/>
+        <p:nvPr/>
+      </p:nvGrpSpPr>
+      <p:grpSpPr>
+        <a:xfrm>
+          <a:off x="0" y="0"/>
+          <a:ext cx="0" cy="0"/>
+          <a:chOff x="0" y="0"/>
+          <a:chExt cx="0" cy="0"/>
+        </a:xfrm>
+      </p:grpSpPr>
+      <p:sp>
+        <p:nvSpPr>
+          <p:cNvPr id="2" name="Slide Image Placeholder 1"/>
+          <p:cNvSpPr>
+            <a:spLocks noGrp="1"/>
+          </p:cNvSpPr>
+          <p:nvPr>
+            <p:ph type="sldImg" idx="2"/>
+          </p:nvPr>
+        </p:nvSpPr>
+        <p:spPr/>
+      </p:sp>
+      <p:sp>
+        <p:nvSpPr>
+          <p:cNvPr id="3" name="Notes Placeholder 2"/>
+          <p:cNvSpPr>
+            <a:spLocks noGrp="1"/>
+          </p:cNvSpPr>
+          <p:nvPr>
+            <p:ph type="body" idx="3" sz="quarter"/>
+          </p:nvPr>
+        </p:nvSpPr>
+        <p:spPr/>
+        <p:txBody>
+          <a:bodyPr/>
+          <a:lstStyle/>
+          <a:p>
+            <a:r>
+              <a:t>[6:37 PM to 6:41 PM  ~4 min]</a:t>
+            </a:r>
+          </a:p>
+          <a:p>
+            <a:r>
+              <a:t>TO THE NOTEBOOK: Act 2: YOUR KNOB, rewrite the descriptions</a:t>
+            </a:r>
+          </a:p>
+          <a:p/>
+          <a:p>
+            <a:r>
+              <a:t>Which brings us to the single most practical thing tonight. If the descriptions are the program, then how you write them is engineering.</a:t>
+            </a:r>
+          </a:p>
+          <a:p>
+            <a:r>
+              <a:t>Watch. On the left, careful descriptions: sixty four percent. On the right, I replaced them with lazy one-word labels. Just "billing". Just "bug". Forty seven percent.</a:t>
+            </a:r>
+          </a:p>
+          <a:p>
+            <a:r>
+              <a:t>Same model. Same tickets. Same code. Only the wording changed, and it cost seventeen points of accuracy.</a:t>
+            </a:r>
+          </a:p>
+          <a:p>
+            <a:r>
+              <a:t>Why? Because you are not naming a category. You are writing a sentence the model has to judge true or false, and "billing" is much harder to judge than "an invoice, payment, refund or pricing question".</a:t>
+            </a:r>
+          </a:p>
+          <a:p>
+            <a:r>
+              <a:t>This is exactly the same skill as writing a good prompt. Precision in writing is not a soft skill here. It is the program.</a:t>
+            </a:r>
+          </a:p>
+        </p:txBody>
+      </p:sp>
+      <p:sp>
+        <p:nvSpPr>
+          <p:cNvPr id="4" name="Slide Number Placeholder 3"/>
+          <p:cNvSpPr>
+            <a:spLocks noGrp="1"/>
+          </p:cNvSpPr>
+          <p:nvPr>
+            <p:ph type="sldNum" idx="5" sz="quarter"/>
+          </p:nvPr>
+        </p:nvSpPr>
+        <p:spPr/>
+      </p:sp>
+    </p:spTree>
+  </p:cSld>
+  <p:clrMapOvr>
+    <a:masterClrMapping/>
+  </p:clrMapOvr>
+</p:notes>
+</file>
+
+<file path=ppt/notesSlides/notesSlide15.xml><?xml version="1.0" encoding="utf-8"?>
+<p:notes xmlns:a="http://schemas.openxmlformats.org/drawingml/2006/main" xmlns:p="http://schemas.openxmlformats.org/presentationml/2006/main" xmlns:r="http://schemas.openxmlformats.org/officeDocument/2006/relationships">
+  <p:cSld>
+    <p:spTree>
+      <p:nvGrpSpPr>
+        <p:cNvPr id="1" name=""/>
+        <p:cNvGrpSpPr/>
+        <p:nvPr/>
+      </p:nvGrpSpPr>
+      <p:grpSpPr>
+        <a:xfrm>
+          <a:off x="0" y="0"/>
+          <a:ext cx="0" cy="0"/>
+          <a:chOff x="0" y="0"/>
+          <a:chExt cx="0" cy="0"/>
+        </a:xfrm>
+      </p:grpSpPr>
+      <p:sp>
+        <p:nvSpPr>
+          <p:cNvPr id="2" name="Slide Image Placeholder 1"/>
+          <p:cNvSpPr>
+            <a:spLocks noGrp="1"/>
+          </p:cNvSpPr>
+          <p:nvPr>
+            <p:ph type="sldImg" idx="2"/>
+          </p:nvPr>
+        </p:nvSpPr>
+        <p:spPr/>
+      </p:sp>
+      <p:sp>
+        <p:nvSpPr>
+          <p:cNvPr id="3" name="Notes Placeholder 2"/>
+          <p:cNvSpPr>
+            <a:spLocks noGrp="1"/>
+          </p:cNvSpPr>
+          <p:nvPr>
+            <p:ph type="body" idx="3" sz="quarter"/>
+          </p:nvPr>
+        </p:nvSpPr>
+        <p:spPr/>
+        <p:txBody>
+          <a:bodyPr/>
+          <a:lstStyle/>
+          <a:p>
+            <a:r>
+              <a:t>[6:41 PM to 6:46 PM  ~5 min]</a:t>
+            </a:r>
+          </a:p>
+          <a:p>
+            <a:r>
+              <a:t>TO THE NOTEBOOK: Act 3: "Where v1 breaks"</a:t>
+            </a:r>
+          </a:p>
+          <a:p/>
+          <a:p>
+            <a:r>
+              <a:t>Now let us be honest about sixty four percent, because an average is a terrible way to run a product. The question is not "how accurate is it". The question is "which tickets does it get wrong, and do I care".</a:t>
+            </a:r>
+          </a:p>
+          <a:p>
+            <a:r>
+              <a:t>Here is the per-bucket breakdown. Green is fine, red is broken. How-to and feature requests are strong. Data sync is the worst by a mile.</a:t>
+            </a:r>
+          </a:p>
+          <a:p>
+            <a:r>
+              <a:t>And when I pull up the actual mistakes, the pattern is obvious. Data sync tickets are being sent to the UI bug bucket. Look at why. "The row counts do not match our warehouse." Is that a data sync problem, or is that something displaying the wrong number? Honestly, it is both. My two descriptions overlap.</a:t>
+            </a:r>
+          </a:p>
+          <a:p>
+            <a:r>
+              <a:t>The model is not confused. My categories are.</a:t>
+            </a:r>
+          </a:p>
+          <a:p>
+            <a:r>
+              <a:t>So write this one down: when a classifier underperforms, look at your taxonomy before you look at your model. Categories should describe what the customer wants done, not which internal component broke.</a:t>
+            </a:r>
+          </a:p>
+        </p:txBody>
+      </p:sp>
+      <p:sp>
+        <p:nvSpPr>
+          <p:cNvPr id="4" name="Slide Number Placeholder 3"/>
+          <p:cNvSpPr>
+            <a:spLocks noGrp="1"/>
+          </p:cNvSpPr>
+          <p:nvPr>
+            <p:ph type="sldNum" idx="5" sz="quarter"/>
+          </p:nvPr>
+        </p:nvSpPr>
+        <p:spPr/>
+      </p:sp>
+    </p:spTree>
+  </p:cSld>
+  <p:clrMapOvr>
+    <a:masterClrMapping/>
+  </p:clrMapOvr>
+</p:notes>
+</file>
+
+<file path=ppt/notesSlides/notesSlide16.xml><?xml version="1.0" encoding="utf-8"?>
+<p:notes xmlns:a="http://schemas.openxmlformats.org/drawingml/2006/main" xmlns:p="http://schemas.openxmlformats.org/presentationml/2006/main" xmlns:r="http://schemas.openxmlformats.org/officeDocument/2006/relationships">
+  <p:cSld>
+    <p:spTree>
+      <p:nvGrpSpPr>
+        <p:cNvPr id="1" name=""/>
+        <p:cNvGrpSpPr/>
+        <p:nvPr/>
+      </p:nvGrpSpPr>
+      <p:grpSpPr>
+        <a:xfrm>
+          <a:off x="0" y="0"/>
+          <a:ext cx="0" cy="0"/>
+          <a:chOff x="0" y="0"/>
+          <a:chExt cx="0" cy="0"/>
+        </a:xfrm>
+      </p:grpSpPr>
+      <p:sp>
+        <p:nvSpPr>
+          <p:cNvPr id="2" name="Slide Image Placeholder 1"/>
+          <p:cNvSpPr>
+            <a:spLocks noGrp="1"/>
+          </p:cNvSpPr>
+          <p:nvPr>
+            <p:ph type="sldImg" idx="2"/>
+          </p:nvPr>
+        </p:nvSpPr>
+        <p:spPr/>
+      </p:sp>
+      <p:sp>
+        <p:nvSpPr>
+          <p:cNvPr id="3" name="Notes Placeholder 2"/>
+          <p:cNvSpPr>
+            <a:spLocks noGrp="1"/>
+          </p:cNvSpPr>
+          <p:nvPr>
+            <p:ph type="body" idx="3" sz="quarter"/>
+          </p:nvPr>
+        </p:nvSpPr>
+        <p:spPr/>
+        <p:txBody>
+          <a:bodyPr/>
+          <a:lstStyle/>
+          <a:p>
+            <a:r>
+              <a:t>[6:46 PM to 6:51 PM  ~5 min]</a:t>
+            </a:r>
+          </a:p>
+          <a:p>
+            <a:r>
+              <a:t>TO THE NOTEBOOK: Act 3: "Why was it 99% sure and wrong?"</a:t>
+            </a:r>
+          </a:p>
+          <a:p/>
+          <a:p>
+            <a:r>
+              <a:t>Here is the thing that should genuinely worry you, and it is the most important slide tonight.</a:t>
+            </a:r>
+          </a:p>
+          <a:p>
+            <a:r>
+              <a:t>Those data sync tickets were not misrouted with a shrug. The model was ninety four percent, ninety nine percent confident, and wrong. Confidently wrong is far more dangerous than uncertain.</a:t>
+            </a:r>
+          </a:p>
+          <a:p>
+            <a:r>
+              <a:t>Let me show you why that happens. I am going to feed it a ticket that belongs in none of our eight buckets: somebody applying for a job. Predict what happens.</a:t>
+            </a:r>
+          </a:p>
+          <a:p>
+            <a:r>
+              <a:t>[run it] It says "feature request", sixty one percent confident. And look at the bottom line: the scores sum to one point zero zero.</a:t>
+            </a:r>
+          </a:p>
+          <a:p>
+            <a:r>
+              <a:t>There it is. The final step is a softmax, and a softmax spreads one hundred percent of the belief across the options you supplied. It has to pick a winner. There is no "none of these" unless you build one.</a:t>
+            </a:r>
+          </a:p>
+          <a:p>
+            <a:r>
+              <a:t>So that confidence number does not mean "how likely am I to be right". It means "of the choices you gave me, this one fits best". A confident wrong answer is exactly what you get when every option is bad.</a:t>
+            </a:r>
+          </a:p>
+          <a:p>
+            <a:r>
+              <a:t>Practical rule: never show a raw confidence score to a user as if it were a probability of correctness, and never let one gate an action you cannot undo.</a:t>
+            </a:r>
+          </a:p>
+        </p:txBody>
+      </p:sp>
+      <p:sp>
+        <p:nvSpPr>
+          <p:cNvPr id="4" name="Slide Number Placeholder 3"/>
+          <p:cNvSpPr>
+            <a:spLocks noGrp="1"/>
+          </p:cNvSpPr>
+          <p:nvPr>
+            <p:ph type="sldNum" idx="5" sz="quarter"/>
+          </p:nvPr>
+        </p:nvSpPr>
+        <p:spPr/>
+      </p:sp>
+    </p:spTree>
+  </p:cSld>
+  <p:clrMapOvr>
+    <a:masterClrMapping/>
+  </p:clrMapOvr>
+</p:notes>
+</file>
+
+<file path=ppt/notesSlides/notesSlide17.xml><?xml version="1.0" encoding="utf-8"?>
+<p:notes xmlns:a="http://schemas.openxmlformats.org/drawingml/2006/main" xmlns:p="http://schemas.openxmlformats.org/presentationml/2006/main" xmlns:r="http://schemas.openxmlformats.org/officeDocument/2006/relationships">
+  <p:cSld>
+    <p:spTree>
+      <p:nvGrpSpPr>
+        <p:cNvPr id="1" name=""/>
+        <p:cNvGrpSpPr/>
+        <p:nvPr/>
+      </p:nvGrpSpPr>
+      <p:grpSpPr>
+        <a:xfrm>
+          <a:off x="0" y="0"/>
+          <a:ext cx="0" cy="0"/>
+          <a:chOff x="0" y="0"/>
+          <a:chExt cx="0" cy="0"/>
+        </a:xfrm>
+      </p:grpSpPr>
+      <p:sp>
+        <p:nvSpPr>
+          <p:cNvPr id="2" name="Slide Image Placeholder 1"/>
+          <p:cNvSpPr>
+            <a:spLocks noGrp="1"/>
+          </p:cNvSpPr>
+          <p:nvPr>
+            <p:ph type="sldImg" idx="2"/>
+          </p:nvPr>
+        </p:nvSpPr>
+        <p:spPr/>
+      </p:sp>
+      <p:sp>
+        <p:nvSpPr>
+          <p:cNvPr id="3" name="Notes Placeholder 2"/>
+          <p:cNvSpPr>
+            <a:spLocks noGrp="1"/>
+          </p:cNvSpPr>
+          <p:nvPr>
+            <p:ph type="body" idx="3" sz="quarter"/>
+          </p:nvPr>
+        </p:nvSpPr>
+        <p:spPr/>
+        <p:txBody>
+          <a:bodyPr/>
+          <a:lstStyle/>
+          <a:p>
+            <a:r>
+              <a:t>[6:51 PM to 6:55 PM  ~4 min]</a:t>
+            </a:r>
+          </a:p>
+          <a:p>
+            <a:r>
+              <a:t>TO THE NOTEBOOK: Act 3: the two one-line defences</a:t>
+            </a:r>
+          </a:p>
+          <a:p/>
+          <a:p>
+            <a:r>
+              <a:t>Two fixes, one line each.</a:t>
+            </a:r>
+          </a:p>
+          <a:p>
+            <a:r>
+              <a:t>First, give the model somewhere honest to go. I add an "other" bucket, described as "unrelated to the product, such as sales or careers". Re-run the job application and it lands in "other" at seventy five percent. Fixed.</a:t>
+            </a:r>
+          </a:p>
+          <a:p>
+            <a:r>
+              <a:t>Second, and this one is subtler: stop making it choose. Switch to multi-label, which scores every category independently instead of forcing them to compete. Now the job application scores thirteen percent on its best category, and the total is zero point one four. Low on everything. That is the model saying "I do not know", which is enormously more useful than a confident wrong answer.</a:t>
+            </a:r>
+          </a:p>
+          <a:p>
+            <a:r>
+              <a:t>The difference between a demo and a product is very often just this: deciding what happens when the model is out of its depth. Good question to ask any vendor: what does your system do with an input it has never seen?</a:t>
+            </a:r>
+          </a:p>
+        </p:txBody>
+      </p:sp>
+      <p:sp>
+        <p:nvSpPr>
+          <p:cNvPr id="4" name="Slide Number Placeholder 3"/>
+          <p:cNvSpPr>
+            <a:spLocks noGrp="1"/>
+          </p:cNvSpPr>
+          <p:nvPr>
+            <p:ph type="sldNum" idx="5" sz="quarter"/>
+          </p:nvPr>
+        </p:nvSpPr>
+        <p:spPr/>
+      </p:sp>
+    </p:spTree>
+  </p:cSld>
+  <p:clrMapOvr>
+    <a:masterClrMapping/>
+  </p:clrMapOvr>
+</p:notes>
+</file>
+
+<file path=ppt/notesSlides/notesSlide18.xml><?xml version="1.0" encoding="utf-8"?>
+<p:notes xmlns:a="http://schemas.openxmlformats.org/drawingml/2006/main" xmlns:p="http://schemas.openxmlformats.org/presentationml/2006/main" xmlns:r="http://schemas.openxmlformats.org/officeDocument/2006/relationships">
+  <p:cSld>
+    <p:spTree>
+      <p:nvGrpSpPr>
+        <p:cNvPr id="1" name=""/>
+        <p:cNvGrpSpPr/>
+        <p:nvPr/>
+      </p:nvGrpSpPr>
+      <p:grpSpPr>
+        <a:xfrm>
+          <a:off x="0" y="0"/>
+          <a:ext cx="0" cy="0"/>
+          <a:chOff x="0" y="0"/>
+          <a:chExt cx="0" cy="0"/>
+        </a:xfrm>
+      </p:grpSpPr>
+      <p:sp>
+        <p:nvSpPr>
+          <p:cNvPr id="2" name="Slide Image Placeholder 1"/>
+          <p:cNvSpPr>
+            <a:spLocks noGrp="1"/>
+          </p:cNvSpPr>
+          <p:nvPr>
+            <p:ph type="sldImg" idx="2"/>
+          </p:nvPr>
+        </p:nvSpPr>
+        <p:spPr/>
+      </p:sp>
+      <p:sp>
+        <p:nvSpPr>
+          <p:cNvPr id="3" name="Notes Placeholder 2"/>
+          <p:cNvSpPr>
+            <a:spLocks noGrp="1"/>
+          </p:cNvSpPr>
+          <p:nvPr>
+            <p:ph type="body" idx="3" sz="quarter"/>
+          </p:nvPr>
+        </p:nvSpPr>
+        <p:spPr/>
+        <p:txBody>
+          <a:bodyPr/>
+          <a:lstStyle/>
+          <a:p>
+            <a:r>
+              <a:t>[6:55 PM to 7:00 PM  ~5 min]</a:t>
+            </a:r>
+          </a:p>
+          <a:p>
+            <a:r>
+              <a:t>TO THE NOTEBOOK: Act 3: YOUR KNOB, move THRESHOLD</a:t>
+            </a:r>
+          </a:p>
+          <a:p/>
+          <a:p>
+            <a:r>
+              <a:t>Last capability. You do not have to route everything. Route only what the model is sure about, and send the rest to a human. That is one number, and this curve is what it does.</a:t>
+            </a:r>
+          </a:p>
+          <a:p>
+            <a:r>
+              <a:t>Purple is the share of the inbox you auto-route. Green is how accurate those decisions are. They move in opposite directions, and there is no setting that maximises both. Set the bar low and you automate almost everything, badly. Set it high and you automate a little, very well.</a:t>
+            </a:r>
+          </a:p>
+          <a:p>
+            <a:r>
+              <a:t>This curve, not an accuracy number, is what you take into the room. "We can automate thirty nine percent of the inbox at eighty seven percent accuracy, or cover far more and be less right." That is a sentence an executive can actually make a decision about.</a:t>
+            </a:r>
+          </a:p>
+          <a:p>
+            <a:r>
+              <a:t>And notice: the right answer depends entirely on what a misroute costs you versus what an agent's hour is worth. That is a business question, not a modelling question.</a:t>
+            </a:r>
+          </a:p>
+        </p:txBody>
+      </p:sp>
+      <p:sp>
+        <p:nvSpPr>
+          <p:cNvPr id="4" name="Slide Number Placeholder 3"/>
+          <p:cNvSpPr>
+            <a:spLocks noGrp="1"/>
+          </p:cNvSpPr>
+          <p:nvPr>
+            <p:ph type="sldNum" idx="5" sz="quarter"/>
+          </p:nvPr>
+        </p:nvSpPr>
+        <p:spPr/>
+      </p:sp>
+    </p:spTree>
+  </p:cSld>
+  <p:clrMapOvr>
+    <a:masterClrMapping/>
+  </p:clrMapOvr>
+</p:notes>
+</file>
+
+<file path=ppt/notesSlides/notesSlide19.xml><?xml version="1.0" encoding="utf-8"?>
+<p:notes xmlns:a="http://schemas.openxmlformats.org/drawingml/2006/main" xmlns:p="http://schemas.openxmlformats.org/presentationml/2006/main" xmlns:r="http://schemas.openxmlformats.org/officeDocument/2006/relationships">
+  <p:cSld>
+    <p:spTree>
+      <p:nvGrpSpPr>
+        <p:cNvPr id="1" name=""/>
+        <p:cNvGrpSpPr/>
+        <p:nvPr/>
+      </p:nvGrpSpPr>
+      <p:grpSpPr>
+        <a:xfrm>
+          <a:off x="0" y="0"/>
+          <a:ext cx="0" cy="0"/>
+          <a:chOff x="0" y="0"/>
+          <a:chExt cx="0" cy="0"/>
+        </a:xfrm>
+      </p:grpSpPr>
+      <p:sp>
+        <p:nvSpPr>
+          <p:cNvPr id="2" name="Slide Image Placeholder 1"/>
+          <p:cNvSpPr>
+            <a:spLocks noGrp="1"/>
+          </p:cNvSpPr>
+          <p:nvPr>
+            <p:ph type="sldImg" idx="2"/>
+          </p:nvPr>
+        </p:nvSpPr>
+        <p:spPr/>
+      </p:sp>
+      <p:sp>
+        <p:nvSpPr>
+          <p:cNvPr id="3" name="Notes Placeholder 2"/>
+          <p:cNvSpPr>
+            <a:spLocks noGrp="1"/>
+          </p:cNvSpPr>
+          <p:nvPr>
+            <p:ph type="body" idx="3" sz="quarter"/>
+          </p:nvPr>
+        </p:nvSpPr>
+        <p:spPr/>
+        <p:txBody>
+          <a:bodyPr/>
+          <a:lstStyle/>
+          <a:p>
+            <a:r>
+              <a:t>[7:00 PM to 7:03 PM  ~3 min]</a:t>
+            </a:r>
+          </a:p>
+          <a:p>
+            <a:r>
+              <a:t>TO THE NOTEBOOK: Act 3: same cell, read the business numbers</a:t>
+            </a:r>
+          </a:p>
+          <a:p/>
+          <a:p>
+            <a:r>
+              <a:t>So let us put a number on it. Threshold at zero point nine. Thirty nine percent of the inbox auto-routed, and eighty seven percent accurate on those. Sixty one percent still goes to a human.</a:t>
+            </a:r>
+          </a:p>
+          <a:p>
+            <a:r>
+              <a:t>At five thousand tickets a week, that is roughly nineteen hundred tickets a week handled without anyone touching them.</a:t>
+            </a:r>
+          </a:p>
+          <a:p>
+            <a:r>
+              <a:t>Nineteen hundred. With no labelled data, no training, and no GPU bill. That is a real thing you could ship on Monday.</a:t>
+            </a:r>
+          </a:p>
+        </p:txBody>
+      </p:sp>
+      <p:sp>
+        <p:nvSpPr>
+          <p:cNvPr id="4" name="Slide Number Placeholder 3"/>
+          <p:cNvSpPr>
+            <a:spLocks noGrp="1"/>
+          </p:cNvSpPr>
+          <p:nvPr>
+            <p:ph type="sldNum" idx="5" sz="quarter"/>
+          </p:nvPr>
+        </p:nvSpPr>
+        <p:spPr/>
+      </p:sp>
+    </p:spTree>
+  </p:cSld>
+  <p:clrMapOvr>
+    <a:masterClrMapping/>
+  </p:clrMapOvr>
+</p:notes>
+</file>
+
+<file path=ppt/notesSlides/notesSlide2.xml><?xml version="1.0" encoding="utf-8"?>
+<p:notes xmlns:a="http://schemas.openxmlformats.org/drawingml/2006/main" xmlns:p="http://schemas.openxmlformats.org/presentationml/2006/main" xmlns:r="http://schemas.openxmlformats.org/officeDocument/2006/relationships">
+  <p:cSld>
+    <p:spTree>
+      <p:nvGrpSpPr>
+        <p:cNvPr id="1" name=""/>
+        <p:cNvGrpSpPr/>
+        <p:nvPr/>
+      </p:nvGrpSpPr>
+      <p:grpSpPr>
+        <a:xfrm>
+          <a:off x="0" y="0"/>
+          <a:ext cx="0" cy="0"/>
+          <a:chOff x="0" y="0"/>
+          <a:chExt cx="0" cy="0"/>
+        </a:xfrm>
+      </p:grpSpPr>
+      <p:sp>
+        <p:nvSpPr>
+          <p:cNvPr id="2" name="Slide Image Placeholder 1"/>
+          <p:cNvSpPr>
+            <a:spLocks noGrp="1"/>
+          </p:cNvSpPr>
+          <p:nvPr>
+            <p:ph type="sldImg" idx="2"/>
+          </p:nvPr>
+        </p:nvSpPr>
+        <p:spPr/>
+      </p:sp>
+      <p:sp>
+        <p:nvSpPr>
+          <p:cNvPr id="3" name="Notes Placeholder 2"/>
+          <p:cNvSpPr>
+            <a:spLocks noGrp="1"/>
+          </p:cNvSpPr>
+          <p:nvPr>
+            <p:ph type="body" idx="3" sz="quarter"/>
+          </p:nvPr>
+        </p:nvSpPr>
+        <p:spPr/>
+        <p:txBody>
+          <a:bodyPr/>
+          <a:lstStyle/>
+          <a:p>
+            <a:r>
+              <a:t>[5:47 PM to 5:50 PM  ~3 min]</a:t>
+            </a:r>
+          </a:p>
+          <a:p/>
+          <a:p>
+            <a:r>
+              <a:t>Before we build anything, here is the map of the week so you always know where you are.</a:t>
+            </a:r>
+          </a:p>
+          <a:p>
+            <a:r>
+              <a:t>On the left are the concepts. The ones tagged L13 are tonight. The ones tagged L14 are Thursday. Notice the split: tonight is about *using* models that already exist, and Thursday is about how they got that way and what happens when you adapt one to your own data.</a:t>
+            </a:r>
+          </a:p>
+          <a:p>
+            <a:r>
+              <a:t>On the right are the five models we actually run. Look at the sizes. Twenty three million parameters for the small one, a hundred and eighty four million for the biggest. These are tiny by modern standards, and every one of them runs free in Colab. And every single one was pretrained by somebody else. We just download them. That fact is the entire reason this week works.</a:t>
+            </a:r>
+          </a:p>
+          <a:p>
+            <a:r>
+              <a:t>At the bottom are the readings. Jurafsky and Martin chapter seven is generalised language models, chapter ten is BERT. Those two are the core. The titles are live links in the PDF on Canvas.</a:t>
+            </a:r>
+          </a:p>
+        </p:txBody>
+      </p:sp>
+      <p:sp>
+        <p:nvSpPr>
+          <p:cNvPr id="4" name="Slide Number Placeholder 3"/>
+          <p:cNvSpPr>
+            <a:spLocks noGrp="1"/>
+          </p:cNvSpPr>
+          <p:nvPr>
+            <p:ph type="sldNum" idx="5" sz="quarter"/>
+          </p:nvPr>
+        </p:nvSpPr>
+        <p:spPr/>
+      </p:sp>
+    </p:spTree>
+  </p:cSld>
+  <p:clrMapOvr>
+    <a:masterClrMapping/>
+  </p:clrMapOvr>
+</p:notes>
+</file>
+
+<file path=ppt/notesSlides/notesSlide20.xml><?xml version="1.0" encoding="utf-8"?>
+<p:notes xmlns:a="http://schemas.openxmlformats.org/drawingml/2006/main" xmlns:p="http://schemas.openxmlformats.org/presentationml/2006/main" xmlns:r="http://schemas.openxmlformats.org/officeDocument/2006/relationships">
+  <p:cSld>
+    <p:spTree>
+      <p:nvGrpSpPr>
+        <p:cNvPr id="1" name=""/>
+        <p:cNvGrpSpPr/>
+        <p:nvPr/>
+      </p:nvGrpSpPr>
+      <p:grpSpPr>
+        <a:xfrm>
+          <a:off x="0" y="0"/>
+          <a:ext cx="0" cy="0"/>
+          <a:chOff x="0" y="0"/>
+          <a:chExt cx="0" cy="0"/>
+        </a:xfrm>
+      </p:grpSpPr>
+      <p:sp>
+        <p:nvSpPr>
+          <p:cNvPr id="2" name="Slide Image Placeholder 1"/>
+          <p:cNvSpPr>
+            <a:spLocks noGrp="1"/>
+          </p:cNvSpPr>
+          <p:nvPr>
+            <p:ph type="sldImg" idx="2"/>
+          </p:nvPr>
+        </p:nvSpPr>
+        <p:spPr/>
+      </p:sp>
+      <p:sp>
+        <p:nvSpPr>
+          <p:cNvPr id="3" name="Notes Placeholder 2"/>
+          <p:cNvSpPr>
+            <a:spLocks noGrp="1"/>
+          </p:cNvSpPr>
+          <p:nvPr>
+            <p:ph type="body" idx="3" sz="quarter"/>
+          </p:nvPr>
+        </p:nvSpPr>
+        <p:spPr/>
+        <p:txBody>
+          <a:bodyPr/>
+          <a:lstStyle/>
+          <a:p>
+            <a:r>
+              <a:t>[7:03 PM to 7:07 PM  ~4 min]</a:t>
+            </a:r>
+          </a:p>
+          <a:p/>
+          <a:p>
+            <a:r>
+              <a:t>Full circle. Here is what we built tonight.</a:t>
+            </a:r>
+          </a:p>
+          <a:p>
+            <a:r>
+              <a:t>Semantic search across the whole inbox. An eight-way router built with zero labelled examples. A confidence policy that decides what ships automatically. And an escalation path, so the system can admit when it does not know.</a:t>
+            </a:r>
+          </a:p>
+          <a:p>
+            <a:r>
+              <a:t>Total labelling cost: zero dollars.</a:t>
+            </a:r>
+          </a:p>
+          <a:p>
+            <a:r>
+              <a:t>And here is the one idea I want you to leave with. Somebody else already spent millions of dollars teaching a model to read English. You do not have to build intelligence. Your job is to point it at your problem, cheaply, and know where it breaks.</a:t>
+            </a:r>
+          </a:p>
+        </p:txBody>
+      </p:sp>
+      <p:sp>
+        <p:nvSpPr>
+          <p:cNvPr id="4" name="Slide Number Placeholder 3"/>
+          <p:cNvSpPr>
+            <a:spLocks noGrp="1"/>
+          </p:cNvSpPr>
+          <p:nvPr>
+            <p:ph type="sldNum" idx="5" sz="quarter"/>
+          </p:nvPr>
+        </p:nvSpPr>
+        <p:spPr/>
+      </p:sp>
+    </p:spTree>
+  </p:cSld>
+  <p:clrMapOvr>
+    <a:masterClrMapping/>
+  </p:clrMapOvr>
+</p:notes>
+</file>
+
+<file path=ppt/notesSlides/notesSlide21.xml><?xml version="1.0" encoding="utf-8"?>
+<p:notes xmlns:a="http://schemas.openxmlformats.org/drawingml/2006/main" xmlns:p="http://schemas.openxmlformats.org/presentationml/2006/main" xmlns:r="http://schemas.openxmlformats.org/officeDocument/2006/relationships">
+  <p:cSld>
+    <p:spTree>
+      <p:nvGrpSpPr>
+        <p:cNvPr id="1" name=""/>
+        <p:cNvGrpSpPr/>
+        <p:nvPr/>
+      </p:nvGrpSpPr>
+      <p:grpSpPr>
+        <a:xfrm>
+          <a:off x="0" y="0"/>
+          <a:ext cx="0" cy="0"/>
+          <a:chOff x="0" y="0"/>
+          <a:chExt cx="0" cy="0"/>
+        </a:xfrm>
+      </p:grpSpPr>
+      <p:sp>
+        <p:nvSpPr>
+          <p:cNvPr id="2" name="Slide Image Placeholder 1"/>
+          <p:cNvSpPr>
+            <a:spLocks noGrp="1"/>
+          </p:cNvSpPr>
+          <p:nvPr>
+            <p:ph type="sldImg" idx="2"/>
+          </p:nvPr>
+        </p:nvSpPr>
+        <p:spPr/>
+      </p:sp>
+      <p:sp>
+        <p:nvSpPr>
+          <p:cNvPr id="3" name="Notes Placeholder 2"/>
+          <p:cNvSpPr>
+            <a:spLocks noGrp="1"/>
+          </p:cNvSpPr>
+          <p:nvPr>
+            <p:ph type="body" idx="3" sz="quarter"/>
+          </p:nvPr>
+        </p:nvSpPr>
+        <p:spPr/>
+        <p:txBody>
+          <a:bodyPr/>
+          <a:lstStyle/>
+          <a:p>
+            <a:r>
+              <a:t>[7:07 PM to 7:11 PM  ~4 min]</a:t>
+            </a:r>
+          </a:p>
+          <a:p/>
+          <a:p>
+            <a:r>
+              <a:t>Let me translate all of that into sentences you can actually say in a meeting, because that is the part that gets you hired.</a:t>
+            </a:r>
+          </a:p>
+          <a:p>
+            <a:r>
+              <a:t>Take the third row. You now know you can ship a useful classifier with no training data. So when somebody says "we cannot start until we have labelled data", you know that is often just not true.</a:t>
+            </a:r>
+          </a:p>
+          <a:p>
+            <a:r>
+              <a:t>Or the fifth row: a confident answer can be completely wrong, so you never wire a confidence score to an irreversible action.</a:t>
+            </a:r>
+          </a:p>
+          <a:p>
+            <a:r>
+              <a:t>Or the last one: coverage and accuracy trade off against each other, so what you hand your boss is a curve, not a number.</a:t>
+            </a:r>
+          </a:p>
+          <a:p>
+            <a:r>
+              <a:t>None of these are facts about transformers. They are instincts about building products with them, and this morning you did not have them.</a:t>
+            </a:r>
+          </a:p>
+        </p:txBody>
+      </p:sp>
+      <p:sp>
+        <p:nvSpPr>
+          <p:cNvPr id="4" name="Slide Number Placeholder 3"/>
+          <p:cNvSpPr>
+            <a:spLocks noGrp="1"/>
+          </p:cNvSpPr>
+          <p:nvPr>
+            <p:ph type="sldNum" idx="5" sz="quarter"/>
+          </p:nvPr>
+        </p:nvSpPr>
+        <p:spPr/>
+      </p:sp>
+    </p:spTree>
+  </p:cSld>
+  <p:clrMapOvr>
+    <a:masterClrMapping/>
+  </p:clrMapOvr>
+</p:notes>
+</file>
+
+<file path=ppt/notesSlides/notesSlide22.xml><?xml version="1.0" encoding="utf-8"?>
+<p:notes xmlns:a="http://schemas.openxmlformats.org/drawingml/2006/main" xmlns:p="http://schemas.openxmlformats.org/presentationml/2006/main" xmlns:r="http://schemas.openxmlformats.org/officeDocument/2006/relationships">
+  <p:cSld>
+    <p:spTree>
+      <p:nvGrpSpPr>
+        <p:cNvPr id="1" name=""/>
+        <p:cNvGrpSpPr/>
+        <p:nvPr/>
+      </p:nvGrpSpPr>
+      <p:grpSpPr>
+        <a:xfrm>
+          <a:off x="0" y="0"/>
+          <a:ext cx="0" cy="0"/>
+          <a:chOff x="0" y="0"/>
+          <a:chExt cx="0" cy="0"/>
+        </a:xfrm>
+      </p:grpSpPr>
+      <p:sp>
+        <p:nvSpPr>
+          <p:cNvPr id="2" name="Slide Image Placeholder 1"/>
+          <p:cNvSpPr>
+            <a:spLocks noGrp="1"/>
+          </p:cNvSpPr>
+          <p:nvPr>
+            <p:ph type="sldImg" idx="2"/>
+          </p:nvPr>
+        </p:nvSpPr>
+        <p:spPr/>
+      </p:sp>
+      <p:sp>
+        <p:nvSpPr>
+          <p:cNvPr id="3" name="Notes Placeholder 2"/>
+          <p:cNvSpPr>
+            <a:spLocks noGrp="1"/>
+          </p:cNvSpPr>
+          <p:nvPr>
+            <p:ph type="body" idx="3" sz="quarter"/>
+          </p:nvPr>
+        </p:nvSpPr>
+        <p:spPr/>
+        <p:txBody>
+          <a:bodyPr/>
+          <a:lstStyle/>
+          <a:p>
+            <a:r>
+              <a:t>[7:11 PM to 7:13 PM  ~2 min]</a:t>
+            </a:r>
+          </a:p>
+          <a:p/>
+          <a:p>
+            <a:r>
+              <a:t>Thursday we build the other half. Four things.</a:t>
+            </a:r>
+          </a:p>
+          <a:p>
+            <a:r>
+              <a:t>First: what actually happens if we do invest in labelling a few hundred tickets. Is it worth it?</a:t>
+            </a:r>
+          </a:p>
+          <a:p>
+            <a:r>
+              <a:t>Second: where tonight's reading ability came from, which is BERT and masked language modelling.</a:t>
+            </a:r>
+          </a:p>
+          <a:p>
+            <a:r>
+              <a:t>Third: pulling out specifics, so instead of "this is a data problem" we get "the Postgres connector, error code SYNC_TIMEOUT, on the Business plan".</a:t>
+            </a:r>
+          </a:p>
+          <a:p>
+            <a:r>
+              <a:t>And fourth, the one that sets up Week 8: we watch the model invent a refund policy that does not exist, with total confidence.</a:t>
+            </a:r>
+          </a:p>
+          <a:p>
+            <a:r>
+              <a:t>The notebook is on Canvas and on GitHub. Run it, turn the knobs, and try to break it. That is where this goes from "I watched it" to "I get it".</a:t>
+            </a:r>
+          </a:p>
+        </p:txBody>
+      </p:sp>
+      <p:sp>
+        <p:nvSpPr>
+          <p:cNvPr id="4" name="Slide Number Placeholder 3"/>
+          <p:cNvSpPr>
+            <a:spLocks noGrp="1"/>
+          </p:cNvSpPr>
+          <p:nvPr>
+            <p:ph type="sldNum" idx="5" sz="quarter"/>
+          </p:nvPr>
+        </p:nvSpPr>
+        <p:spPr/>
+      </p:sp>
+    </p:spTree>
+  </p:cSld>
+  <p:clrMapOvr>
+    <a:masterClrMapping/>
+  </p:clrMapOvr>
+</p:notes>
+</file>
+
+<file path=ppt/notesSlides/notesSlide3.xml><?xml version="1.0" encoding="utf-8"?>
+<p:notes xmlns:a="http://schemas.openxmlformats.org/drawingml/2006/main" xmlns:p="http://schemas.openxmlformats.org/presentationml/2006/main" xmlns:r="http://schemas.openxmlformats.org/officeDocument/2006/relationships">
+  <p:cSld>
+    <p:spTree>
+      <p:nvGrpSpPr>
+        <p:cNvPr id="1" name=""/>
+        <p:cNvGrpSpPr/>
+        <p:nvPr/>
+      </p:nvGrpSpPr>
+      <p:grpSpPr>
+        <a:xfrm>
+          <a:off x="0" y="0"/>
+          <a:ext cx="0" cy="0"/>
+          <a:chOff x="0" y="0"/>
+          <a:chExt cx="0" cy="0"/>
+        </a:xfrm>
+      </p:grpSpPr>
+      <p:sp>
+        <p:nvSpPr>
+          <p:cNvPr id="2" name="Slide Image Placeholder 1"/>
+          <p:cNvSpPr>
+            <a:spLocks noGrp="1"/>
+          </p:cNvSpPr>
+          <p:nvPr>
+            <p:ph type="sldImg" idx="2"/>
+          </p:nvPr>
+        </p:nvSpPr>
+        <p:spPr/>
+      </p:sp>
+      <p:sp>
+        <p:nvSpPr>
+          <p:cNvPr id="3" name="Notes Placeholder 2"/>
+          <p:cNvSpPr>
+            <a:spLocks noGrp="1"/>
+          </p:cNvSpPr>
+          <p:nvPr>
+            <p:ph type="body" idx="3" sz="quarter"/>
+          </p:nvPr>
+        </p:nvSpPr>
+        <p:spPr/>
+        <p:txBody>
+          <a:bodyPr/>
+          <a:lstStyle/>
+          <a:p>
+            <a:r>
+              <a:t>[5:50 PM to 5:55 PM  ~5 min]</a:t>
+            </a:r>
+          </a:p>
+          <a:p/>
+          <a:p>
+            <a:r>
+              <a:t>Here is your job. You have just taken over support at Cobalt, a B2B analytics platform.</a:t>
+            </a:r>
+          </a:p>
+          <a:p>
+            <a:r>
+              <a:t>Five thousand tickets a week, three people to answer them. About forty percent are variations of the same handful of questions. And here is the part that actually costs money: your agents spend the first few minutes of every single ticket just working out what it is about and who should own it. That is the waste we are attacking.</a:t>
+            </a:r>
+          </a:p>
+          <a:p>
+            <a:r>
+              <a:t>Now the constraint, and it is the realistic one. Nobody at Cobalt has ever labelled a ticket. There is no training set. There is no budget for one this quarter. Hold onto that, because it rules out the textbook answer.</a:t>
+            </a:r>
+          </a:p>
+          <a:p>
+            <a:r>
+              <a:t>Tonight we build the half of the product that reads the inbox. Thursday we make it act. And everything tonight works on any pile of text: tickets, reviews, resumes, survey answers, sales call notes.</a:t>
+            </a:r>
+          </a:p>
+        </p:txBody>
+      </p:sp>
+      <p:sp>
+        <p:nvSpPr>
+          <p:cNvPr id="4" name="Slide Number Placeholder 3"/>
+          <p:cNvSpPr>
+            <a:spLocks noGrp="1"/>
+          </p:cNvSpPr>
+          <p:nvPr>
+            <p:ph type="sldNum" idx="5" sz="quarter"/>
+          </p:nvPr>
+        </p:nvSpPr>
+        <p:spPr/>
+      </p:sp>
+    </p:spTree>
+  </p:cSld>
+  <p:clrMapOvr>
+    <a:masterClrMapping/>
+  </p:clrMapOvr>
+</p:notes>
+</file>
+
+<file path=ppt/notesSlides/notesSlide4.xml><?xml version="1.0" encoding="utf-8"?>
+<p:notes xmlns:a="http://schemas.openxmlformats.org/drawingml/2006/main" xmlns:p="http://schemas.openxmlformats.org/presentationml/2006/main" xmlns:r="http://schemas.openxmlformats.org/officeDocument/2006/relationships">
+  <p:cSld>
+    <p:spTree>
+      <p:nvGrpSpPr>
+        <p:cNvPr id="1" name=""/>
+        <p:cNvGrpSpPr/>
+        <p:nvPr/>
+      </p:nvGrpSpPr>
+      <p:grpSpPr>
+        <a:xfrm>
+          <a:off x="0" y="0"/>
+          <a:ext cx="0" cy="0"/>
+          <a:chOff x="0" y="0"/>
+          <a:chExt cx="0" cy="0"/>
+        </a:xfrm>
+      </p:grpSpPr>
+      <p:sp>
+        <p:nvSpPr>
+          <p:cNvPr id="2" name="Slide Image Placeholder 1"/>
+          <p:cNvSpPr>
+            <a:spLocks noGrp="1"/>
+          </p:cNvSpPr>
+          <p:nvPr>
+            <p:ph type="sldImg" idx="2"/>
+          </p:nvPr>
+        </p:nvSpPr>
+        <p:spPr/>
+      </p:sp>
+      <p:sp>
+        <p:nvSpPr>
+          <p:cNvPr id="3" name="Notes Placeholder 2"/>
+          <p:cNvSpPr>
+            <a:spLocks noGrp="1"/>
+          </p:cNvSpPr>
+          <p:nvPr>
+            <p:ph type="body" idx="3" sz="quarter"/>
+          </p:nvPr>
+        </p:nvSpPr>
+        <p:spPr/>
+        <p:txBody>
+          <a:bodyPr/>
+          <a:lstStyle/>
+          <a:p>
+            <a:r>
+              <a:t>[5:55 PM to 5:58 PM  ~3 min]</a:t>
+            </a:r>
+          </a:p>
+          <a:p/>
+          <a:p>
+            <a:r>
+              <a:t>Four capabilities, built in order.</a:t>
+            </a:r>
+          </a:p>
+          <a:p>
+            <a:r>
+              <a:t>Represent: turn each ticket into numbers, because a model cannot read.</a:t>
+            </a:r>
+          </a:p>
+          <a:p>
+            <a:r>
+              <a:t>Retrieve: find tickets by meaning instead of by keyword.</a:t>
+            </a:r>
+          </a:p>
+          <a:p>
+            <a:r>
+              <a:t>Route: sort the inbox into buckets with zero labelled data.</a:t>
+            </a:r>
+          </a:p>
+          <a:p>
+            <a:r>
+              <a:t>Decide: work out which decisions the system is allowed to make on its own.</a:t>
+            </a:r>
+          </a:p>
+          <a:p>
+            <a:r>
+              <a:t>Each one is useful by itself. You could stop after step two and have shipped something your support team would thank you for. Together they are a product.</a:t>
+            </a:r>
+          </a:p>
+          <a:p>
+            <a:r>
+              <a:t>Watch the numbered strip in the top right corner. It tells you which rung we are standing on.</a:t>
+            </a:r>
+          </a:p>
+        </p:txBody>
+      </p:sp>
+      <p:sp>
+        <p:nvSpPr>
+          <p:cNvPr id="4" name="Slide Number Placeholder 3"/>
+          <p:cNvSpPr>
+            <a:spLocks noGrp="1"/>
+          </p:cNvSpPr>
+          <p:nvPr>
+            <p:ph type="sldNum" idx="5" sz="quarter"/>
+          </p:nvPr>
+        </p:nvSpPr>
+        <p:spPr/>
+      </p:sp>
+    </p:spTree>
+  </p:cSld>
+  <p:clrMapOvr>
+    <a:masterClrMapping/>
+  </p:clrMapOvr>
+</p:notes>
+</file>
+
+<file path=ppt/notesSlides/notesSlide5.xml><?xml version="1.0" encoding="utf-8"?>
+<p:notes xmlns:a="http://schemas.openxmlformats.org/drawingml/2006/main" xmlns:p="http://schemas.openxmlformats.org/presentationml/2006/main" xmlns:r="http://schemas.openxmlformats.org/officeDocument/2006/relationships">
+  <p:cSld>
+    <p:spTree>
+      <p:nvGrpSpPr>
+        <p:cNvPr id="1" name=""/>
+        <p:cNvGrpSpPr/>
+        <p:nvPr/>
+      </p:nvGrpSpPr>
+      <p:grpSpPr>
+        <a:xfrm>
+          <a:off x="0" y="0"/>
+          <a:ext cx="0" cy="0"/>
+          <a:chOff x="0" y="0"/>
+          <a:chExt cx="0" cy="0"/>
+        </a:xfrm>
+      </p:grpSpPr>
+      <p:sp>
+        <p:nvSpPr>
+          <p:cNvPr id="2" name="Slide Image Placeholder 1"/>
+          <p:cNvSpPr>
+            <a:spLocks noGrp="1"/>
+          </p:cNvSpPr>
+          <p:nvPr>
+            <p:ph type="sldImg" idx="2"/>
+          </p:nvPr>
+        </p:nvSpPr>
+        <p:spPr/>
+      </p:sp>
+      <p:sp>
+        <p:nvSpPr>
+          <p:cNvPr id="3" name="Notes Placeholder 2"/>
+          <p:cNvSpPr>
+            <a:spLocks noGrp="1"/>
+          </p:cNvSpPr>
+          <p:nvPr>
+            <p:ph type="body" idx="3" sz="quarter"/>
+          </p:nvPr>
+        </p:nvSpPr>
+        <p:spPr/>
+        <p:txBody>
+          <a:bodyPr/>
+          <a:lstStyle/>
+          <a:p>
+            <a:r>
+              <a:t>[5:58 PM to 6:02 PM  ~4 min]</a:t>
+            </a:r>
+          </a:p>
+          <a:p>
+            <a:r>
+              <a:t>TO THE NOTEBOOK: Under the hood: "text to tokens to ids"</a:t>
+            </a:r>
+          </a:p>
+          <a:p/>
+          <a:p>
+            <a:r>
+              <a:t>Step one, and it starts with the least glamorous fact in machine learning: a model cannot read. It does arithmetic. So the first job is turning text into numbers.</a:t>
+            </a:r>
+          </a:p>
+          <a:p>
+            <a:r>
+              <a:t>Watch what happens to this sentence. The model does not see words. It sees tokens, which are chunks from a fixed vocabulary of about thirty thousand pieces. "Our", "connector" and "failed" survive whole because they are common. But "Postgres" gets broken into "post", "gre", "s". Three fragments.</a:t>
+            </a:r>
+          </a:p>
+          <a:p>
+            <a:r>
+              <a:t>Why? Because Postgres was not common enough to earn its own slot in the vocabulary, so the model spells it out from pieces. That is how a fixed vocabulary can represent any word you throw at it, including words that were invented after the model was trained.</a:t>
+            </a:r>
+          </a:p>
+        </p:txBody>
+      </p:sp>
+      <p:sp>
+        <p:nvSpPr>
+          <p:cNvPr id="4" name="Slide Number Placeholder 3"/>
+          <p:cNvSpPr>
+            <a:spLocks noGrp="1"/>
+          </p:cNvSpPr>
+          <p:nvPr>
+            <p:ph type="sldNum" idx="5" sz="quarter"/>
+          </p:nvPr>
+        </p:nvSpPr>
+        <p:spPr/>
+      </p:sp>
+    </p:spTree>
+  </p:cSld>
+  <p:clrMapOvr>
+    <a:masterClrMapping/>
+  </p:clrMapOvr>
+</p:notes>
+</file>
+
+<file path=ppt/notesSlides/notesSlide6.xml><?xml version="1.0" encoding="utf-8"?>
+<p:notes xmlns:a="http://schemas.openxmlformats.org/drawingml/2006/main" xmlns:p="http://schemas.openxmlformats.org/presentationml/2006/main" xmlns:r="http://schemas.openxmlformats.org/officeDocument/2006/relationships">
+  <p:cSld>
+    <p:spTree>
+      <p:nvGrpSpPr>
+        <p:cNvPr id="1" name=""/>
+        <p:cNvGrpSpPr/>
+        <p:nvPr/>
+      </p:nvGrpSpPr>
+      <p:grpSpPr>
+        <a:xfrm>
+          <a:off x="0" y="0"/>
+          <a:ext cx="0" cy="0"/>
+          <a:chOff x="0" y="0"/>
+          <a:chExt cx="0" cy="0"/>
+        </a:xfrm>
+      </p:grpSpPr>
+      <p:sp>
+        <p:nvSpPr>
+          <p:cNvPr id="2" name="Slide Image Placeholder 1"/>
+          <p:cNvSpPr>
+            <a:spLocks noGrp="1"/>
+          </p:cNvSpPr>
+          <p:nvPr>
+            <p:ph type="sldImg" idx="2"/>
+          </p:nvPr>
+        </p:nvSpPr>
+        <p:spPr/>
+      </p:sp>
+      <p:sp>
+        <p:nvSpPr>
+          <p:cNvPr id="3" name="Notes Placeholder 2"/>
+          <p:cNvSpPr>
+            <a:spLocks noGrp="1"/>
+          </p:cNvSpPr>
+          <p:nvPr>
+            <p:ph type="body" idx="3" sz="quarter"/>
+          </p:nvPr>
+        </p:nvSpPr>
+        <p:spPr/>
+        <p:txBody>
+          <a:bodyPr/>
+          <a:lstStyle/>
+          <a:p>
+            <a:r>
+              <a:t>[6:02 PM to 6:06 PM  ~4 min]</a:t>
+            </a:r>
+          </a:p>
+          <a:p>
+            <a:r>
+              <a:t>TO THE NOTEBOOK: Under the hood: "does your vocabulary survive?"</a:t>
+            </a:r>
+          </a:p>
+          <a:p/>
+          <a:p>
+            <a:r>
+              <a:t>Now here is why you should care, and this is the first genuinely useful thing you can take to work.</a:t>
+            </a:r>
+          </a:p>
+          <a:p>
+            <a:r>
+              <a:t>Let me run your product vocabulary through that same tokenizer. Okta becomes "ok" plus "ta". SAML becomes "sam" plus "l". Webhook becomes three pieces. Kubernetes shatters into four.</a:t>
+            </a:r>
+          </a:p>
+          <a:p>
+            <a:r>
+              <a:t>Look at what just happened. The model has never seen your industry's words. It is sounding them out phonetically, like somebody reading a foreign name off a page. Snowflake is not a data warehouse to this model. It is snow, plus fl, plus ake.</a:t>
+            </a:r>
+          </a:p>
+          <a:p>
+            <a:r>
+              <a:t>So when a vendor tells you semantic search will work beautifully on your data, this is the two minute test that tells you whether they are right. It degrades exactly where your business is most specific: product names, error codes, part numbers, drug names, legal citations. Run the tokenizer first.</a:t>
+            </a:r>
+          </a:p>
+        </p:txBody>
+      </p:sp>
+      <p:sp>
+        <p:nvSpPr>
+          <p:cNvPr id="4" name="Slide Number Placeholder 3"/>
+          <p:cNvSpPr>
+            <a:spLocks noGrp="1"/>
+          </p:cNvSpPr>
+          <p:nvPr>
+            <p:ph type="sldNum" idx="5" sz="quarter"/>
+          </p:nvPr>
+        </p:nvSpPr>
+        <p:spPr/>
+      </p:sp>
+    </p:spTree>
+  </p:cSld>
+  <p:clrMapOvr>
+    <a:masterClrMapping/>
+  </p:clrMapOvr>
+</p:notes>
+</file>
+
+<file path=ppt/notesSlides/notesSlide7.xml><?xml version="1.0" encoding="utf-8"?>
+<p:notes xmlns:a="http://schemas.openxmlformats.org/drawingml/2006/main" xmlns:p="http://schemas.openxmlformats.org/presentationml/2006/main" xmlns:r="http://schemas.openxmlformats.org/officeDocument/2006/relationships">
+  <p:cSld>
+    <p:spTree>
+      <p:nvGrpSpPr>
+        <p:cNvPr id="1" name=""/>
+        <p:cNvGrpSpPr/>
+        <p:nvPr/>
+      </p:nvGrpSpPr>
+      <p:grpSpPr>
+        <a:xfrm>
+          <a:off x="0" y="0"/>
+          <a:ext cx="0" cy="0"/>
+          <a:chOff x="0" y="0"/>
+          <a:chExt cx="0" cy="0"/>
+        </a:xfrm>
+      </p:grpSpPr>
+      <p:sp>
+        <p:nvSpPr>
+          <p:cNvPr id="2" name="Slide Image Placeholder 1"/>
+          <p:cNvSpPr>
+            <a:spLocks noGrp="1"/>
+          </p:cNvSpPr>
+          <p:nvPr>
+            <p:ph type="sldImg" idx="2"/>
+          </p:nvPr>
+        </p:nvSpPr>
+        <p:spPr/>
+      </p:sp>
+      <p:sp>
+        <p:nvSpPr>
+          <p:cNvPr id="3" name="Notes Placeholder 2"/>
+          <p:cNvSpPr>
+            <a:spLocks noGrp="1"/>
+          </p:cNvSpPr>
+          <p:nvPr>
+            <p:ph type="body" idx="3" sz="quarter"/>
+          </p:nvPr>
+        </p:nvSpPr>
+        <p:spPr/>
+        <p:txBody>
+          <a:bodyPr/>
+          <a:lstStyle/>
+          <a:p>
+            <a:r>
+              <a:t>[6:06 PM to 6:11 PM  ~5 min]</a:t>
+            </a:r>
+          </a:p>
+          <a:p>
+            <a:r>
+              <a:t>TO THE NOTEBOOK: Under the hood: "from tokens to ONE vector"</a:t>
+            </a:r>
+          </a:p>
+          <a:p/>
+          <a:p>
+            <a:r>
+              <a:t>Tokens become vectors, one per token. But we need one vector per ticket, not one per token. So how do we get from twelve token vectors down to one?</a:t>
+            </a:r>
+          </a:p>
+          <a:p>
+            <a:r>
+              <a:t>We average them. That is genuinely it. Add them up, divide by how many there are, scale the result to length one.</a:t>
+            </a:r>
+          </a:p>
+          <a:p>
+            <a:r>
+              <a:t>When we do that by hand in the notebook and compare it to the library's one-line function, the difference is exactly zero. Not approximately zero. Zero. It is the same arithmetic, just written out.</a:t>
+            </a:r>
+          </a:p>
+          <a:p>
+            <a:r>
+              <a:t>And notice the weakness that exposes. A ticket's vector is an average. If a customer writes three unrelated complaints in one ticket, all three blend into a single mushy point that is not really about any of them. That is why long documents get chopped into chunks before you embed them, and it is going to matter a great deal when we get to retrieval next week.</a:t>
+            </a:r>
+          </a:p>
+        </p:txBody>
+      </p:sp>
+      <p:sp>
+        <p:nvSpPr>
+          <p:cNvPr id="4" name="Slide Number Placeholder 3"/>
+          <p:cNvSpPr>
+            <a:spLocks noGrp="1"/>
+          </p:cNvSpPr>
+          <p:nvPr>
+            <p:ph type="sldNum" idx="5" sz="quarter"/>
+          </p:nvPr>
+        </p:nvSpPr>
+        <p:spPr/>
+      </p:sp>
+    </p:spTree>
+  </p:cSld>
+  <p:clrMapOvr>
+    <a:masterClrMapping/>
+  </p:clrMapOvr>
+</p:notes>
+</file>
+
+<file path=ppt/notesSlides/notesSlide8.xml><?xml version="1.0" encoding="utf-8"?>
+<p:notes xmlns:a="http://schemas.openxmlformats.org/drawingml/2006/main" xmlns:p="http://schemas.openxmlformats.org/presentationml/2006/main" xmlns:r="http://schemas.openxmlformats.org/officeDocument/2006/relationships">
+  <p:cSld>
+    <p:spTree>
+      <p:nvGrpSpPr>
+        <p:cNvPr id="1" name=""/>
+        <p:cNvGrpSpPr/>
+        <p:nvPr/>
+      </p:nvGrpSpPr>
+      <p:grpSpPr>
+        <a:xfrm>
+          <a:off x="0" y="0"/>
+          <a:ext cx="0" cy="0"/>
+          <a:chOff x="0" y="0"/>
+          <a:chExt cx="0" cy="0"/>
+        </a:xfrm>
+      </p:grpSpPr>
+      <p:sp>
+        <p:nvSpPr>
+          <p:cNvPr id="2" name="Slide Image Placeholder 1"/>
+          <p:cNvSpPr>
+            <a:spLocks noGrp="1"/>
+          </p:cNvSpPr>
+          <p:nvPr>
+            <p:ph type="sldImg" idx="2"/>
+          </p:nvPr>
+        </p:nvSpPr>
+        <p:spPr/>
+      </p:sp>
+      <p:sp>
+        <p:nvSpPr>
+          <p:cNvPr id="3" name="Notes Placeholder 2"/>
+          <p:cNvSpPr>
+            <a:spLocks noGrp="1"/>
+          </p:cNvSpPr>
+          <p:nvPr>
+            <p:ph type="body" idx="3" sz="quarter"/>
+          </p:nvPr>
+        </p:nvSpPr>
+        <p:spPr/>
+        <p:txBody>
+          <a:bodyPr/>
+          <a:lstStyle/>
+          <a:p>
+            <a:r>
+              <a:t>[6:11 PM to 6:14 PM  ~3 min]</a:t>
+            </a:r>
+          </a:p>
+          <a:p>
+            <a:r>
+              <a:t>TO THE NOTEBOOK: Under the hood: "similarity is just multiplication"</a:t>
+            </a:r>
+          </a:p>
+          <a:p/>
+          <a:p>
+            <a:r>
+              <a:t>So every ticket is now a point in space. How do we measure whether two tickets are about the same thing? We multiply and add.</a:t>
+            </a:r>
+          </a:p>
+          <a:p>
+            <a:r>
+              <a:t>Because every vector was scaled to length one, similarity is just the dot product: multiply the matching numbers, sum them up. "I can't log in" and "password reset failed" score zero point six two. "I can't log in" and "please add dark mode" score zero point zero nine.</a:t>
+            </a:r>
+          </a:p>
+          <a:p>
+            <a:r>
+              <a:t>That number is the entire search engine. No keywords, no rules, no if-statements, no training. One multiplication.</a:t>
+            </a:r>
+          </a:p>
+        </p:txBody>
+      </p:sp>
+      <p:sp>
+        <p:nvSpPr>
+          <p:cNvPr id="4" name="Slide Number Placeholder 3"/>
+          <p:cNvSpPr>
+            <a:spLocks noGrp="1"/>
+          </p:cNvSpPr>
+          <p:nvPr>
+            <p:ph type="sldNum" idx="5" sz="quarter"/>
+          </p:nvPr>
+        </p:nvSpPr>
+        <p:spPr/>
+      </p:sp>
+    </p:spTree>
+  </p:cSld>
+  <p:clrMapOvr>
+    <a:masterClrMapping/>
+  </p:clrMapOvr>
+</p:notes>
+</file>
+
+<file path=ppt/notesSlides/notesSlide9.xml><?xml version="1.0" encoding="utf-8"?>
+<p:notes xmlns:a="http://schemas.openxmlformats.org/drawingml/2006/main" xmlns:p="http://schemas.openxmlformats.org/presentationml/2006/main" xmlns:r="http://schemas.openxmlformats.org/officeDocument/2006/relationships">
+  <p:cSld>
+    <p:spTree>
+      <p:nvGrpSpPr>
+        <p:cNvPr id="1" name=""/>
+        <p:cNvGrpSpPr/>
+        <p:nvPr/>
+      </p:nvGrpSpPr>
+      <p:grpSpPr>
+        <a:xfrm>
+          <a:off x="0" y="0"/>
+          <a:ext cx="0" cy="0"/>
+          <a:chOff x="0" y="0"/>
+          <a:chExt cx="0" cy="0"/>
+        </a:xfrm>
+      </p:grpSpPr>
+      <p:sp>
+        <p:nvSpPr>
+          <p:cNvPr id="2" name="Slide Image Placeholder 1"/>
+          <p:cNvSpPr>
+            <a:spLocks noGrp="1"/>
+          </p:cNvSpPr>
+          <p:nvPr>
+            <p:ph type="sldImg" idx="2"/>
+          </p:nvPr>
+        </p:nvSpPr>
+        <p:spPr/>
+      </p:sp>
+      <p:sp>
+        <p:nvSpPr>
+          <p:cNvPr id="3" name="Notes Placeholder 2"/>
+          <p:cNvSpPr>
+            <a:spLocks noGrp="1"/>
+          </p:cNvSpPr>
+          <p:nvPr>
+            <p:ph type="body" idx="3" sz="quarter"/>
+          </p:nvPr>
+        </p:nvSpPr>
+        <p:spPr/>
+        <p:txBody>
+          <a:bodyPr/>
+          <a:lstStyle/>
+          <a:p>
+            <a:r>
+              <a:t>[6:14 PM to 6:19 PM  ~5 min]</a:t>
+            </a:r>
+          </a:p>
+          <a:p>
+            <a:r>
+              <a:t>TO THE NOTEBOOK: Act 1: "Teach the computer to read"</a:t>
+            </a:r>
+          </a:p>
+          <a:p/>
+          <a:p>
+            <a:r>
+              <a:t>Let me show you why that matters.</a:t>
+            </a:r>
+          </a:p>
+          <a:p>
+            <a:r>
+              <a:t>I am going to search the inbox for "we are being charged wrong". First, keyword search. Zero results. Not one ticket contains that phrase, because real customers do not write the phrase you happened to think of.</a:t>
+            </a:r>
+          </a:p>
+          <a:p>
+            <a:r>
+              <a:t>Now semantic search, same query. Back come "we got charged for a trial I understood to be free", "invoice does not match the amount that hit our card", "we were charged twice this month for the same seats". None of those contain the words I typed. Meaning matched. Spelling did not.</a:t>
+            </a:r>
+          </a:p>
+          <a:p>
+            <a:r>
+              <a:t>This is a feature you have used a hundred times without thinking about it. Every help centre search that actually works, every "related tickets" sidebar, every internal wiki that finds the right document. It is this.</a:t>
+            </a:r>
+          </a:p>
+        </p:txBody>
+      </p:sp>
+      <p:sp>
+        <p:nvSpPr>
+          <p:cNvPr id="4" name="Slide Number Placeholder 3"/>
+          <p:cNvSpPr>
+            <a:spLocks noGrp="1"/>
+          </p:cNvSpPr>
+          <p:nvPr>
+            <p:ph type="sldNum" idx="5" sz="quarter"/>
+          </p:nvPr>
+        </p:nvSpPr>
+        <p:spPr/>
+      </p:sp>
+    </p:spTree>
+  </p:cSld>
+  <p:clrMapOvr>
+    <a:masterClrMapping/>
+  </p:clrMapOvr>
+</p:notes>
 </file>
 
 <file path=ppt/slideLayouts/slideLayout1.xml><?xml version="1.0" encoding="utf-8"?>
@@ -15195,4 +17662,324 @@
   </a:objectDefaults>
   <a:extraClrSchemeLst/>
 </a:theme>
+</file>
+
+<file path=ppt/theme/theme2.xml><?xml version="1.0" encoding="utf-8"?>
+<a:theme xmlns:a="http://schemas.openxmlformats.org/drawingml/2006/main" name="Office Theme">
+  <a:themeElements>
+    <a:clrScheme name="Office">
+      <a:dk1>
+        <a:sysClr val="windowText" lastClr="000000"/>
+      </a:dk1>
+      <a:lt1>
+        <a:sysClr val="window" lastClr="FFFFFF"/>
+      </a:lt1>
+      <a:dk2>
+        <a:srgbClr val="1F497D"/>
+      </a:dk2>
+      <a:lt2>
+        <a:srgbClr val="EEECE1"/>
+      </a:lt2>
+      <a:accent1>
+        <a:srgbClr val="4F81BD"/>
+      </a:accent1>
+      <a:accent2>
+        <a:srgbClr val="C0504D"/>
+      </a:accent2>
+      <a:accent3>
+        <a:srgbClr val="9BBB59"/>
+      </a:accent3>
+      <a:accent4>
+        <a:srgbClr val="8064A2"/>
+      </a:accent4>
+      <a:accent5>
+        <a:srgbClr val="4BACC6"/>
+      </a:accent5>
+      <a:accent6>
+        <a:srgbClr val="F79646"/>
+      </a:accent6>
+      <a:hlink>
+        <a:srgbClr val="0000FF"/>
+      </a:hlink>
+      <a:folHlink>
+        <a:srgbClr val="800080"/>
+      </a:folHlink>
+    </a:clrScheme>
+    <a:fontScheme name="Office">
+      <a:majorFont>
+        <a:latin typeface="Calibri"/>
+        <a:ea typeface=""/>
+        <a:cs typeface=""/>
+        <a:font script="Jpan" typeface="ＭＳ Ｐゴシック"/>
+        <a:font script="Hang" typeface="맑은 고딕"/>
+        <a:font script="Hans" typeface="宋体"/>
+        <a:font script="Hant" typeface="新細明體"/>
+        <a:font script="Arab" typeface="Times New Roman"/>
+        <a:font script="Hebr" typeface="Times New Roman"/>
+        <a:font script="Thai" typeface="Angsana New"/>
+        <a:font script="Ethi" typeface="Nyala"/>
+        <a:font script="Beng" typeface="Vrinda"/>
+        <a:font script="Gujr" typeface="Shruti"/>
+        <a:font script="Khmr" typeface="MoolBoran"/>
+        <a:font script="Knda" typeface="Tunga"/>
+        <a:font script="Guru" typeface="Raavi"/>
+        <a:font script="Cans" typeface="Euphemia"/>
+        <a:font script="Cher" typeface="Plantagenet Cherokee"/>
+        <a:font script="Yiii" typeface="Microsoft Yi Baiti"/>
+        <a:font script="Tibt" typeface="Microsoft Himalaya"/>
+        <a:font script="Thaa" typeface="MV Boli"/>
+        <a:font script="Deva" typeface="Mangal"/>
+        <a:font script="Telu" typeface="Gautami"/>
+        <a:font script="Taml" typeface="Latha"/>
+        <a:font script="Syrc" typeface="Estrangelo Edessa"/>
+        <a:font script="Orya" typeface="Kalinga"/>
+        <a:font script="Mlym" typeface="Kartika"/>
+        <a:font script="Laoo" typeface="DokChampa"/>
+        <a:font script="Sinh" typeface="Iskoola Pota"/>
+        <a:font script="Mong" typeface="Mongolian Baiti"/>
+        <a:font script="Viet" typeface="Times New Roman"/>
+        <a:font script="Uigh" typeface="Microsoft Uighur"/>
+        <a:font script="Geor" typeface="Sylfaen"/>
+      </a:majorFont>
+      <a:minorFont>
+        <a:latin typeface="Calibri"/>
+        <a:ea typeface=""/>
+        <a:cs typeface=""/>
+        <a:font script="Jpan" typeface="ＭＳ Ｐゴシック"/>
+        <a:font script="Hang" typeface="맑은 고딕"/>
+        <a:font script="Hans" typeface="宋体"/>
+        <a:font script="Hant" typeface="新細明體"/>
+        <a:font script="Arab" typeface="Arial"/>
+        <a:font script="Hebr" typeface="Arial"/>
+        <a:font script="Thai" typeface="Cordia New"/>
+        <a:font script="Ethi" typeface="Nyala"/>
+        <a:font script="Beng" typeface="Vrinda"/>
+        <a:font script="Gujr" typeface="Shruti"/>
+        <a:font script="Khmr" typeface="DaunPenh"/>
+        <a:font script="Knda" typeface="Tunga"/>
+        <a:font script="Guru" typeface="Raavi"/>
+        <a:font script="Cans" typeface="Euphemia"/>
+        <a:font script="Cher" typeface="Plantagenet Cherokee"/>
+        <a:font script="Yiii" typeface="Microsoft Yi Baiti"/>
+        <a:font script="Tibt" typeface="Microsoft Himalaya"/>
+        <a:font script="Thaa" typeface="MV Boli"/>
+        <a:font script="Deva" typeface="Mangal"/>
+        <a:font script="Telu" typeface="Gautami"/>
+        <a:font script="Taml" typeface="Latha"/>
+        <a:font script="Syrc" typeface="Estrangelo Edessa"/>
+        <a:font script="Orya" typeface="Kalinga"/>
+        <a:font script="Mlym" typeface="Kartika"/>
+        <a:font script="Laoo" typeface="DokChampa"/>
+        <a:font script="Sinh" typeface="Iskoola Pota"/>
+        <a:font script="Mong" typeface="Mongolian Baiti"/>
+        <a:font script="Viet" typeface="Arial"/>
+        <a:font script="Uigh" typeface="Microsoft Uighur"/>
+        <a:font script="Geor" typeface="Sylfaen"/>
+      </a:minorFont>
+    </a:fontScheme>
+    <a:fmtScheme name="Office">
+      <a:fillStyleLst>
+        <a:solidFill>
+          <a:schemeClr val="phClr"/>
+        </a:solidFill>
+        <a:gradFill rotWithShape="1">
+          <a:gsLst>
+            <a:gs pos="0">
+              <a:schemeClr val="phClr">
+                <a:tint val="50000"/>
+                <a:satMod val="300000"/>
+              </a:schemeClr>
+            </a:gs>
+            <a:gs pos="35000">
+              <a:schemeClr val="phClr">
+                <a:tint val="37000"/>
+                <a:satMod val="300000"/>
+              </a:schemeClr>
+            </a:gs>
+            <a:gs pos="100000">
+              <a:schemeClr val="phClr">
+                <a:tint val="15000"/>
+                <a:satMod val="350000"/>
+              </a:schemeClr>
+            </a:gs>
+          </a:gsLst>
+          <a:lin ang="16200000" scaled="1"/>
+        </a:gradFill>
+        <a:gradFill rotWithShape="1">
+          <a:gsLst>
+            <a:gs pos="0">
+              <a:schemeClr val="phClr">
+                <a:tint val="100000"/>
+                <a:shade val="100000"/>
+                <a:satMod val="130000"/>
+              </a:schemeClr>
+            </a:gs>
+            <a:gs pos="100000">
+              <a:schemeClr val="phClr">
+                <a:tint val="50000"/>
+                <a:shade val="100000"/>
+                <a:satMod val="350000"/>
+              </a:schemeClr>
+            </a:gs>
+          </a:gsLst>
+          <a:lin ang="16200000" scaled="0"/>
+        </a:gradFill>
+      </a:fillStyleLst>
+      <a:lnStyleLst>
+        <a:ln w="9525" cap="flat" cmpd="sng" algn="ctr">
+          <a:solidFill>
+            <a:schemeClr val="phClr">
+              <a:shade val="95000"/>
+              <a:satMod val="105000"/>
+            </a:schemeClr>
+          </a:solidFill>
+          <a:prstDash val="solid"/>
+        </a:ln>
+        <a:ln w="25400" cap="flat" cmpd="sng" algn="ctr">
+          <a:solidFill>
+            <a:schemeClr val="phClr"/>
+          </a:solidFill>
+          <a:prstDash val="solid"/>
+        </a:ln>
+        <a:ln w="38100" cap="flat" cmpd="sng" algn="ctr">
+          <a:solidFill>
+            <a:schemeClr val="phClr"/>
+          </a:solidFill>
+          <a:prstDash val="solid"/>
+        </a:ln>
+      </a:lnStyleLst>
+      <a:effectStyleLst>
+        <a:effectStyle>
+          <a:effectLst>
+            <a:outerShdw blurRad="40000" dist="20000" dir="5400000" rotWithShape="0">
+              <a:srgbClr val="000000">
+                <a:alpha val="38000"/>
+              </a:srgbClr>
+            </a:outerShdw>
+          </a:effectLst>
+        </a:effectStyle>
+        <a:effectStyle>
+          <a:effectLst>
+            <a:outerShdw blurRad="40000" dist="23000" dir="5400000" rotWithShape="0">
+              <a:srgbClr val="000000">
+                <a:alpha val="35000"/>
+              </a:srgbClr>
+            </a:outerShdw>
+          </a:effectLst>
+        </a:effectStyle>
+        <a:effectStyle>
+          <a:effectLst>
+            <a:outerShdw blurRad="40000" dist="23000" dir="5400000" rotWithShape="0">
+              <a:srgbClr val="000000">
+                <a:alpha val="35000"/>
+              </a:srgbClr>
+            </a:outerShdw>
+          </a:effectLst>
+          <a:scene3d>
+            <a:camera prst="orthographicFront">
+              <a:rot lat="0" lon="0" rev="0"/>
+            </a:camera>
+            <a:lightRig rig="threePt" dir="t">
+              <a:rot lat="0" lon="0" rev="1200000"/>
+            </a:lightRig>
+          </a:scene3d>
+          <a:sp3d>
+            <a:bevelT w="63500" h="25400"/>
+          </a:sp3d>
+        </a:effectStyle>
+      </a:effectStyleLst>
+      <a:bgFillStyleLst>
+        <a:solidFill>
+          <a:schemeClr val="phClr"/>
+        </a:solidFill>
+        <a:gradFill rotWithShape="1">
+          <a:gsLst>
+            <a:gs pos="0">
+              <a:schemeClr val="phClr">
+                <a:tint val="40000"/>
+                <a:satMod val="350000"/>
+              </a:schemeClr>
+            </a:gs>
+            <a:gs pos="40000">
+              <a:schemeClr val="phClr">
+                <a:tint val="45000"/>
+                <a:shade val="99000"/>
+                <a:satMod val="350000"/>
+              </a:schemeClr>
+            </a:gs>
+            <a:gs pos="100000">
+              <a:schemeClr val="phClr">
+                <a:shade val="20000"/>
+                <a:satMod val="255000"/>
+              </a:schemeClr>
+            </a:gs>
+          </a:gsLst>
+          <a:path path="circle">
+            <a:fillToRect l="50000" t="-80000" r="50000" b="180000"/>
+          </a:path>
+        </a:gradFill>
+        <a:gradFill rotWithShape="1">
+          <a:gsLst>
+            <a:gs pos="0">
+              <a:schemeClr val="phClr">
+                <a:tint val="80000"/>
+                <a:satMod val="300000"/>
+              </a:schemeClr>
+            </a:gs>
+            <a:gs pos="100000">
+              <a:schemeClr val="phClr">
+                <a:shade val="30000"/>
+                <a:satMod val="200000"/>
+              </a:schemeClr>
+            </a:gs>
+          </a:gsLst>
+          <a:path path="circle">
+            <a:fillToRect l="50000" t="50000" r="50000" b="50000"/>
+          </a:path>
+        </a:gradFill>
+      </a:bgFillStyleLst>
+    </a:fmtScheme>
+  </a:themeElements>
+  <a:objectDefaults>
+    <a:spDef>
+      <a:spPr/>
+      <a:bodyPr/>
+      <a:lstStyle/>
+      <a:style>
+        <a:lnRef idx="1">
+          <a:schemeClr val="accent1"/>
+        </a:lnRef>
+        <a:fillRef idx="3">
+          <a:schemeClr val="accent1"/>
+        </a:fillRef>
+        <a:effectRef idx="2">
+          <a:schemeClr val="accent1"/>
+        </a:effectRef>
+        <a:fontRef idx="minor">
+          <a:schemeClr val="lt1"/>
+        </a:fontRef>
+      </a:style>
+    </a:spDef>
+    <a:lnDef>
+      <a:spPr/>
+      <a:bodyPr/>
+      <a:lstStyle/>
+      <a:style>
+        <a:lnRef idx="2">
+          <a:schemeClr val="accent1"/>
+        </a:lnRef>
+        <a:fillRef idx="0">
+          <a:schemeClr val="accent1"/>
+        </a:fillRef>
+        <a:effectRef idx="1">
+          <a:schemeClr val="accent1"/>
+        </a:effectRef>
+        <a:fontRef idx="minor">
+          <a:schemeClr val="tx1"/>
+        </a:fontRef>
+      </a:style>
+    </a:lnDef>
+  </a:objectDefaults>
+  <a:extraClrSchemeLst/>
+</a:theme>
 </file>
</xml_diff>

<commit_message>
Week 7: explain the 'no training data' problem in plain language
The brief said 'nobody has ever labelled a ticket', which assumes you already
know what labelled data is. Rewrites the deck slide, the notebook opening and
the speaker script to define training data from scratch: a few thousand examples
a person sorted by hand, which Cobalt has none of and no budget to create.

Co-Authored-By: Claude Opus 4.8 <noreply@anthropic.com>
</commit_message>
<xml_diff>
--- a/Week 7/L13_Support_Copilot.pptx
+++ b/Week 7/L13_Support_Copilot.pptx
@@ -539,7 +539,7 @@
           </a:p>
           <a:p>
             <a:r>
-              <a:t>Here is the situation we are walking into. Five thousand support tickets a week, three agents, and not one labelled example. Most people would tell you that you need to hire a labelling team before AI can help at all. We are going to ship something useful tonight without labelling a single ticket.</a:t>
+              <a:t>Here is the situation we are walking into. Five thousand support tickets a week, three agents, and nothing in that inbox has ever been sorted or tagged by anyone. The standard advice is that you cannot use AI on a pile like that until somebody hand-sorts thousands of examples first. We are going to ship something useful tonight without sorting a single one.</a:t>
             </a:r>
           </a:p>
         </p:txBody>
@@ -1984,17 +1984,27 @@
           </a:p>
           <a:p>
             <a:r>
-              <a:t>Five thousand tickets a week, three people to answer them. About forty percent are variations of the same handful of questions. And here is the part that actually costs money: your agents spend the first few minutes of every single ticket just working out what it is about and who should own it. That is the waste we are attacking.</a:t>
-            </a:r>
-          </a:p>
-          <a:p>
-            <a:r>
-              <a:t>Now the constraint, and it is the realistic one. Nobody at Cobalt has ever labelled a ticket. There is no training set. There is no budget for one this quarter. Hold onto that, because it rules out the textbook answer.</a:t>
-            </a:r>
-          </a:p>
-          <a:p>
-            <a:r>
-              <a:t>Tonight we build the half of the product that reads the inbox. Thursday we make it act. And everything tonight works on any pile of text: tickets, reviews, resumes, survey answers, sales call notes.</a:t>
+              <a:t>Five thousand tickets a week, and three people to answer them. Every ticket is just a paragraph of text that a customer typed in their own words. There is no dropdown they picked from, no category, no tag. Just writing. About forty percent are variations of the same handful of questions, and your three agents spend the first few minutes of every single ticket simply working out what it is about and who should own it. That is the waste we are going after.</a:t>
+            </a:r>
+          </a:p>
+          <a:p>
+            <a:r>
+              <a:t>Now the constraint, and this is the one that makes it interesting. Look at the third box: nothing in this inbox is sorted.</a:t>
+            </a:r>
+          </a:p>
+          <a:p>
+            <a:r>
+              <a:t>Here is why that matters, and if you have never done machine learning this is the sentence to hold onto. The normal way to teach a computer to sort text is to hand it a few thousand examples that a person has already sorted by hand. Somebody sits down, reads ticket one, and writes "billing". Reads ticket two, writes "login problem". A few thousand times. That pile of hand-sorted examples is called training data, and almost everything you have heard about machine learning assumes you have it.</a:t>
+            </a:r>
+          </a:p>
+          <a:p>
+            <a:r>
+              <a:t>Cobalt does not. Building it would mean paying people to read and tag thousands of tickets before you could write a single line of code. That is weeks of work and a budget nobody approved.</a:t>
+            </a:r>
+          </a:p>
+          <a:p>
+            <a:r>
+              <a:t>So the textbook answer is off the table, and that is the whole point of tonight. We are going to build something useful anyway. We start with the half of the product that reads the inbox. Thursday we make it act. And everything we do tonight works on any pile of text you have: tickets, reviews, resumes, survey answers, sales call notes.</a:t>
             </a:r>
           </a:p>
         </p:txBody>
@@ -2085,7 +2095,7 @@
           </a:p>
           <a:p>
             <a:r>
-              <a:t>Route: sort the inbox into buckets with zero labelled data.</a:t>
+              <a:t>Route: sort the inbox into buckets without any of that hand-sorted training data.</a:t>
             </a:r>
           </a:p>
           <a:p>
@@ -13634,7 +13644,7 @@
                 </a:solidFill>
                 <a:latin typeface="Helvetica Neue"/>
               </a:rPr>
-              <a:t>A B2B analytics platform. The inbox is the product problem, and nobody has ever labelled a single ticket.</a:t>
+              <a:t>A B2B analytics platform. Every ticket arrives as a paragraph of text, typed by a customer in their own words.</a:t>
             </a:r>
           </a:p>
         </p:txBody>
@@ -13682,8 +13692,8 @@
         </p:nvSpPr>
         <p:spPr>
           <a:xfrm>
-            <a:off x="685800" y="2377440"/>
-            <a:ext cx="2615184" cy="1371600"/>
+            <a:off x="685800" y="2212848"/>
+            <a:ext cx="2615184" cy="1298448"/>
           </a:xfrm>
           <a:prstGeom prst="roundRect">
             <a:avLst/>
@@ -13727,7 +13737,7 @@
         </p:nvSpPr>
         <p:spPr>
           <a:xfrm>
-            <a:off x="886968" y="2578608"/>
+            <a:off x="886968" y="2395728"/>
             <a:ext cx="2286000" cy="457200"/>
           </a:xfrm>
           <a:prstGeom prst="rect">
@@ -13743,7 +13753,7 @@
           <a:p>
             <a:pPr algn="l"/>
             <a:r>
-              <a:rPr sz="1800" b="1" i="0">
+              <a:rPr sz="1750" b="1" i="0">
                 <a:solidFill>
                   <a:srgbClr val="0F172A"/>
                 </a:solidFill>
@@ -13762,8 +13772,8 @@
         </p:nvSpPr>
         <p:spPr>
           <a:xfrm>
-            <a:off x="886968" y="3063240"/>
-            <a:ext cx="2286000" cy="548640"/>
+            <a:off x="886968" y="2871216"/>
+            <a:ext cx="2304288" cy="548640"/>
           </a:xfrm>
           <a:prstGeom prst="rect">
             <a:avLst/>
@@ -13778,13 +13788,13 @@
           <a:p>
             <a:pPr algn="l"/>
             <a:r>
-              <a:rPr sz="1400" b="0" i="0">
+              <a:rPr sz="1350" b="0" i="0">
                 <a:solidFill>
                   <a:srgbClr val="475569"/>
                 </a:solidFill>
                 <a:latin typeface="Helvetica Neue"/>
               </a:rPr>
-              <a:t>three agents to answer them</a:t>
+              <a:t>and three people to answer them</a:t>
             </a:r>
           </a:p>
         </p:txBody>
@@ -13797,8 +13807,8 @@
         </p:nvSpPr>
         <p:spPr>
           <a:xfrm>
-            <a:off x="3483864" y="2377440"/>
-            <a:ext cx="2615184" cy="1371600"/>
+            <a:off x="3483864" y="2212848"/>
+            <a:ext cx="2615184" cy="1298448"/>
           </a:xfrm>
           <a:prstGeom prst="roundRect">
             <a:avLst/>
@@ -13842,7 +13852,7 @@
         </p:nvSpPr>
         <p:spPr>
           <a:xfrm>
-            <a:off x="3685032" y="2578608"/>
+            <a:off x="3685032" y="2395728"/>
             <a:ext cx="2286000" cy="457200"/>
           </a:xfrm>
           <a:prstGeom prst="rect">
@@ -13858,7 +13868,7 @@
           <a:p>
             <a:pPr algn="l"/>
             <a:r>
-              <a:rPr sz="1800" b="1" i="0">
+              <a:rPr sz="1750" b="1" i="0">
                 <a:solidFill>
                   <a:srgbClr val="0F172A"/>
                 </a:solidFill>
@@ -13877,8 +13887,8 @@
         </p:nvSpPr>
         <p:spPr>
           <a:xfrm>
-            <a:off x="3685032" y="3063240"/>
-            <a:ext cx="2286000" cy="548640"/>
+            <a:off x="3685032" y="2871216"/>
+            <a:ext cx="2304288" cy="548640"/>
           </a:xfrm>
           <a:prstGeom prst="rect">
             <a:avLst/>
@@ -13893,7 +13903,7 @@
           <a:p>
             <a:pPr algn="l"/>
             <a:r>
-              <a:rPr sz="1400" b="0" i="0">
+              <a:rPr sz="1350" b="0" i="0">
                 <a:solidFill>
                   <a:srgbClr val="475569"/>
                 </a:solidFill>
@@ -13912,8 +13922,8 @@
         </p:nvSpPr>
         <p:spPr>
           <a:xfrm>
-            <a:off x="6281928" y="2377440"/>
-            <a:ext cx="2615184" cy="1371600"/>
+            <a:off x="6281928" y="2212848"/>
+            <a:ext cx="2615184" cy="1298448"/>
           </a:xfrm>
           <a:prstGeom prst="roundRect">
             <a:avLst/>
@@ -13957,7 +13967,7 @@
         </p:nvSpPr>
         <p:spPr>
           <a:xfrm>
-            <a:off x="6483096" y="2578608"/>
+            <a:off x="6483096" y="2395728"/>
             <a:ext cx="2286000" cy="457200"/>
           </a:xfrm>
           <a:prstGeom prst="rect">
@@ -13973,13 +13983,13 @@
           <a:p>
             <a:pPr algn="l"/>
             <a:r>
-              <a:rPr sz="1800" b="1" i="0">
+              <a:rPr sz="1750" b="1" i="0">
                 <a:solidFill>
                   <a:srgbClr val="0F172A"/>
                 </a:solidFill>
                 <a:latin typeface="Helvetica Neue"/>
               </a:rPr>
-              <a:t>No labelled data</a:t>
+              <a:t>Nothing is sorted</a:t>
             </a:r>
           </a:p>
         </p:txBody>
@@ -13992,8 +14002,8 @@
         </p:nvSpPr>
         <p:spPr>
           <a:xfrm>
-            <a:off x="6483096" y="3063240"/>
-            <a:ext cx="2286000" cy="548640"/>
+            <a:off x="6483096" y="2871216"/>
+            <a:ext cx="2304288" cy="548640"/>
           </a:xfrm>
           <a:prstGeom prst="rect">
             <a:avLst/>
@@ -14008,13 +14018,13 @@
           <a:p>
             <a:pPr algn="l"/>
             <a:r>
-              <a:rPr sz="1400" b="0" i="0">
+              <a:rPr sz="1350" b="0" i="0">
                 <a:solidFill>
                   <a:srgbClr val="475569"/>
                 </a:solidFill>
                 <a:latin typeface="Helvetica Neue"/>
               </a:rPr>
-              <a:t>and no budget for it this quarter</a:t>
+              <a:t>no tags, no categories, just text</a:t>
             </a:r>
           </a:p>
         </p:txBody>
@@ -14027,8 +14037,8 @@
         </p:nvSpPr>
         <p:spPr>
           <a:xfrm>
-            <a:off x="9079992" y="2377440"/>
-            <a:ext cx="2615184" cy="1371600"/>
+            <a:off x="9079992" y="2212848"/>
+            <a:ext cx="2615184" cy="1298448"/>
           </a:xfrm>
           <a:prstGeom prst="roundRect">
             <a:avLst/>
@@ -14072,7 +14082,7 @@
         </p:nvSpPr>
         <p:spPr>
           <a:xfrm>
-            <a:off x="9281160" y="2578608"/>
+            <a:off x="9281160" y="2395728"/>
             <a:ext cx="2286000" cy="457200"/>
           </a:xfrm>
           <a:prstGeom prst="rect">
@@ -14088,13 +14098,13 @@
           <a:p>
             <a:pPr algn="l"/>
             <a:r>
-              <a:rPr sz="1800" b="1" i="0">
+              <a:rPr sz="1750" b="1" i="0">
                 <a:solidFill>
                   <a:srgbClr val="0F172A"/>
                 </a:solidFill>
                 <a:latin typeface="Helvetica Neue"/>
               </a:rPr>
-              <a:t>Agents burn minutes</a:t>
+              <a:t>Minutes lost per ticket</a:t>
             </a:r>
           </a:p>
         </p:txBody>
@@ -14107,8 +14117,8 @@
         </p:nvSpPr>
         <p:spPr>
           <a:xfrm>
-            <a:off x="9281160" y="3063240"/>
-            <a:ext cx="2286000" cy="548640"/>
+            <a:off x="9281160" y="2871216"/>
+            <a:ext cx="2304288" cy="548640"/>
           </a:xfrm>
           <a:prstGeom prst="rect">
             <a:avLst/>
@@ -14123,27 +14133,74 @@
           <a:p>
             <a:pPr algn="l"/>
             <a:r>
-              <a:rPr sz="1400" b="0" i="0">
+              <a:rPr sz="1350" b="0" i="0">
                 <a:solidFill>
                   <a:srgbClr val="475569"/>
                 </a:solidFill>
                 <a:latin typeface="Helvetica Neue"/>
               </a:rPr>
-              <a:t>just working out who owns it</a:t>
-            </a:r>
-          </a:p>
-        </p:txBody>
-      </p:sp>
-      <p:sp>
-        <p:nvSpPr>
-          <p:cNvPr id="18" name="TextBox 17"/>
-          <p:cNvSpPr txBox="1"/>
-          <p:nvPr/>
-        </p:nvSpPr>
-        <p:spPr>
-          <a:xfrm>
-            <a:off x="640080" y="4160520"/>
-            <a:ext cx="10881360" cy="822960"/>
+              <a:t>just working out who should own it</a:t>
+            </a:r>
+          </a:p>
+        </p:txBody>
+      </p:sp>
+      <p:sp>
+        <p:nvSpPr>
+          <p:cNvPr id="18" name="Rounded Rectangle 17"/>
+          <p:cNvSpPr/>
+          <p:nvPr/>
+        </p:nvSpPr>
+        <p:spPr>
+          <a:xfrm>
+            <a:off x="640080" y="3703320"/>
+            <a:ext cx="10908792" cy="1481328"/>
+          </a:xfrm>
+          <a:prstGeom prst="roundRect">
+            <a:avLst>
+              <a:gd name="adj" fmla="val 6000"/>
+            </a:avLst>
+          </a:prstGeom>
+          <a:solidFill>
+            <a:srgbClr val="FFFBEB"/>
+          </a:solidFill>
+          <a:ln>
+            <a:solidFill>
+              <a:srgbClr val="FDE68A"/>
+            </a:solidFill>
+          </a:ln>
+        </p:spPr>
+        <p:style>
+          <a:lnRef idx="1">
+            <a:schemeClr val="accent1"/>
+          </a:lnRef>
+          <a:fillRef idx="3">
+            <a:schemeClr val="accent1"/>
+          </a:fillRef>
+          <a:effectRef idx="2">
+            <a:schemeClr val="accent1"/>
+          </a:effectRef>
+          <a:fontRef idx="minor">
+            <a:schemeClr val="lt1"/>
+          </a:fontRef>
+        </p:style>
+        <p:txBody>
+          <a:bodyPr rtlCol="0" anchor="ctr"/>
+          <a:lstStyle/>
+          <a:p>
+            <a:pPr algn="ctr"/>
+          </a:p>
+        </p:txBody>
+      </p:sp>
+      <p:sp>
+        <p:nvSpPr>
+          <p:cNvPr id="19" name="TextBox 18"/>
+          <p:cNvSpPr txBox="1"/>
+          <p:nvPr/>
+        </p:nvSpPr>
+        <p:spPr>
+          <a:xfrm>
+            <a:off x="914400" y="3858768"/>
+            <a:ext cx="10424160" cy="274320"/>
           </a:xfrm>
           <a:prstGeom prst="rect">
             <a:avLst/>
@@ -14158,26 +14215,61 @@
           <a:p>
             <a:pPr algn="l"/>
             <a:r>
-              <a:rPr sz="1800" b="0" i="0">
+              <a:rPr sz="1150" b="1" i="0" spc="180">
+                <a:solidFill>
+                  <a:srgbClr val="B45309"/>
+                </a:solidFill>
+                <a:latin typeface="Helvetica Neue"/>
+              </a:rPr>
+              <a:t>WHY THAT THIRD BOX IS THE HARD ONE</a:t>
+            </a:r>
+          </a:p>
+        </p:txBody>
+      </p:sp>
+      <p:sp>
+        <p:nvSpPr>
+          <p:cNvPr id="20" name="TextBox 19"/>
+          <p:cNvSpPr txBox="1"/>
+          <p:nvPr/>
+        </p:nvSpPr>
+        <p:spPr>
+          <a:xfrm>
+            <a:off x="914400" y="4169663"/>
+            <a:ext cx="10378440" cy="914400"/>
+          </a:xfrm>
+          <a:prstGeom prst="rect">
+            <a:avLst/>
+          </a:prstGeom>
+          <a:noFill/>
+        </p:spPr>
+        <p:txBody>
+          <a:bodyPr wrap="square">
+            <a:spAutoFit/>
+          </a:bodyPr>
+          <a:lstStyle/>
+          <a:p>
+            <a:pPr algn="l"/>
+            <a:r>
+              <a:rPr sz="1500" b="0" i="0">
                 <a:solidFill>
                   <a:srgbClr val="334155"/>
                 </a:solidFill>
                 <a:latin typeface="Helvetica Neue"/>
               </a:rPr>
-              <a:t>Today we build the part that READS the inbox: search it, sort it, and decide what a human actually needs to see. Next lecture we make it act.</a:t>
-            </a:r>
-          </a:p>
-        </p:txBody>
-      </p:sp>
-      <p:sp>
-        <p:nvSpPr>
-          <p:cNvPr id="19" name="TextBox 18"/>
-          <p:cNvSpPr txBox="1"/>
-          <p:nvPr/>
-        </p:nvSpPr>
-        <p:spPr>
-          <a:xfrm>
-            <a:off x="640080" y="5257800"/>
+              <a:t>The normal way to teach a computer to sort text is to hand it a few thousand examples that a person has already sorted by hand. Those hand-sorted examples are called training data, and most machine learning cannot start without them. Cobalt has none. Building that pile would mean paying people to read and tag thousands of tickets before you could write a line of code.</a:t>
+            </a:r>
+          </a:p>
+        </p:txBody>
+      </p:sp>
+      <p:sp>
+        <p:nvSpPr>
+          <p:cNvPr id="21" name="TextBox 20"/>
+          <p:cNvSpPr txBox="1"/>
+          <p:nvPr/>
+        </p:nvSpPr>
+        <p:spPr>
+          <a:xfrm>
+            <a:off x="640080" y="5413248"/>
             <a:ext cx="10881360" cy="457200"/>
           </a:xfrm>
           <a:prstGeom prst="rect">
@@ -14193,13 +14285,13 @@
           <a:p>
             <a:pPr algn="l"/>
             <a:r>
-              <a:rPr sz="1500" b="0" i="1">
-                <a:solidFill>
-                  <a:srgbClr val="475569"/>
-                </a:solidFill>
-                <a:latin typeface="Helvetica Neue"/>
-              </a:rPr>
-              <a:t>Every technique today is one you can point at any pile of text: tickets, reviews, resumes, survey answers.</a:t>
+              <a:rPr sz="1600" b="0" i="1">
+                <a:solidFill>
+                  <a:srgbClr val="0F172A"/>
+                </a:solidFill>
+                <a:latin typeface="Helvetica Neue"/>
+              </a:rPr>
+              <a:t>So tonight we build something that never needs them. We start with the half that READS the inbox: search it, sort it, and decide what a person actually has to see.</a:t>
             </a:r>
           </a:p>
         </p:txBody>

</xml_diff>

<commit_message>
Week 7: stop calling category descriptions 'labels'
The deck and notebook used 'label' for two opposite things: the hand-sorted
training data Cobalt does not have, and the category descriptions we write.
One notebook cell said 'candidate_labels' and 'zero labelled examples' three
lines apart. Now: 'training data' for what we lack, 'category descriptions'
for what we write, and an explicit callout where students meet the
candidate_labels argument so the library's naming does not undo the point.

Co-Authored-By: Claude Opus 4.8 <noreply@anthropic.com>
</commit_message>
<xml_diff>
--- a/Week 7/L13_Support_Copilot.pptx
+++ b/Week 7/L13_Support_Copilot.pptx
@@ -1032,12 +1032,12 @@
           </a:p>
           <a:p>
             <a:r>
-              <a:t>Look at what happened. The billing tickets cluster together. The sign-in tickets cluster. The slow-and-broken tickets cluster. Nobody labelled any of this. I never told the model these categories existed. That structure was already sitting in the text, and all we did was make it visible.</a:t>
-            </a:r>
-          </a:p>
-          <a:p>
-            <a:r>
-              <a:t>The practical version: you can walk into a leadership meeting and show them what is inside a pile of feedback before spending one dollar on labelling.</a:t>
+              <a:t>Look at what happened. The billing tickets cluster together. The sign-in tickets cluster. The slow-and-broken tickets cluster. Nobody sorted any of this. I never told the model these categories existed. That structure was already sitting in the text, and all we did was make it visible.</a:t>
+            </a:r>
+          </a:p>
+          <a:p>
+            <a:r>
+              <a:t>The practical version: you can walk into a leadership meeting and show them what is inside a pile of feedback before spending one dollar on hand-sorting.</a:t>
             </a:r>
           </a:p>
         </p:txBody>
@@ -1112,13 +1112,18 @@
           </a:p>
           <a:p>
             <a:r>
-              <a:t>TO THE NOTEBOOK: Act 2: "Route with zero labelled examples"</a:t>
+              <a:t>TO THE NOTEBOOK: Act 2: "Route with no training data at all"</a:t>
             </a:r>
           </a:p>
           <a:p/>
           <a:p>
             <a:r>
-              <a:t>Now the interesting part. We want to sort the inbox into the buckets our support team actually uses. The textbook answer is: label a few thousand tickets, then train a classifier. That is weeks of work and money Cobalt does not have.</a:t>
+              <a:t>Now the interesting part. We want to sort the inbox into the buckets our support team actually uses. The textbook answer is: hand-sort a few thousand tickets, then train a classifier. That is weeks of work and money Cobalt does not have.</a:t>
+            </a:r>
+          </a:p>
+          <a:p>
+            <a:r>
+              <a:t>One thing to head off before it confuses somebody. In the code you will see an argument called candidate underscore labels. Those are not the hand-sorted labels I just told you we do not have. Nobody sorted a ticket. They are the sentences we write, in English, in about a minute. The library just picked an unfortunate name.</a:t>
             </a:r>
           </a:p>
           <a:p>
@@ -1133,7 +1138,7 @@
           </a:p>
           <a:p>
             <a:r>
-              <a:t>[run it] Sixty four percent on its single best guess, and eighty percent if you let it offer two. Zero labelled examples. Zero training. Zero dollars.</a:t>
+              <a:t>[run it] Sixty four percent on its single best guess, and eighty percent if you let it offer two. Nobody sorted a ticket. Nothing was trained. Zero dollars.</a:t>
             </a:r>
           </a:p>
           <a:p>
@@ -1416,7 +1421,7 @@
           </a:p>
           <a:p>
             <a:r>
-              <a:t>Watch. On the left, careful descriptions: sixty four percent. On the right, I replaced them with lazy one-word labels. Just "billing". Just "bug". Forty seven percent.</a:t>
+              <a:t>Watch. On the left, careful descriptions: sixty four percent. On the right, I replaced them with lazy one-word descriptions. Just "billing". Just "bug". Forty seven percent.</a:t>
             </a:r>
           </a:p>
           <a:p>
@@ -2012,12 +2017,12 @@
           </a:p>
           <a:p>
             <a:r>
-              <a:t>Semantic search across the whole inbox. An eight-way router built with zero labelled examples. A confidence policy that decides what ships automatically. And an escalation path, so the system can admit when it does not know.</a:t>
-            </a:r>
-          </a:p>
-          <a:p>
-            <a:r>
-              <a:t>Total labelling cost: zero dollars.</a:t>
+              <a:t>Semantic search across the whole inbox. An eight-way router built with no training data at all. A confidence policy that decides what ships automatically. And an escalation path, so the system can admit when it does not know.</a:t>
+            </a:r>
+          </a:p>
+          <a:p>
+            <a:r>
+              <a:t>Total cost of hand-sorting tickets: zero dollars.</a:t>
             </a:r>
           </a:p>
           <a:p>
@@ -6100,7 +6105,7 @@
                 </a:solidFill>
                 <a:latin typeface="Helvetica Neue"/>
               </a:rPr>
-              <a:t>5,000 tickets a week, three agents, and not one labelled example. Let's ship something anyway.</a:t>
+              <a:t>5,000 tickets a week, three agents, and nothing in the queue has ever been sorted. Let's ship anyway.</a:t>
             </a:r>
           </a:p>
         </p:txBody>
@@ -8667,7 +8672,7 @@
                 </a:solidFill>
                 <a:latin typeface="Helvetica Neue"/>
               </a:rPr>
-              <a:t>Nobody labelled these. Plot the vectors and the neighbourhoods appear on their own.</a:t>
+              <a:t>Nobody sorted these. Plot the vectors and the neighbourhoods appear on their own.</a:t>
             </a:r>
           </a:p>
         </p:txBody>
@@ -9257,7 +9262,7 @@
                 </a:solidFill>
                 <a:latin typeface="Helvetica Neue"/>
               </a:rPr>
-              <a:t>Sort the inbox with zero labelled examples.</a:t>
+              <a:t>Sort the inbox with no training data at all.</a:t>
             </a:r>
           </a:p>
         </p:txBody>
@@ -9692,8 +9697,8 @@
         </p:nvSpPr>
         <p:spPr>
           <a:xfrm>
-            <a:off x="6480810" y="6382512"/>
-            <a:ext cx="5070805" cy="310896"/>
+            <a:off x="6900519" y="6382512"/>
+            <a:ext cx="4651095" cy="310896"/>
           </a:xfrm>
           <a:prstGeom prst="roundRect">
             <a:avLst>
@@ -9737,8 +9742,8 @@
         </p:nvSpPr>
         <p:spPr>
           <a:xfrm>
-            <a:off x="6480810" y="6432804"/>
-            <a:ext cx="5070805" cy="237744"/>
+            <a:off x="6900519" y="6432804"/>
+            <a:ext cx="4651095" cy="237744"/>
           </a:xfrm>
           <a:prstGeom prst="rect">
             <a:avLst/>
@@ -9759,7 +9764,7 @@
                 </a:solidFill>
                 <a:latin typeface="Helvetica Neue"/>
               </a:rPr>
-              <a:t>▶  TO THE NOTEBOOK      Act 2 · “Route with zero labelled examples”</a:t>
+              <a:t>▶  TO THE NOTEBOOK      Act 2 · “Route with no training data”</a:t>
             </a:r>
           </a:p>
         </p:txBody>
@@ -11097,7 +11102,7 @@
                 </a:solidFill>
                 <a:latin typeface="Helvetica Neue"/>
               </a:rPr>
-              <a:t>The words you write ARE the program.</a:t>
+              <a:t>The descriptions you write ARE the program.</a:t>
             </a:r>
           </a:p>
         </p:txBody>
@@ -15080,7 +15085,7 @@
                 </a:solidFill>
                 <a:latin typeface="Helvetica Neue"/>
               </a:rPr>
-              <a:t>No labelled data. No training. No GPU bill. One afternoon.</a:t>
+              <a:t>No training data. No training run. No GPU bill. One afternoon.</a:t>
             </a:r>
           </a:p>
         </p:txBody>
@@ -15557,7 +15562,7 @@
                 </a:solidFill>
                 <a:latin typeface="Helvetica Neue"/>
               </a:rPr>
-              <a:t>What if we DO label?</a:t>
+              <a:t>What if we DO sort them by hand?</a:t>
             </a:r>
           </a:p>
         </p:txBody>

</xml_diff>

<commit_message>
Week 7: replace cell numbers with named STEPs
A bare cell number told you nothing about what you were looking for. Every
runnable cell is now a numbered STEP with a short descriptive name, emitted as
a markdown heading so Colab's table of contents lists all 21 and you can jump
straight to one. The slide cue shows the same thing:
  NOTEBOOK | STEP 16 | YOUR KNOB: rewrite the descriptions
Speaker notes carry the identical label, and the competition notebook is
stepped the same way.

Co-Authored-By: Claude Opus 4.8 <noreply@anthropic.com>
</commit_message>
<xml_diff>
--- a/Week 7/L13_Support_Copilot.pptx
+++ b/Week 7/L13_Support_Copilot.pptx
@@ -617,7 +617,7 @@
           </a:p>
           <a:p>
             <a:r>
-              <a:t>TO THE NOTEBOOK: CELL 9  ·  the same word in two tickets</a:t>
+              <a:t>TO THE NOTEBOOK: STEP 9 · Watch attention change a word</a:t>
             </a:r>
           </a:p>
           <a:p/>
@@ -723,7 +723,7 @@
           </a:p>
           <a:p>
             <a:r>
-              <a:t>TO THE NOTEBOOK: CELL 10 ·  fill-mask, and where the weights sit</a:t>
+              <a:t>TO THE NOTEBOOK: STEP 10 · Find where the knowledge is stored</a:t>
             </a:r>
           </a:p>
           <a:p/>
@@ -829,7 +829,7 @@
           </a:p>
           <a:p>
             <a:r>
-              <a:t>TO THE NOTEBOOK: CELL 11 ·  similarity is just multiplication</a:t>
+              <a:t>TO THE NOTEBOOK: STEP 11 · Measure similarity by hand</a:t>
             </a:r>
           </a:p>
           <a:p/>
@@ -920,7 +920,7 @@
           </a:p>
           <a:p>
             <a:r>
-              <a:t>TO THE NOTEBOOK: CELL 3  ·  keyword vs semantic search   (scroll back up)</a:t>
+              <a:t>TO THE NOTEBOOK: STEP 3 · Turn tickets into vectors, then search   (scroll back up)</a:t>
             </a:r>
           </a:p>
           <a:p/>
@@ -1016,7 +1016,7 @@
           </a:p>
           <a:p>
             <a:r>
-              <a:t>TO THE NOTEBOOK: CELL 5  ·  the inbox map</a:t>
+              <a:t>TO THE NOTEBOOK: STEP 5 · Map the whole inbox   (scroll back up)</a:t>
             </a:r>
           </a:p>
           <a:p/>
@@ -1112,7 +1112,7 @@
           </a:p>
           <a:p>
             <a:r>
-              <a:t>TO THE NOTEBOOK: CELL 13 ·  route with no training data</a:t>
+              <a:t>TO THE NOTEBOOK: STEP 13 · Route the inbox with no training data</a:t>
             </a:r>
           </a:p>
           <a:p/>
@@ -1218,7 +1218,7 @@
           </a:p>
           <a:p>
             <a:r>
-              <a:t>TO THE NOTEBOOK: CELL 17 ·  the entailment scores</a:t>
+              <a:t>TO THE NOTEBOOK: STEP 17 · See the entailment scores</a:t>
             </a:r>
           </a:p>
           <a:p/>
@@ -1319,7 +1319,7 @@
           </a:p>
           <a:p>
             <a:r>
-              <a:t>TO THE NOTEBOOK: CELL 17 ·  same cell, read the logits</a:t>
+              <a:t>TO THE NOTEBOOK: STEP 17 · See the entailment scores</a:t>
             </a:r>
           </a:p>
           <a:p/>
@@ -1410,7 +1410,7 @@
           </a:p>
           <a:p>
             <a:r>
-              <a:t>TO THE NOTEBOOK: CELL 16 ·  YOUR KNOB, the descriptions</a:t>
+              <a:t>TO THE NOTEBOOK: STEP 16 · YOUR KNOB: rewrite the descriptions</a:t>
             </a:r>
           </a:p>
           <a:p/>
@@ -1511,7 +1511,7 @@
           </a:p>
           <a:p>
             <a:r>
-              <a:t>TO THE NOTEBOOK: CELL 18 ·  per-bucket recall</a:t>
+              <a:t>TO THE NOTEBOOK: STEP 18 · Find the weak buckets</a:t>
             </a:r>
           </a:p>
           <a:p/>
@@ -1703,7 +1703,7 @@
           </a:p>
           <a:p>
             <a:r>
-              <a:t>TO THE NOTEBOOK: CELL 19 ·  the off-topic ticket</a:t>
+              <a:t>TO THE NOTEBOOK: STEP 19 · Feed it an off-topic ticket</a:t>
             </a:r>
           </a:p>
           <a:p/>
@@ -1814,7 +1814,7 @@
           </a:p>
           <a:p>
             <a:r>
-              <a:t>TO THE NOTEBOOK: CELL 20 ·  the two defences</a:t>
+              <a:t>TO THE NOTEBOOK: STEP 20 · Add the two defences</a:t>
             </a:r>
           </a:p>
           <a:p/>
@@ -1910,7 +1910,7 @@
           </a:p>
           <a:p>
             <a:r>
-              <a:t>TO THE NOTEBOOK: CELL 21 ·  YOUR KNOB, the threshold</a:t>
+              <a:t>TO THE NOTEBOOK: STEP 21 · YOUR KNOB: set the threshold</a:t>
             </a:r>
           </a:p>
           <a:p/>
@@ -2612,7 +2612,7 @@
           </a:p>
           <a:p>
             <a:r>
-              <a:t>TO THE NOTEBOOK: CELL 6  ·  text to tokens to ids</a:t>
+              <a:t>TO THE NOTEBOOK: STEP 6 · Split text into tokens</a:t>
             </a:r>
           </a:p>
           <a:p/>
@@ -2703,7 +2703,7 @@
           </a:p>
           <a:p>
             <a:r>
-              <a:t>TO THE NOTEBOOK: CELL 7  ·  does your vocabulary survive?</a:t>
+              <a:t>TO THE NOTEBOOK: STEP 7 · Test your product vocabulary</a:t>
             </a:r>
           </a:p>
           <a:p/>
@@ -2799,7 +2799,7 @@
           </a:p>
           <a:p>
             <a:r>
-              <a:t>TO THE NOTEBOOK: CELL 8  ·  from tokens to ONE vector</a:t>
+              <a:t>TO THE NOTEBOOK: STEP 8 · Pool tokens into one vector</a:t>
             </a:r>
           </a:p>
           <a:p/>
@@ -2895,7 +2895,7 @@
           </a:p>
           <a:p>
             <a:r>
-              <a:t>TO THE NOTEBOOK: CELL 9  ·  what happened inside bert(...)</a:t>
+              <a:t>TO THE NOTEBOOK: STEP 9 · Watch attention change a word</a:t>
             </a:r>
           </a:p>
           <a:p/>
@@ -6703,8 +6703,8 @@
         </p:nvSpPr>
         <p:spPr>
           <a:xfrm>
-            <a:off x="6941210" y="6345936"/>
-            <a:ext cx="4610404" cy="365760"/>
+            <a:off x="7105802" y="6345936"/>
+            <a:ext cx="4445812" cy="365760"/>
           </a:xfrm>
           <a:prstGeom prst="roundRect">
             <a:avLst>
@@ -6748,8 +6748,8 @@
         </p:nvSpPr>
         <p:spPr>
           <a:xfrm>
-            <a:off x="8056778" y="6396228"/>
-            <a:ext cx="760780" cy="265176"/>
+            <a:off x="8148218" y="6396228"/>
+            <a:ext cx="685800" cy="265176"/>
           </a:xfrm>
           <a:prstGeom prst="roundRect">
             <a:avLst>
@@ -6793,8 +6793,8 @@
         </p:nvSpPr>
         <p:spPr>
           <a:xfrm>
-            <a:off x="7096658" y="6460236"/>
-            <a:ext cx="1024128" cy="219456"/>
+            <a:off x="7261250" y="6460236"/>
+            <a:ext cx="914400" cy="219456"/>
           </a:xfrm>
           <a:prstGeom prst="rect">
             <a:avLst/>
@@ -6809,83 +6809,83 @@
           <a:p>
             <a:pPr algn="l"/>
             <a:r>
+              <a:rPr sz="950" b="1" i="0">
+                <a:solidFill>
+                  <a:srgbClr val="A7F3D0"/>
+                </a:solidFill>
+                <a:latin typeface="Helvetica Neue"/>
+              </a:rPr>
+              <a:t>▶ NOTEBOOK</a:t>
+            </a:r>
+          </a:p>
+        </p:txBody>
+      </p:sp>
+      <p:sp>
+        <p:nvSpPr>
+          <p:cNvPr id="19" name="TextBox 18"/>
+          <p:cNvSpPr txBox="1"/>
+          <p:nvPr/>
+        </p:nvSpPr>
+        <p:spPr>
+          <a:xfrm>
+            <a:off x="8148218" y="6451092"/>
+            <a:ext cx="685800" cy="219456"/>
+          </a:xfrm>
+          <a:prstGeom prst="rect">
+            <a:avLst/>
+          </a:prstGeom>
+          <a:noFill/>
+        </p:spPr>
+        <p:txBody>
+          <a:bodyPr wrap="none" lIns="0" rIns="0" tIns="0" bIns="0">
+            <a:spAutoFit/>
+          </a:bodyPr>
+          <a:lstStyle/>
+          <a:p>
+            <a:pPr algn="ctr"/>
+            <a:r>
+              <a:rPr sz="1100" b="1" i="0">
+                <a:solidFill>
+                  <a:srgbClr val="FFFFFF"/>
+                </a:solidFill>
+                <a:latin typeface="Helvetica Neue"/>
+              </a:rPr>
+              <a:t>STEP 9</a:t>
+            </a:r>
+          </a:p>
+        </p:txBody>
+      </p:sp>
+      <p:sp>
+        <p:nvSpPr>
+          <p:cNvPr id="20" name="TextBox 19"/>
+          <p:cNvSpPr txBox="1"/>
+          <p:nvPr/>
+        </p:nvSpPr>
+        <p:spPr>
+          <a:xfrm>
+            <a:off x="8952890" y="6460236"/>
+            <a:ext cx="2498140" cy="219456"/>
+          </a:xfrm>
+          <a:prstGeom prst="rect">
+            <a:avLst/>
+          </a:prstGeom>
+          <a:noFill/>
+        </p:spPr>
+        <p:txBody>
+          <a:bodyPr wrap="none" lIns="0" rIns="0" tIns="0" bIns="0">
+            <a:spAutoFit/>
+          </a:bodyPr>
+          <a:lstStyle/>
+          <a:p>
+            <a:pPr algn="l"/>
+            <a:r>
               <a:rPr sz="1000" b="1" i="0">
                 <a:solidFill>
-                  <a:srgbClr val="A7F3D0"/>
-                </a:solidFill>
-                <a:latin typeface="Helvetica Neue"/>
-              </a:rPr>
-              <a:t>▶ NOTEBOOK</a:t>
-            </a:r>
-          </a:p>
-        </p:txBody>
-      </p:sp>
-      <p:sp>
-        <p:nvSpPr>
-          <p:cNvPr id="19" name="TextBox 18"/>
-          <p:cNvSpPr txBox="1"/>
-          <p:nvPr/>
-        </p:nvSpPr>
-        <p:spPr>
-          <a:xfrm>
-            <a:off x="8056778" y="6451092"/>
-            <a:ext cx="760780" cy="219456"/>
-          </a:xfrm>
-          <a:prstGeom prst="rect">
-            <a:avLst/>
-          </a:prstGeom>
-          <a:noFill/>
-        </p:spPr>
-        <p:txBody>
-          <a:bodyPr wrap="none" lIns="0" rIns="0" tIns="0" bIns="0">
-            <a:spAutoFit/>
-          </a:bodyPr>
-          <a:lstStyle/>
-          <a:p>
-            <a:pPr algn="ctr"/>
-            <a:r>
-              <a:rPr sz="1150" b="1" i="0">
-                <a:solidFill>
                   <a:srgbClr val="FFFFFF"/>
                 </a:solidFill>
                 <a:latin typeface="Helvetica Neue"/>
               </a:rPr>
-              <a:t>CELL 9</a:t>
-            </a:r>
-          </a:p>
-        </p:txBody>
-      </p:sp>
-      <p:sp>
-        <p:nvSpPr>
-          <p:cNvPr id="20" name="TextBox 19"/>
-          <p:cNvSpPr txBox="1"/>
-          <p:nvPr/>
-        </p:nvSpPr>
-        <p:spPr>
-          <a:xfrm>
-            <a:off x="8945575" y="6460236"/>
-            <a:ext cx="2496312" cy="219456"/>
-          </a:xfrm>
-          <a:prstGeom prst="rect">
-            <a:avLst/>
-          </a:prstGeom>
-          <a:noFill/>
-        </p:spPr>
-        <p:txBody>
-          <a:bodyPr wrap="none" lIns="0" rIns="0" tIns="0" bIns="0">
-            <a:spAutoFit/>
-          </a:bodyPr>
-          <a:lstStyle/>
-          <a:p>
-            <a:pPr algn="l"/>
-            <a:r>
-              <a:rPr sz="1050" b="1" i="0">
-                <a:solidFill>
-                  <a:srgbClr val="FFFFFF"/>
-                </a:solidFill>
-                <a:latin typeface="Helvetica Neue"/>
-              </a:rPr>
-              <a:t>the same word, two tickets</a:t>
+              <a:t>Watch attention change a word</a:t>
             </a:r>
           </a:p>
         </p:txBody>
@@ -7443,8 +7443,8 @@
         </p:nvSpPr>
         <p:spPr>
           <a:xfrm>
-            <a:off x="6341364" y="6345936"/>
-            <a:ext cx="5210251" cy="365760"/>
+            <a:off x="6705295" y="6345936"/>
+            <a:ext cx="4846320" cy="365760"/>
           </a:xfrm>
           <a:prstGeom prst="roundRect">
             <a:avLst>
@@ -7488,8 +7488,8 @@
         </p:nvSpPr>
         <p:spPr>
           <a:xfrm>
-            <a:off x="7456932" y="6396228"/>
-            <a:ext cx="835761" cy="265176"/>
+            <a:off x="7747711" y="6396228"/>
+            <a:ext cx="754380" cy="265176"/>
           </a:xfrm>
           <a:prstGeom prst="roundRect">
             <a:avLst>
@@ -7533,8 +7533,8 @@
         </p:nvSpPr>
         <p:spPr>
           <a:xfrm>
-            <a:off x="6496812" y="6460236"/>
-            <a:ext cx="1024128" cy="219456"/>
+            <a:off x="6860743" y="6460236"/>
+            <a:ext cx="914400" cy="219456"/>
           </a:xfrm>
           <a:prstGeom prst="rect">
             <a:avLst/>
@@ -7549,83 +7549,83 @@
           <a:p>
             <a:pPr algn="l"/>
             <a:r>
+              <a:rPr sz="950" b="1" i="0">
+                <a:solidFill>
+                  <a:srgbClr val="A7F3D0"/>
+                </a:solidFill>
+                <a:latin typeface="Helvetica Neue"/>
+              </a:rPr>
+              <a:t>▶ NOTEBOOK</a:t>
+            </a:r>
+          </a:p>
+        </p:txBody>
+      </p:sp>
+      <p:sp>
+        <p:nvSpPr>
+          <p:cNvPr id="18" name="TextBox 17"/>
+          <p:cNvSpPr txBox="1"/>
+          <p:nvPr/>
+        </p:nvSpPr>
+        <p:spPr>
+          <a:xfrm>
+            <a:off x="7747711" y="6451092"/>
+            <a:ext cx="754380" cy="219456"/>
+          </a:xfrm>
+          <a:prstGeom prst="rect">
+            <a:avLst/>
+          </a:prstGeom>
+          <a:noFill/>
+        </p:spPr>
+        <p:txBody>
+          <a:bodyPr wrap="none" lIns="0" rIns="0" tIns="0" bIns="0">
+            <a:spAutoFit/>
+          </a:bodyPr>
+          <a:lstStyle/>
+          <a:p>
+            <a:pPr algn="ctr"/>
+            <a:r>
+              <a:rPr sz="1100" b="1" i="0">
+                <a:solidFill>
+                  <a:srgbClr val="FFFFFF"/>
+                </a:solidFill>
+                <a:latin typeface="Helvetica Neue"/>
+              </a:rPr>
+              <a:t>STEP 10</a:t>
+            </a:r>
+          </a:p>
+        </p:txBody>
+      </p:sp>
+      <p:sp>
+        <p:nvSpPr>
+          <p:cNvPr id="19" name="TextBox 18"/>
+          <p:cNvSpPr txBox="1"/>
+          <p:nvPr/>
+        </p:nvSpPr>
+        <p:spPr>
+          <a:xfrm>
+            <a:off x="8620963" y="6460236"/>
+            <a:ext cx="2830068" cy="219456"/>
+          </a:xfrm>
+          <a:prstGeom prst="rect">
+            <a:avLst/>
+          </a:prstGeom>
+          <a:noFill/>
+        </p:spPr>
+        <p:txBody>
+          <a:bodyPr wrap="none" lIns="0" rIns="0" tIns="0" bIns="0">
+            <a:spAutoFit/>
+          </a:bodyPr>
+          <a:lstStyle/>
+          <a:p>
+            <a:pPr algn="l"/>
+            <a:r>
               <a:rPr sz="1000" b="1" i="0">
                 <a:solidFill>
-                  <a:srgbClr val="A7F3D0"/>
-                </a:solidFill>
-                <a:latin typeface="Helvetica Neue"/>
-              </a:rPr>
-              <a:t>▶ NOTEBOOK</a:t>
-            </a:r>
-          </a:p>
-        </p:txBody>
-      </p:sp>
-      <p:sp>
-        <p:nvSpPr>
-          <p:cNvPr id="18" name="TextBox 17"/>
-          <p:cNvSpPr txBox="1"/>
-          <p:nvPr/>
-        </p:nvSpPr>
-        <p:spPr>
-          <a:xfrm>
-            <a:off x="7456932" y="6451092"/>
-            <a:ext cx="835761" cy="219456"/>
-          </a:xfrm>
-          <a:prstGeom prst="rect">
-            <a:avLst/>
-          </a:prstGeom>
-          <a:noFill/>
-        </p:spPr>
-        <p:txBody>
-          <a:bodyPr wrap="none" lIns="0" rIns="0" tIns="0" bIns="0">
-            <a:spAutoFit/>
-          </a:bodyPr>
-          <a:lstStyle/>
-          <a:p>
-            <a:pPr algn="ctr"/>
-            <a:r>
-              <a:rPr sz="1150" b="1" i="0">
-                <a:solidFill>
                   <a:srgbClr val="FFFFFF"/>
                 </a:solidFill>
                 <a:latin typeface="Helvetica Neue"/>
               </a:rPr>
-              <a:t>CELL 10</a:t>
-            </a:r>
-          </a:p>
-        </p:txBody>
-      </p:sp>
-      <p:sp>
-        <p:nvSpPr>
-          <p:cNvPr id="19" name="TextBox 18"/>
-          <p:cNvSpPr txBox="1"/>
-          <p:nvPr/>
-        </p:nvSpPr>
-        <p:spPr>
-          <a:xfrm>
-            <a:off x="8420709" y="6460236"/>
-            <a:ext cx="3021177" cy="219456"/>
-          </a:xfrm>
-          <a:prstGeom prst="rect">
-            <a:avLst/>
-          </a:prstGeom>
-          <a:noFill/>
-        </p:spPr>
-        <p:txBody>
-          <a:bodyPr wrap="none" lIns="0" rIns="0" tIns="0" bIns="0">
-            <a:spAutoFit/>
-          </a:bodyPr>
-          <a:lstStyle/>
-          <a:p>
-            <a:pPr algn="l"/>
-            <a:r>
-              <a:rPr sz="1050" b="1" i="0">
-                <a:solidFill>
-                  <a:srgbClr val="FFFFFF"/>
-                </a:solidFill>
-                <a:latin typeface="Helvetica Neue"/>
-              </a:rPr>
-              <a:t>fill-mask + where the weights sit</a:t>
+              <a:t>Find where the knowledge is stored</a:t>
             </a:r>
           </a:p>
         </p:txBody>
@@ -8207,8 +8207,8 @@
         </p:nvSpPr>
         <p:spPr>
           <a:xfrm>
-            <a:off x="6341364" y="6345936"/>
-            <a:ext cx="5210251" cy="365760"/>
+            <a:off x="7239304" y="6345936"/>
+            <a:ext cx="4312310" cy="365760"/>
           </a:xfrm>
           <a:prstGeom prst="roundRect">
             <a:avLst>
@@ -8252,8 +8252,8 @@
         </p:nvSpPr>
         <p:spPr>
           <a:xfrm>
-            <a:off x="7456932" y="6396228"/>
-            <a:ext cx="835761" cy="265176"/>
+            <a:off x="8281720" y="6396228"/>
+            <a:ext cx="754380" cy="265176"/>
           </a:xfrm>
           <a:prstGeom prst="roundRect">
             <a:avLst>
@@ -8297,8 +8297,8 @@
         </p:nvSpPr>
         <p:spPr>
           <a:xfrm>
-            <a:off x="6496812" y="6460236"/>
-            <a:ext cx="1024128" cy="219456"/>
+            <a:off x="7394752" y="6460236"/>
+            <a:ext cx="914400" cy="219456"/>
           </a:xfrm>
           <a:prstGeom prst="rect">
             <a:avLst/>
@@ -8313,83 +8313,83 @@
           <a:p>
             <a:pPr algn="l"/>
             <a:r>
+              <a:rPr sz="950" b="1" i="0">
+                <a:solidFill>
+                  <a:srgbClr val="A7F3D0"/>
+                </a:solidFill>
+                <a:latin typeface="Helvetica Neue"/>
+              </a:rPr>
+              <a:t>▶ NOTEBOOK</a:t>
+            </a:r>
+          </a:p>
+        </p:txBody>
+      </p:sp>
+      <p:sp>
+        <p:nvSpPr>
+          <p:cNvPr id="18" name="TextBox 17"/>
+          <p:cNvSpPr txBox="1"/>
+          <p:nvPr/>
+        </p:nvSpPr>
+        <p:spPr>
+          <a:xfrm>
+            <a:off x="8281720" y="6451092"/>
+            <a:ext cx="754380" cy="219456"/>
+          </a:xfrm>
+          <a:prstGeom prst="rect">
+            <a:avLst/>
+          </a:prstGeom>
+          <a:noFill/>
+        </p:spPr>
+        <p:txBody>
+          <a:bodyPr wrap="none" lIns="0" rIns="0" tIns="0" bIns="0">
+            <a:spAutoFit/>
+          </a:bodyPr>
+          <a:lstStyle/>
+          <a:p>
+            <a:pPr algn="ctr"/>
+            <a:r>
+              <a:rPr sz="1100" b="1" i="0">
+                <a:solidFill>
+                  <a:srgbClr val="FFFFFF"/>
+                </a:solidFill>
+                <a:latin typeface="Helvetica Neue"/>
+              </a:rPr>
+              <a:t>STEP 11</a:t>
+            </a:r>
+          </a:p>
+        </p:txBody>
+      </p:sp>
+      <p:sp>
+        <p:nvSpPr>
+          <p:cNvPr id="19" name="TextBox 18"/>
+          <p:cNvSpPr txBox="1"/>
+          <p:nvPr/>
+        </p:nvSpPr>
+        <p:spPr>
+          <a:xfrm>
+            <a:off x="9154972" y="6460236"/>
+            <a:ext cx="2296058" cy="219456"/>
+          </a:xfrm>
+          <a:prstGeom prst="rect">
+            <a:avLst/>
+          </a:prstGeom>
+          <a:noFill/>
+        </p:spPr>
+        <p:txBody>
+          <a:bodyPr wrap="none" lIns="0" rIns="0" tIns="0" bIns="0">
+            <a:spAutoFit/>
+          </a:bodyPr>
+          <a:lstStyle/>
+          <a:p>
+            <a:pPr algn="l"/>
+            <a:r>
               <a:rPr sz="1000" b="1" i="0">
                 <a:solidFill>
-                  <a:srgbClr val="A7F3D0"/>
-                </a:solidFill>
-                <a:latin typeface="Helvetica Neue"/>
-              </a:rPr>
-              <a:t>▶ NOTEBOOK</a:t>
-            </a:r>
-          </a:p>
-        </p:txBody>
-      </p:sp>
-      <p:sp>
-        <p:nvSpPr>
-          <p:cNvPr id="18" name="TextBox 17"/>
-          <p:cNvSpPr txBox="1"/>
-          <p:nvPr/>
-        </p:nvSpPr>
-        <p:spPr>
-          <a:xfrm>
-            <a:off x="7456932" y="6451092"/>
-            <a:ext cx="835761" cy="219456"/>
-          </a:xfrm>
-          <a:prstGeom prst="rect">
-            <a:avLst/>
-          </a:prstGeom>
-          <a:noFill/>
-        </p:spPr>
-        <p:txBody>
-          <a:bodyPr wrap="none" lIns="0" rIns="0" tIns="0" bIns="0">
-            <a:spAutoFit/>
-          </a:bodyPr>
-          <a:lstStyle/>
-          <a:p>
-            <a:pPr algn="ctr"/>
-            <a:r>
-              <a:rPr sz="1150" b="1" i="0">
-                <a:solidFill>
                   <a:srgbClr val="FFFFFF"/>
                 </a:solidFill>
                 <a:latin typeface="Helvetica Neue"/>
               </a:rPr>
-              <a:t>CELL 11</a:t>
-            </a:r>
-          </a:p>
-        </p:txBody>
-      </p:sp>
-      <p:sp>
-        <p:nvSpPr>
-          <p:cNvPr id="19" name="TextBox 18"/>
-          <p:cNvSpPr txBox="1"/>
-          <p:nvPr/>
-        </p:nvSpPr>
-        <p:spPr>
-          <a:xfrm>
-            <a:off x="8420709" y="6460236"/>
-            <a:ext cx="3021177" cy="219456"/>
-          </a:xfrm>
-          <a:prstGeom prst="rect">
-            <a:avLst/>
-          </a:prstGeom>
-          <a:noFill/>
-        </p:spPr>
-        <p:txBody>
-          <a:bodyPr wrap="none" lIns="0" rIns="0" tIns="0" bIns="0">
-            <a:spAutoFit/>
-          </a:bodyPr>
-          <a:lstStyle/>
-          <a:p>
-            <a:pPr algn="l"/>
-            <a:r>
-              <a:rPr sz="1050" b="1" i="0">
-                <a:solidFill>
-                  <a:srgbClr val="FFFFFF"/>
-                </a:solidFill>
-                <a:latin typeface="Helvetica Neue"/>
-              </a:rPr>
-              <a:t>similarity is just multiplication</a:t>
+              <a:t>Measure similarity by hand</a:t>
             </a:r>
           </a:p>
         </p:txBody>
@@ -8912,8 +8912,8 @@
         </p:nvSpPr>
         <p:spPr>
           <a:xfrm>
-            <a:off x="6941210" y="6345936"/>
-            <a:ext cx="4610404" cy="365760"/>
+            <a:off x="6505041" y="6345936"/>
+            <a:ext cx="5046573" cy="365760"/>
           </a:xfrm>
           <a:prstGeom prst="roundRect">
             <a:avLst>
@@ -8957,8 +8957,8 @@
         </p:nvSpPr>
         <p:spPr>
           <a:xfrm>
-            <a:off x="8056778" y="6396228"/>
-            <a:ext cx="760780" cy="265176"/>
+            <a:off x="7547457" y="6396228"/>
+            <a:ext cx="685800" cy="265176"/>
           </a:xfrm>
           <a:prstGeom prst="roundRect">
             <a:avLst>
@@ -9002,8 +9002,8 @@
         </p:nvSpPr>
         <p:spPr>
           <a:xfrm>
-            <a:off x="7096658" y="6460236"/>
-            <a:ext cx="1024128" cy="219456"/>
+            <a:off x="6660489" y="6460236"/>
+            <a:ext cx="914400" cy="219456"/>
           </a:xfrm>
           <a:prstGeom prst="rect">
             <a:avLst/>
@@ -9018,83 +9018,83 @@
           <a:p>
             <a:pPr algn="l"/>
             <a:r>
+              <a:rPr sz="950" b="1" i="0">
+                <a:solidFill>
+                  <a:srgbClr val="A7F3D0"/>
+                </a:solidFill>
+                <a:latin typeface="Helvetica Neue"/>
+              </a:rPr>
+              <a:t>▶ NOTEBOOK</a:t>
+            </a:r>
+          </a:p>
+        </p:txBody>
+      </p:sp>
+      <p:sp>
+        <p:nvSpPr>
+          <p:cNvPr id="18" name="TextBox 17"/>
+          <p:cNvSpPr txBox="1"/>
+          <p:nvPr/>
+        </p:nvSpPr>
+        <p:spPr>
+          <a:xfrm>
+            <a:off x="7547457" y="6451092"/>
+            <a:ext cx="685800" cy="219456"/>
+          </a:xfrm>
+          <a:prstGeom prst="rect">
+            <a:avLst/>
+          </a:prstGeom>
+          <a:noFill/>
+        </p:spPr>
+        <p:txBody>
+          <a:bodyPr wrap="none" lIns="0" rIns="0" tIns="0" bIns="0">
+            <a:spAutoFit/>
+          </a:bodyPr>
+          <a:lstStyle/>
+          <a:p>
+            <a:pPr algn="ctr"/>
+            <a:r>
+              <a:rPr sz="1100" b="1" i="0">
+                <a:solidFill>
+                  <a:srgbClr val="FFFFFF"/>
+                </a:solidFill>
+                <a:latin typeface="Helvetica Neue"/>
+              </a:rPr>
+              <a:t>STEP 3</a:t>
+            </a:r>
+          </a:p>
+        </p:txBody>
+      </p:sp>
+      <p:sp>
+        <p:nvSpPr>
+          <p:cNvPr id="19" name="TextBox 18"/>
+          <p:cNvSpPr txBox="1"/>
+          <p:nvPr/>
+        </p:nvSpPr>
+        <p:spPr>
+          <a:xfrm>
+            <a:off x="8352129" y="6460236"/>
+            <a:ext cx="3098901" cy="219456"/>
+          </a:xfrm>
+          <a:prstGeom prst="rect">
+            <a:avLst/>
+          </a:prstGeom>
+          <a:noFill/>
+        </p:spPr>
+        <p:txBody>
+          <a:bodyPr wrap="none" lIns="0" rIns="0" tIns="0" bIns="0">
+            <a:spAutoFit/>
+          </a:bodyPr>
+          <a:lstStyle/>
+          <a:p>
+            <a:pPr algn="l"/>
+            <a:r>
               <a:rPr sz="1000" b="1" i="0">
                 <a:solidFill>
-                  <a:srgbClr val="A7F3D0"/>
-                </a:solidFill>
-                <a:latin typeface="Helvetica Neue"/>
-              </a:rPr>
-              <a:t>▶ NOTEBOOK</a:t>
-            </a:r>
-          </a:p>
-        </p:txBody>
-      </p:sp>
-      <p:sp>
-        <p:nvSpPr>
-          <p:cNvPr id="18" name="TextBox 17"/>
-          <p:cNvSpPr txBox="1"/>
-          <p:nvPr/>
-        </p:nvSpPr>
-        <p:spPr>
-          <a:xfrm>
-            <a:off x="8056778" y="6451092"/>
-            <a:ext cx="760780" cy="219456"/>
-          </a:xfrm>
-          <a:prstGeom prst="rect">
-            <a:avLst/>
-          </a:prstGeom>
-          <a:noFill/>
-        </p:spPr>
-        <p:txBody>
-          <a:bodyPr wrap="none" lIns="0" rIns="0" tIns="0" bIns="0">
-            <a:spAutoFit/>
-          </a:bodyPr>
-          <a:lstStyle/>
-          <a:p>
-            <a:pPr algn="ctr"/>
-            <a:r>
-              <a:rPr sz="1150" b="1" i="0">
-                <a:solidFill>
                   <a:srgbClr val="FFFFFF"/>
                 </a:solidFill>
                 <a:latin typeface="Helvetica Neue"/>
               </a:rPr>
-              <a:t>CELL 3</a:t>
-            </a:r>
-          </a:p>
-        </p:txBody>
-      </p:sp>
-      <p:sp>
-        <p:nvSpPr>
-          <p:cNvPr id="19" name="TextBox 18"/>
-          <p:cNvSpPr txBox="1"/>
-          <p:nvPr/>
-        </p:nvSpPr>
-        <p:spPr>
-          <a:xfrm>
-            <a:off x="8945575" y="6460236"/>
-            <a:ext cx="2496312" cy="219456"/>
-          </a:xfrm>
-          <a:prstGeom prst="rect">
-            <a:avLst/>
-          </a:prstGeom>
-          <a:noFill/>
-        </p:spPr>
-        <p:txBody>
-          <a:bodyPr wrap="none" lIns="0" rIns="0" tIns="0" bIns="0">
-            <a:spAutoFit/>
-          </a:bodyPr>
-          <a:lstStyle/>
-          <a:p>
-            <a:pPr algn="l"/>
-            <a:r>
-              <a:rPr sz="1050" b="1" i="0">
-                <a:solidFill>
-                  <a:srgbClr val="FFFFFF"/>
-                </a:solidFill>
-                <a:latin typeface="Helvetica Neue"/>
-              </a:rPr>
-              <a:t>keyword vs semantic search</a:t>
+              <a:t>Turn tickets into vectors, then search</a:t>
             </a:r>
           </a:p>
         </p:txBody>
@@ -9652,8 +9652,8 @@
         </p:nvSpPr>
         <p:spPr>
           <a:xfrm>
-            <a:off x="7915960" y="6345936"/>
-            <a:ext cx="3635654" cy="365760"/>
+            <a:off x="7773314" y="6345936"/>
+            <a:ext cx="3778300" cy="365760"/>
           </a:xfrm>
           <a:prstGeom prst="roundRect">
             <a:avLst>
@@ -9697,8 +9697,8 @@
         </p:nvSpPr>
         <p:spPr>
           <a:xfrm>
-            <a:off x="9031528" y="6396228"/>
-            <a:ext cx="760780" cy="265176"/>
+            <a:off x="8815730" y="6396228"/>
+            <a:ext cx="685800" cy="265176"/>
           </a:xfrm>
           <a:prstGeom prst="roundRect">
             <a:avLst>
@@ -9742,8 +9742,8 @@
         </p:nvSpPr>
         <p:spPr>
           <a:xfrm>
-            <a:off x="8071408" y="6460236"/>
-            <a:ext cx="1024128" cy="219456"/>
+            <a:off x="7928762" y="6460236"/>
+            <a:ext cx="914400" cy="219456"/>
           </a:xfrm>
           <a:prstGeom prst="rect">
             <a:avLst/>
@@ -9758,83 +9758,83 @@
           <a:p>
             <a:pPr algn="l"/>
             <a:r>
+              <a:rPr sz="950" b="1" i="0">
+                <a:solidFill>
+                  <a:srgbClr val="A7F3D0"/>
+                </a:solidFill>
+                <a:latin typeface="Helvetica Neue"/>
+              </a:rPr>
+              <a:t>▶ NOTEBOOK</a:t>
+            </a:r>
+          </a:p>
+        </p:txBody>
+      </p:sp>
+      <p:sp>
+        <p:nvSpPr>
+          <p:cNvPr id="19" name="TextBox 18"/>
+          <p:cNvSpPr txBox="1"/>
+          <p:nvPr/>
+        </p:nvSpPr>
+        <p:spPr>
+          <a:xfrm>
+            <a:off x="8815730" y="6451092"/>
+            <a:ext cx="685800" cy="219456"/>
+          </a:xfrm>
+          <a:prstGeom prst="rect">
+            <a:avLst/>
+          </a:prstGeom>
+          <a:noFill/>
+        </p:spPr>
+        <p:txBody>
+          <a:bodyPr wrap="none" lIns="0" rIns="0" tIns="0" bIns="0">
+            <a:spAutoFit/>
+          </a:bodyPr>
+          <a:lstStyle/>
+          <a:p>
+            <a:pPr algn="ctr"/>
+            <a:r>
+              <a:rPr sz="1100" b="1" i="0">
+                <a:solidFill>
+                  <a:srgbClr val="FFFFFF"/>
+                </a:solidFill>
+                <a:latin typeface="Helvetica Neue"/>
+              </a:rPr>
+              <a:t>STEP 5</a:t>
+            </a:r>
+          </a:p>
+        </p:txBody>
+      </p:sp>
+      <p:sp>
+        <p:nvSpPr>
+          <p:cNvPr id="20" name="TextBox 19"/>
+          <p:cNvSpPr txBox="1"/>
+          <p:nvPr/>
+        </p:nvSpPr>
+        <p:spPr>
+          <a:xfrm>
+            <a:off x="9620402" y="6460236"/>
+            <a:ext cx="1830628" cy="219456"/>
+          </a:xfrm>
+          <a:prstGeom prst="rect">
+            <a:avLst/>
+          </a:prstGeom>
+          <a:noFill/>
+        </p:spPr>
+        <p:txBody>
+          <a:bodyPr wrap="none" lIns="0" rIns="0" tIns="0" bIns="0">
+            <a:spAutoFit/>
+          </a:bodyPr>
+          <a:lstStyle/>
+          <a:p>
+            <a:pPr algn="l"/>
+            <a:r>
               <a:rPr sz="1000" b="1" i="0">
                 <a:solidFill>
-                  <a:srgbClr val="A7F3D0"/>
-                </a:solidFill>
-                <a:latin typeface="Helvetica Neue"/>
-              </a:rPr>
-              <a:t>▶ NOTEBOOK</a:t>
-            </a:r>
-          </a:p>
-        </p:txBody>
-      </p:sp>
-      <p:sp>
-        <p:nvSpPr>
-          <p:cNvPr id="19" name="TextBox 18"/>
-          <p:cNvSpPr txBox="1"/>
-          <p:nvPr/>
-        </p:nvSpPr>
-        <p:spPr>
-          <a:xfrm>
-            <a:off x="9031528" y="6451092"/>
-            <a:ext cx="760780" cy="219456"/>
-          </a:xfrm>
-          <a:prstGeom prst="rect">
-            <a:avLst/>
-          </a:prstGeom>
-          <a:noFill/>
-        </p:spPr>
-        <p:txBody>
-          <a:bodyPr wrap="none" lIns="0" rIns="0" tIns="0" bIns="0">
-            <a:spAutoFit/>
-          </a:bodyPr>
-          <a:lstStyle/>
-          <a:p>
-            <a:pPr algn="ctr"/>
-            <a:r>
-              <a:rPr sz="1150" b="1" i="0">
-                <a:solidFill>
                   <a:srgbClr val="FFFFFF"/>
                 </a:solidFill>
                 <a:latin typeface="Helvetica Neue"/>
               </a:rPr>
-              <a:t>CELL 5</a:t>
-            </a:r>
-          </a:p>
-        </p:txBody>
-      </p:sp>
-      <p:sp>
-        <p:nvSpPr>
-          <p:cNvPr id="20" name="TextBox 19"/>
-          <p:cNvSpPr txBox="1"/>
-          <p:nvPr/>
-        </p:nvSpPr>
-        <p:spPr>
-          <a:xfrm>
-            <a:off x="9920325" y="6460236"/>
-            <a:ext cx="1521561" cy="219456"/>
-          </a:xfrm>
-          <a:prstGeom prst="rect">
-            <a:avLst/>
-          </a:prstGeom>
-          <a:noFill/>
-        </p:spPr>
-        <p:txBody>
-          <a:bodyPr wrap="none" lIns="0" rIns="0" tIns="0" bIns="0">
-            <a:spAutoFit/>
-          </a:bodyPr>
-          <a:lstStyle/>
-          <a:p>
-            <a:pPr algn="l"/>
-            <a:r>
-              <a:rPr sz="1050" b="1" i="0">
-                <a:solidFill>
-                  <a:srgbClr val="FFFFFF"/>
-                </a:solidFill>
-                <a:latin typeface="Helvetica Neue"/>
-              </a:rPr>
-              <a:t>the inbox map</a:t>
+              <a:t>Map the whole inbox</a:t>
             </a:r>
           </a:p>
         </p:txBody>
@@ -10357,8 +10357,8 @@
         </p:nvSpPr>
         <p:spPr>
           <a:xfrm>
-            <a:off x="6791248" y="6345936"/>
-            <a:ext cx="4760366" cy="365760"/>
+            <a:off x="6505041" y="6345936"/>
+            <a:ext cx="5046573" cy="365760"/>
           </a:xfrm>
           <a:prstGeom prst="roundRect">
             <a:avLst>
@@ -10402,8 +10402,8 @@
         </p:nvSpPr>
         <p:spPr>
           <a:xfrm>
-            <a:off x="7906816" y="6396228"/>
-            <a:ext cx="835761" cy="265176"/>
+            <a:off x="7547457" y="6396228"/>
+            <a:ext cx="754380" cy="265176"/>
           </a:xfrm>
           <a:prstGeom prst="roundRect">
             <a:avLst>
@@ -10447,8 +10447,8 @@
         </p:nvSpPr>
         <p:spPr>
           <a:xfrm>
-            <a:off x="6946696" y="6460236"/>
-            <a:ext cx="1024128" cy="219456"/>
+            <a:off x="6660489" y="6460236"/>
+            <a:ext cx="914400" cy="219456"/>
           </a:xfrm>
           <a:prstGeom prst="rect">
             <a:avLst/>
@@ -10463,83 +10463,83 @@
           <a:p>
             <a:pPr algn="l"/>
             <a:r>
+              <a:rPr sz="950" b="1" i="0">
+                <a:solidFill>
+                  <a:srgbClr val="A7F3D0"/>
+                </a:solidFill>
+                <a:latin typeface="Helvetica Neue"/>
+              </a:rPr>
+              <a:t>▶ NOTEBOOK</a:t>
+            </a:r>
+          </a:p>
+        </p:txBody>
+      </p:sp>
+      <p:sp>
+        <p:nvSpPr>
+          <p:cNvPr id="18" name="TextBox 17"/>
+          <p:cNvSpPr txBox="1"/>
+          <p:nvPr/>
+        </p:nvSpPr>
+        <p:spPr>
+          <a:xfrm>
+            <a:off x="7547457" y="6451092"/>
+            <a:ext cx="754380" cy="219456"/>
+          </a:xfrm>
+          <a:prstGeom prst="rect">
+            <a:avLst/>
+          </a:prstGeom>
+          <a:noFill/>
+        </p:spPr>
+        <p:txBody>
+          <a:bodyPr wrap="none" lIns="0" rIns="0" tIns="0" bIns="0">
+            <a:spAutoFit/>
+          </a:bodyPr>
+          <a:lstStyle/>
+          <a:p>
+            <a:pPr algn="ctr"/>
+            <a:r>
+              <a:rPr sz="1100" b="1" i="0">
+                <a:solidFill>
+                  <a:srgbClr val="FFFFFF"/>
+                </a:solidFill>
+                <a:latin typeface="Helvetica Neue"/>
+              </a:rPr>
+              <a:t>STEP 13</a:t>
+            </a:r>
+          </a:p>
+        </p:txBody>
+      </p:sp>
+      <p:sp>
+        <p:nvSpPr>
+          <p:cNvPr id="19" name="TextBox 18"/>
+          <p:cNvSpPr txBox="1"/>
+          <p:nvPr/>
+        </p:nvSpPr>
+        <p:spPr>
+          <a:xfrm>
+            <a:off x="8420709" y="6460236"/>
+            <a:ext cx="3030321" cy="219456"/>
+          </a:xfrm>
+          <a:prstGeom prst="rect">
+            <a:avLst/>
+          </a:prstGeom>
+          <a:noFill/>
+        </p:spPr>
+        <p:txBody>
+          <a:bodyPr wrap="none" lIns="0" rIns="0" tIns="0" bIns="0">
+            <a:spAutoFit/>
+          </a:bodyPr>
+          <a:lstStyle/>
+          <a:p>
+            <a:pPr algn="l"/>
+            <a:r>
               <a:rPr sz="1000" b="1" i="0">
                 <a:solidFill>
-                  <a:srgbClr val="A7F3D0"/>
-                </a:solidFill>
-                <a:latin typeface="Helvetica Neue"/>
-              </a:rPr>
-              <a:t>▶ NOTEBOOK</a:t>
-            </a:r>
-          </a:p>
-        </p:txBody>
-      </p:sp>
-      <p:sp>
-        <p:nvSpPr>
-          <p:cNvPr id="18" name="TextBox 17"/>
-          <p:cNvSpPr txBox="1"/>
-          <p:nvPr/>
-        </p:nvSpPr>
-        <p:spPr>
-          <a:xfrm>
-            <a:off x="7906816" y="6451092"/>
-            <a:ext cx="835761" cy="219456"/>
-          </a:xfrm>
-          <a:prstGeom prst="rect">
-            <a:avLst/>
-          </a:prstGeom>
-          <a:noFill/>
-        </p:spPr>
-        <p:txBody>
-          <a:bodyPr wrap="none" lIns="0" rIns="0" tIns="0" bIns="0">
-            <a:spAutoFit/>
-          </a:bodyPr>
-          <a:lstStyle/>
-          <a:p>
-            <a:pPr algn="ctr"/>
-            <a:r>
-              <a:rPr sz="1150" b="1" i="0">
-                <a:solidFill>
                   <a:srgbClr val="FFFFFF"/>
                 </a:solidFill>
                 <a:latin typeface="Helvetica Neue"/>
               </a:rPr>
-              <a:t>CELL 13</a:t>
-            </a:r>
-          </a:p>
-        </p:txBody>
-      </p:sp>
-      <p:sp>
-        <p:nvSpPr>
-          <p:cNvPr id="19" name="TextBox 18"/>
-          <p:cNvSpPr txBox="1"/>
-          <p:nvPr/>
-        </p:nvSpPr>
-        <p:spPr>
-          <a:xfrm>
-            <a:off x="8870594" y="6460236"/>
-            <a:ext cx="2571292" cy="219456"/>
-          </a:xfrm>
-          <a:prstGeom prst="rect">
-            <a:avLst/>
-          </a:prstGeom>
-          <a:noFill/>
-        </p:spPr>
-        <p:txBody>
-          <a:bodyPr wrap="none" lIns="0" rIns="0" tIns="0" bIns="0">
-            <a:spAutoFit/>
-          </a:bodyPr>
-          <a:lstStyle/>
-          <a:p>
-            <a:pPr algn="l"/>
-            <a:r>
-              <a:rPr sz="1050" b="1" i="0">
-                <a:solidFill>
-                  <a:srgbClr val="FFFFFF"/>
-                </a:solidFill>
-                <a:latin typeface="Helvetica Neue"/>
-              </a:rPr>
-              <a:t>route with no training data</a:t>
+              <a:t>Route the inbox with no training data</a:t>
             </a:r>
           </a:p>
         </p:txBody>
@@ -11097,8 +11097,8 @@
         </p:nvSpPr>
         <p:spPr>
           <a:xfrm>
-            <a:off x="7241133" y="6345936"/>
-            <a:ext cx="4310481" cy="365760"/>
+            <a:off x="7306056" y="6345936"/>
+            <a:ext cx="4245559" cy="365760"/>
           </a:xfrm>
           <a:prstGeom prst="roundRect">
             <a:avLst>
@@ -11142,8 +11142,8 @@
         </p:nvSpPr>
         <p:spPr>
           <a:xfrm>
-            <a:off x="8356701" y="6396228"/>
-            <a:ext cx="835761" cy="265176"/>
+            <a:off x="8348472" y="6396228"/>
+            <a:ext cx="754380" cy="265176"/>
           </a:xfrm>
           <a:prstGeom prst="roundRect">
             <a:avLst>
@@ -11187,8 +11187,8 @@
         </p:nvSpPr>
         <p:spPr>
           <a:xfrm>
-            <a:off x="7396581" y="6460236"/>
-            <a:ext cx="1024128" cy="219456"/>
+            <a:off x="7461504" y="6460236"/>
+            <a:ext cx="914400" cy="219456"/>
           </a:xfrm>
           <a:prstGeom prst="rect">
             <a:avLst/>
@@ -11203,83 +11203,83 @@
           <a:p>
             <a:pPr algn="l"/>
             <a:r>
+              <a:rPr sz="950" b="1" i="0">
+                <a:solidFill>
+                  <a:srgbClr val="A7F3D0"/>
+                </a:solidFill>
+                <a:latin typeface="Helvetica Neue"/>
+              </a:rPr>
+              <a:t>▶ NOTEBOOK</a:t>
+            </a:r>
+          </a:p>
+        </p:txBody>
+      </p:sp>
+      <p:sp>
+        <p:nvSpPr>
+          <p:cNvPr id="19" name="TextBox 18"/>
+          <p:cNvSpPr txBox="1"/>
+          <p:nvPr/>
+        </p:nvSpPr>
+        <p:spPr>
+          <a:xfrm>
+            <a:off x="8348472" y="6451092"/>
+            <a:ext cx="754380" cy="219456"/>
+          </a:xfrm>
+          <a:prstGeom prst="rect">
+            <a:avLst/>
+          </a:prstGeom>
+          <a:noFill/>
+        </p:spPr>
+        <p:txBody>
+          <a:bodyPr wrap="none" lIns="0" rIns="0" tIns="0" bIns="0">
+            <a:spAutoFit/>
+          </a:bodyPr>
+          <a:lstStyle/>
+          <a:p>
+            <a:pPr algn="ctr"/>
+            <a:r>
+              <a:rPr sz="1100" b="1" i="0">
+                <a:solidFill>
+                  <a:srgbClr val="FFFFFF"/>
+                </a:solidFill>
+                <a:latin typeface="Helvetica Neue"/>
+              </a:rPr>
+              <a:t>STEP 17</a:t>
+            </a:r>
+          </a:p>
+        </p:txBody>
+      </p:sp>
+      <p:sp>
+        <p:nvSpPr>
+          <p:cNvPr id="20" name="TextBox 19"/>
+          <p:cNvSpPr txBox="1"/>
+          <p:nvPr/>
+        </p:nvSpPr>
+        <p:spPr>
+          <a:xfrm>
+            <a:off x="9221724" y="6460236"/>
+            <a:ext cx="2229307" cy="219456"/>
+          </a:xfrm>
+          <a:prstGeom prst="rect">
+            <a:avLst/>
+          </a:prstGeom>
+          <a:noFill/>
+        </p:spPr>
+        <p:txBody>
+          <a:bodyPr wrap="none" lIns="0" rIns="0" tIns="0" bIns="0">
+            <a:spAutoFit/>
+          </a:bodyPr>
+          <a:lstStyle/>
+          <a:p>
+            <a:pPr algn="l"/>
+            <a:r>
               <a:rPr sz="1000" b="1" i="0">
                 <a:solidFill>
-                  <a:srgbClr val="A7F3D0"/>
-                </a:solidFill>
-                <a:latin typeface="Helvetica Neue"/>
-              </a:rPr>
-              <a:t>▶ NOTEBOOK</a:t>
-            </a:r>
-          </a:p>
-        </p:txBody>
-      </p:sp>
-      <p:sp>
-        <p:nvSpPr>
-          <p:cNvPr id="19" name="TextBox 18"/>
-          <p:cNvSpPr txBox="1"/>
-          <p:nvPr/>
-        </p:nvSpPr>
-        <p:spPr>
-          <a:xfrm>
-            <a:off x="8356701" y="6451092"/>
-            <a:ext cx="835761" cy="219456"/>
-          </a:xfrm>
-          <a:prstGeom prst="rect">
-            <a:avLst/>
-          </a:prstGeom>
-          <a:noFill/>
-        </p:spPr>
-        <p:txBody>
-          <a:bodyPr wrap="none" lIns="0" rIns="0" tIns="0" bIns="0">
-            <a:spAutoFit/>
-          </a:bodyPr>
-          <a:lstStyle/>
-          <a:p>
-            <a:pPr algn="ctr"/>
-            <a:r>
-              <a:rPr sz="1150" b="1" i="0">
-                <a:solidFill>
                   <a:srgbClr val="FFFFFF"/>
                 </a:solidFill>
                 <a:latin typeface="Helvetica Neue"/>
               </a:rPr>
-              <a:t>CELL 17</a:t>
-            </a:r>
-          </a:p>
-        </p:txBody>
-      </p:sp>
-      <p:sp>
-        <p:nvSpPr>
-          <p:cNvPr id="20" name="TextBox 19"/>
-          <p:cNvSpPr txBox="1"/>
-          <p:nvPr/>
-        </p:nvSpPr>
-        <p:spPr>
-          <a:xfrm>
-            <a:off x="9320479" y="6460236"/>
-            <a:ext cx="2121408" cy="219456"/>
-          </a:xfrm>
-          <a:prstGeom prst="rect">
-            <a:avLst/>
-          </a:prstGeom>
-          <a:noFill/>
-        </p:spPr>
-        <p:txBody>
-          <a:bodyPr wrap="none" lIns="0" rIns="0" tIns="0" bIns="0">
-            <a:spAutoFit/>
-          </a:bodyPr>
-          <a:lstStyle/>
-          <a:p>
-            <a:pPr algn="l"/>
-            <a:r>
-              <a:rPr sz="1050" b="1" i="0">
-                <a:solidFill>
-                  <a:srgbClr val="FFFFFF"/>
-                </a:solidFill>
-                <a:latin typeface="Helvetica Neue"/>
-              </a:rPr>
-              <a:t>the entailment scores</a:t>
+              <a:t>See the entailment scores</a:t>
             </a:r>
           </a:p>
         </p:txBody>
@@ -11837,8 +11837,8 @@
         </p:nvSpPr>
         <p:spPr>
           <a:xfrm>
-            <a:off x="6866229" y="6345936"/>
-            <a:ext cx="4685385" cy="365760"/>
+            <a:off x="7306056" y="6345936"/>
+            <a:ext cx="4245559" cy="365760"/>
           </a:xfrm>
           <a:prstGeom prst="roundRect">
             <a:avLst>
@@ -11882,8 +11882,8 @@
         </p:nvSpPr>
         <p:spPr>
           <a:xfrm>
-            <a:off x="7981797" y="6396228"/>
-            <a:ext cx="835761" cy="265176"/>
+            <a:off x="8348472" y="6396228"/>
+            <a:ext cx="754380" cy="265176"/>
           </a:xfrm>
           <a:prstGeom prst="roundRect">
             <a:avLst>
@@ -11927,8 +11927,8 @@
         </p:nvSpPr>
         <p:spPr>
           <a:xfrm>
-            <a:off x="7021677" y="6460236"/>
-            <a:ext cx="1024128" cy="219456"/>
+            <a:off x="7461504" y="6460236"/>
+            <a:ext cx="914400" cy="219456"/>
           </a:xfrm>
           <a:prstGeom prst="rect">
             <a:avLst/>
@@ -11943,83 +11943,83 @@
           <a:p>
             <a:pPr algn="l"/>
             <a:r>
+              <a:rPr sz="950" b="1" i="0">
+                <a:solidFill>
+                  <a:srgbClr val="A7F3D0"/>
+                </a:solidFill>
+                <a:latin typeface="Helvetica Neue"/>
+              </a:rPr>
+              <a:t>▶ NOTEBOOK</a:t>
+            </a:r>
+          </a:p>
+        </p:txBody>
+      </p:sp>
+      <p:sp>
+        <p:nvSpPr>
+          <p:cNvPr id="18" name="TextBox 17"/>
+          <p:cNvSpPr txBox="1"/>
+          <p:nvPr/>
+        </p:nvSpPr>
+        <p:spPr>
+          <a:xfrm>
+            <a:off x="8348472" y="6451092"/>
+            <a:ext cx="754380" cy="219456"/>
+          </a:xfrm>
+          <a:prstGeom prst="rect">
+            <a:avLst/>
+          </a:prstGeom>
+          <a:noFill/>
+        </p:spPr>
+        <p:txBody>
+          <a:bodyPr wrap="none" lIns="0" rIns="0" tIns="0" bIns="0">
+            <a:spAutoFit/>
+          </a:bodyPr>
+          <a:lstStyle/>
+          <a:p>
+            <a:pPr algn="ctr"/>
+            <a:r>
+              <a:rPr sz="1100" b="1" i="0">
+                <a:solidFill>
+                  <a:srgbClr val="FFFFFF"/>
+                </a:solidFill>
+                <a:latin typeface="Helvetica Neue"/>
+              </a:rPr>
+              <a:t>STEP 17</a:t>
+            </a:r>
+          </a:p>
+        </p:txBody>
+      </p:sp>
+      <p:sp>
+        <p:nvSpPr>
+          <p:cNvPr id="19" name="TextBox 18"/>
+          <p:cNvSpPr txBox="1"/>
+          <p:nvPr/>
+        </p:nvSpPr>
+        <p:spPr>
+          <a:xfrm>
+            <a:off x="9221724" y="6460236"/>
+            <a:ext cx="2229307" cy="219456"/>
+          </a:xfrm>
+          <a:prstGeom prst="rect">
+            <a:avLst/>
+          </a:prstGeom>
+          <a:noFill/>
+        </p:spPr>
+        <p:txBody>
+          <a:bodyPr wrap="none" lIns="0" rIns="0" tIns="0" bIns="0">
+            <a:spAutoFit/>
+          </a:bodyPr>
+          <a:lstStyle/>
+          <a:p>
+            <a:pPr algn="l"/>
+            <a:r>
               <a:rPr sz="1000" b="1" i="0">
                 <a:solidFill>
-                  <a:srgbClr val="A7F3D0"/>
-                </a:solidFill>
-                <a:latin typeface="Helvetica Neue"/>
-              </a:rPr>
-              <a:t>▶ NOTEBOOK</a:t>
-            </a:r>
-          </a:p>
-        </p:txBody>
-      </p:sp>
-      <p:sp>
-        <p:nvSpPr>
-          <p:cNvPr id="18" name="TextBox 17"/>
-          <p:cNvSpPr txBox="1"/>
-          <p:nvPr/>
-        </p:nvSpPr>
-        <p:spPr>
-          <a:xfrm>
-            <a:off x="7981797" y="6451092"/>
-            <a:ext cx="835761" cy="219456"/>
-          </a:xfrm>
-          <a:prstGeom prst="rect">
-            <a:avLst/>
-          </a:prstGeom>
-          <a:noFill/>
-        </p:spPr>
-        <p:txBody>
-          <a:bodyPr wrap="none" lIns="0" rIns="0" tIns="0" bIns="0">
-            <a:spAutoFit/>
-          </a:bodyPr>
-          <a:lstStyle/>
-          <a:p>
-            <a:pPr algn="ctr"/>
-            <a:r>
-              <a:rPr sz="1150" b="1" i="0">
-                <a:solidFill>
                   <a:srgbClr val="FFFFFF"/>
                 </a:solidFill>
                 <a:latin typeface="Helvetica Neue"/>
               </a:rPr>
-              <a:t>CELL 17</a:t>
-            </a:r>
-          </a:p>
-        </p:txBody>
-      </p:sp>
-      <p:sp>
-        <p:nvSpPr>
-          <p:cNvPr id="19" name="TextBox 18"/>
-          <p:cNvSpPr txBox="1"/>
-          <p:nvPr/>
-        </p:nvSpPr>
-        <p:spPr>
-          <a:xfrm>
-            <a:off x="8945575" y="6460236"/>
-            <a:ext cx="2496312" cy="219456"/>
-          </a:xfrm>
-          <a:prstGeom prst="rect">
-            <a:avLst/>
-          </a:prstGeom>
-          <a:noFill/>
-        </p:spPr>
-        <p:txBody>
-          <a:bodyPr wrap="none" lIns="0" rIns="0" tIns="0" bIns="0">
-            <a:spAutoFit/>
-          </a:bodyPr>
-          <a:lstStyle/>
-          <a:p>
-            <a:pPr algn="l"/>
-            <a:r>
-              <a:rPr sz="1050" b="1" i="0">
-                <a:solidFill>
-                  <a:srgbClr val="FFFFFF"/>
-                </a:solidFill>
-                <a:latin typeface="Helvetica Neue"/>
-              </a:rPr>
-              <a:t>same cell, read the logits</a:t>
+              <a:t>See the entailment scores</a:t>
             </a:r>
           </a:p>
         </p:txBody>
@@ -12542,8 +12542,8 @@
         </p:nvSpPr>
         <p:spPr>
           <a:xfrm>
-            <a:off x="6791248" y="6345936"/>
-            <a:ext cx="4760366" cy="365760"/>
+            <a:off x="6638544" y="6345936"/>
+            <a:ext cx="4913071" cy="365760"/>
           </a:xfrm>
           <a:prstGeom prst="roundRect">
             <a:avLst>
@@ -12587,8 +12587,8 @@
         </p:nvSpPr>
         <p:spPr>
           <a:xfrm>
-            <a:off x="7906816" y="6396228"/>
-            <a:ext cx="835761" cy="265176"/>
+            <a:off x="7680960" y="6396228"/>
+            <a:ext cx="754380" cy="265176"/>
           </a:xfrm>
           <a:prstGeom prst="roundRect">
             <a:avLst>
@@ -12632,8 +12632,8 @@
         </p:nvSpPr>
         <p:spPr>
           <a:xfrm>
-            <a:off x="6946696" y="6460236"/>
-            <a:ext cx="1024128" cy="219456"/>
+            <a:off x="6793992" y="6460236"/>
+            <a:ext cx="914400" cy="219456"/>
           </a:xfrm>
           <a:prstGeom prst="rect">
             <a:avLst/>
@@ -12648,83 +12648,83 @@
           <a:p>
             <a:pPr algn="l"/>
             <a:r>
+              <a:rPr sz="950" b="1" i="0">
+                <a:solidFill>
+                  <a:srgbClr val="A7F3D0"/>
+                </a:solidFill>
+                <a:latin typeface="Helvetica Neue"/>
+              </a:rPr>
+              <a:t>▶ NOTEBOOK</a:t>
+            </a:r>
+          </a:p>
+        </p:txBody>
+      </p:sp>
+      <p:sp>
+        <p:nvSpPr>
+          <p:cNvPr id="18" name="TextBox 17"/>
+          <p:cNvSpPr txBox="1"/>
+          <p:nvPr/>
+        </p:nvSpPr>
+        <p:spPr>
+          <a:xfrm>
+            <a:off x="7680960" y="6451092"/>
+            <a:ext cx="754380" cy="219456"/>
+          </a:xfrm>
+          <a:prstGeom prst="rect">
+            <a:avLst/>
+          </a:prstGeom>
+          <a:noFill/>
+        </p:spPr>
+        <p:txBody>
+          <a:bodyPr wrap="none" lIns="0" rIns="0" tIns="0" bIns="0">
+            <a:spAutoFit/>
+          </a:bodyPr>
+          <a:lstStyle/>
+          <a:p>
+            <a:pPr algn="ctr"/>
+            <a:r>
+              <a:rPr sz="1100" b="1" i="0">
+                <a:solidFill>
+                  <a:srgbClr val="FFFFFF"/>
+                </a:solidFill>
+                <a:latin typeface="Helvetica Neue"/>
+              </a:rPr>
+              <a:t>STEP 16</a:t>
+            </a:r>
+          </a:p>
+        </p:txBody>
+      </p:sp>
+      <p:sp>
+        <p:nvSpPr>
+          <p:cNvPr id="19" name="TextBox 18"/>
+          <p:cNvSpPr txBox="1"/>
+          <p:nvPr/>
+        </p:nvSpPr>
+        <p:spPr>
+          <a:xfrm>
+            <a:off x="8554212" y="6460236"/>
+            <a:ext cx="2896819" cy="219456"/>
+          </a:xfrm>
+          <a:prstGeom prst="rect">
+            <a:avLst/>
+          </a:prstGeom>
+          <a:noFill/>
+        </p:spPr>
+        <p:txBody>
+          <a:bodyPr wrap="none" lIns="0" rIns="0" tIns="0" bIns="0">
+            <a:spAutoFit/>
+          </a:bodyPr>
+          <a:lstStyle/>
+          <a:p>
+            <a:pPr algn="l"/>
+            <a:r>
               <a:rPr sz="1000" b="1" i="0">
                 <a:solidFill>
-                  <a:srgbClr val="A7F3D0"/>
-                </a:solidFill>
-                <a:latin typeface="Helvetica Neue"/>
-              </a:rPr>
-              <a:t>▶ NOTEBOOK</a:t>
-            </a:r>
-          </a:p>
-        </p:txBody>
-      </p:sp>
-      <p:sp>
-        <p:nvSpPr>
-          <p:cNvPr id="18" name="TextBox 17"/>
-          <p:cNvSpPr txBox="1"/>
-          <p:nvPr/>
-        </p:nvSpPr>
-        <p:spPr>
-          <a:xfrm>
-            <a:off x="7906816" y="6451092"/>
-            <a:ext cx="835761" cy="219456"/>
-          </a:xfrm>
-          <a:prstGeom prst="rect">
-            <a:avLst/>
-          </a:prstGeom>
-          <a:noFill/>
-        </p:spPr>
-        <p:txBody>
-          <a:bodyPr wrap="none" lIns="0" rIns="0" tIns="0" bIns="0">
-            <a:spAutoFit/>
-          </a:bodyPr>
-          <a:lstStyle/>
-          <a:p>
-            <a:pPr algn="ctr"/>
-            <a:r>
-              <a:rPr sz="1150" b="1" i="0">
-                <a:solidFill>
                   <a:srgbClr val="FFFFFF"/>
                 </a:solidFill>
                 <a:latin typeface="Helvetica Neue"/>
               </a:rPr>
-              <a:t>CELL 16</a:t>
-            </a:r>
-          </a:p>
-        </p:txBody>
-      </p:sp>
-      <p:sp>
-        <p:nvSpPr>
-          <p:cNvPr id="19" name="TextBox 18"/>
-          <p:cNvSpPr txBox="1"/>
-          <p:nvPr/>
-        </p:nvSpPr>
-        <p:spPr>
-          <a:xfrm>
-            <a:off x="8870594" y="6460236"/>
-            <a:ext cx="2571292" cy="219456"/>
-          </a:xfrm>
-          <a:prstGeom prst="rect">
-            <a:avLst/>
-          </a:prstGeom>
-          <a:noFill/>
-        </p:spPr>
-        <p:txBody>
-          <a:bodyPr wrap="none" lIns="0" rIns="0" tIns="0" bIns="0">
-            <a:spAutoFit/>
-          </a:bodyPr>
-          <a:lstStyle/>
-          <a:p>
-            <a:pPr algn="l"/>
-            <a:r>
-              <a:rPr sz="1050" b="1" i="0">
-                <a:solidFill>
-                  <a:srgbClr val="FFFFFF"/>
-                </a:solidFill>
-                <a:latin typeface="Helvetica Neue"/>
-              </a:rPr>
-              <a:t>YOUR KNOB: the descriptions</a:t>
+              <a:t>YOUR KNOB: rewrite the descriptions</a:t>
             </a:r>
           </a:p>
         </p:txBody>
@@ -13282,8 +13282,8 @@
         </p:nvSpPr>
         <p:spPr>
           <a:xfrm>
-            <a:off x="7541056" y="6345936"/>
-            <a:ext cx="4010558" cy="365760"/>
+            <a:off x="7573060" y="6345936"/>
+            <a:ext cx="3978554" cy="365760"/>
           </a:xfrm>
           <a:prstGeom prst="roundRect">
             <a:avLst>
@@ -13327,8 +13327,8 @@
         </p:nvSpPr>
         <p:spPr>
           <a:xfrm>
-            <a:off x="8656624" y="6396228"/>
-            <a:ext cx="835761" cy="265176"/>
+            <a:off x="8615476" y="6396228"/>
+            <a:ext cx="754380" cy="265176"/>
           </a:xfrm>
           <a:prstGeom prst="roundRect">
             <a:avLst>
@@ -13372,8 +13372,8 @@
         </p:nvSpPr>
         <p:spPr>
           <a:xfrm>
-            <a:off x="7696504" y="6460236"/>
-            <a:ext cx="1024128" cy="219456"/>
+            <a:off x="7728508" y="6460236"/>
+            <a:ext cx="914400" cy="219456"/>
           </a:xfrm>
           <a:prstGeom prst="rect">
             <a:avLst/>
@@ -13388,83 +13388,83 @@
           <a:p>
             <a:pPr algn="l"/>
             <a:r>
+              <a:rPr sz="950" b="1" i="0">
+                <a:solidFill>
+                  <a:srgbClr val="A7F3D0"/>
+                </a:solidFill>
+                <a:latin typeface="Helvetica Neue"/>
+              </a:rPr>
+              <a:t>▶ NOTEBOOK</a:t>
+            </a:r>
+          </a:p>
+        </p:txBody>
+      </p:sp>
+      <p:sp>
+        <p:nvSpPr>
+          <p:cNvPr id="19" name="TextBox 18"/>
+          <p:cNvSpPr txBox="1"/>
+          <p:nvPr/>
+        </p:nvSpPr>
+        <p:spPr>
+          <a:xfrm>
+            <a:off x="8615476" y="6451092"/>
+            <a:ext cx="754380" cy="219456"/>
+          </a:xfrm>
+          <a:prstGeom prst="rect">
+            <a:avLst/>
+          </a:prstGeom>
+          <a:noFill/>
+        </p:spPr>
+        <p:txBody>
+          <a:bodyPr wrap="none" lIns="0" rIns="0" tIns="0" bIns="0">
+            <a:spAutoFit/>
+          </a:bodyPr>
+          <a:lstStyle/>
+          <a:p>
+            <a:pPr algn="ctr"/>
+            <a:r>
+              <a:rPr sz="1100" b="1" i="0">
+                <a:solidFill>
+                  <a:srgbClr val="FFFFFF"/>
+                </a:solidFill>
+                <a:latin typeface="Helvetica Neue"/>
+              </a:rPr>
+              <a:t>STEP 18</a:t>
+            </a:r>
+          </a:p>
+        </p:txBody>
+      </p:sp>
+      <p:sp>
+        <p:nvSpPr>
+          <p:cNvPr id="20" name="TextBox 19"/>
+          <p:cNvSpPr txBox="1"/>
+          <p:nvPr/>
+        </p:nvSpPr>
+        <p:spPr>
+          <a:xfrm>
+            <a:off x="9488728" y="6460236"/>
+            <a:ext cx="1962302" cy="219456"/>
+          </a:xfrm>
+          <a:prstGeom prst="rect">
+            <a:avLst/>
+          </a:prstGeom>
+          <a:noFill/>
+        </p:spPr>
+        <p:txBody>
+          <a:bodyPr wrap="none" lIns="0" rIns="0" tIns="0" bIns="0">
+            <a:spAutoFit/>
+          </a:bodyPr>
+          <a:lstStyle/>
+          <a:p>
+            <a:pPr algn="l"/>
+            <a:r>
               <a:rPr sz="1000" b="1" i="0">
                 <a:solidFill>
-                  <a:srgbClr val="A7F3D0"/>
-                </a:solidFill>
-                <a:latin typeface="Helvetica Neue"/>
-              </a:rPr>
-              <a:t>▶ NOTEBOOK</a:t>
-            </a:r>
-          </a:p>
-        </p:txBody>
-      </p:sp>
-      <p:sp>
-        <p:nvSpPr>
-          <p:cNvPr id="19" name="TextBox 18"/>
-          <p:cNvSpPr txBox="1"/>
-          <p:nvPr/>
-        </p:nvSpPr>
-        <p:spPr>
-          <a:xfrm>
-            <a:off x="8656624" y="6451092"/>
-            <a:ext cx="835761" cy="219456"/>
-          </a:xfrm>
-          <a:prstGeom prst="rect">
-            <a:avLst/>
-          </a:prstGeom>
-          <a:noFill/>
-        </p:spPr>
-        <p:txBody>
-          <a:bodyPr wrap="none" lIns="0" rIns="0" tIns="0" bIns="0">
-            <a:spAutoFit/>
-          </a:bodyPr>
-          <a:lstStyle/>
-          <a:p>
-            <a:pPr algn="ctr"/>
-            <a:r>
-              <a:rPr sz="1150" b="1" i="0">
-                <a:solidFill>
                   <a:srgbClr val="FFFFFF"/>
                 </a:solidFill>
                 <a:latin typeface="Helvetica Neue"/>
               </a:rPr>
-              <a:t>CELL 18</a:t>
-            </a:r>
-          </a:p>
-        </p:txBody>
-      </p:sp>
-      <p:sp>
-        <p:nvSpPr>
-          <p:cNvPr id="20" name="TextBox 19"/>
-          <p:cNvSpPr txBox="1"/>
-          <p:nvPr/>
-        </p:nvSpPr>
-        <p:spPr>
-          <a:xfrm>
-            <a:off x="9620402" y="6460236"/>
-            <a:ext cx="1821484" cy="219456"/>
-          </a:xfrm>
-          <a:prstGeom prst="rect">
-            <a:avLst/>
-          </a:prstGeom>
-          <a:noFill/>
-        </p:spPr>
-        <p:txBody>
-          <a:bodyPr wrap="none" lIns="0" rIns="0" tIns="0" bIns="0">
-            <a:spAutoFit/>
-          </a:bodyPr>
-          <a:lstStyle/>
-          <a:p>
-            <a:pPr algn="l"/>
-            <a:r>
-              <a:rPr sz="1050" b="1" i="0">
-                <a:solidFill>
-                  <a:srgbClr val="FFFFFF"/>
-                </a:solidFill>
-                <a:latin typeface="Helvetica Neue"/>
-              </a:rPr>
-              <a:t>per-bucket recall</a:t>
+              <a:t>Find the weak buckets</a:t>
             </a:r>
           </a:p>
         </p:txBody>
@@ -14590,8 +14590,8 @@
         </p:nvSpPr>
         <p:spPr>
           <a:xfrm>
-            <a:off x="7316114" y="6345936"/>
-            <a:ext cx="4235500" cy="365760"/>
+            <a:off x="7172553" y="6345936"/>
+            <a:ext cx="4379061" cy="365760"/>
           </a:xfrm>
           <a:prstGeom prst="roundRect">
             <a:avLst>
@@ -14635,8 +14635,8 @@
         </p:nvSpPr>
         <p:spPr>
           <a:xfrm>
-            <a:off x="8431682" y="6396228"/>
-            <a:ext cx="835761" cy="265176"/>
+            <a:off x="8214969" y="6396228"/>
+            <a:ext cx="754380" cy="265176"/>
           </a:xfrm>
           <a:prstGeom prst="roundRect">
             <a:avLst>
@@ -14680,8 +14680,8 @@
         </p:nvSpPr>
         <p:spPr>
           <a:xfrm>
-            <a:off x="7471562" y="6460236"/>
-            <a:ext cx="1024128" cy="219456"/>
+            <a:off x="7328001" y="6460236"/>
+            <a:ext cx="914400" cy="219456"/>
           </a:xfrm>
           <a:prstGeom prst="rect">
             <a:avLst/>
@@ -14696,83 +14696,83 @@
           <a:p>
             <a:pPr algn="l"/>
             <a:r>
+              <a:rPr sz="950" b="1" i="0">
+                <a:solidFill>
+                  <a:srgbClr val="A7F3D0"/>
+                </a:solidFill>
+                <a:latin typeface="Helvetica Neue"/>
+              </a:rPr>
+              <a:t>▶ NOTEBOOK</a:t>
+            </a:r>
+          </a:p>
+        </p:txBody>
+      </p:sp>
+      <p:sp>
+        <p:nvSpPr>
+          <p:cNvPr id="18" name="TextBox 17"/>
+          <p:cNvSpPr txBox="1"/>
+          <p:nvPr/>
+        </p:nvSpPr>
+        <p:spPr>
+          <a:xfrm>
+            <a:off x="8214969" y="6451092"/>
+            <a:ext cx="754380" cy="219456"/>
+          </a:xfrm>
+          <a:prstGeom prst="rect">
+            <a:avLst/>
+          </a:prstGeom>
+          <a:noFill/>
+        </p:spPr>
+        <p:txBody>
+          <a:bodyPr wrap="none" lIns="0" rIns="0" tIns="0" bIns="0">
+            <a:spAutoFit/>
+          </a:bodyPr>
+          <a:lstStyle/>
+          <a:p>
+            <a:pPr algn="ctr"/>
+            <a:r>
+              <a:rPr sz="1100" b="1" i="0">
+                <a:solidFill>
+                  <a:srgbClr val="FFFFFF"/>
+                </a:solidFill>
+                <a:latin typeface="Helvetica Neue"/>
+              </a:rPr>
+              <a:t>STEP 19</a:t>
+            </a:r>
+          </a:p>
+        </p:txBody>
+      </p:sp>
+      <p:sp>
+        <p:nvSpPr>
+          <p:cNvPr id="19" name="TextBox 18"/>
+          <p:cNvSpPr txBox="1"/>
+          <p:nvPr/>
+        </p:nvSpPr>
+        <p:spPr>
+          <a:xfrm>
+            <a:off x="9088221" y="6460236"/>
+            <a:ext cx="2362809" cy="219456"/>
+          </a:xfrm>
+          <a:prstGeom prst="rect">
+            <a:avLst/>
+          </a:prstGeom>
+          <a:noFill/>
+        </p:spPr>
+        <p:txBody>
+          <a:bodyPr wrap="none" lIns="0" rIns="0" tIns="0" bIns="0">
+            <a:spAutoFit/>
+          </a:bodyPr>
+          <a:lstStyle/>
+          <a:p>
+            <a:pPr algn="l"/>
+            <a:r>
               <a:rPr sz="1000" b="1" i="0">
                 <a:solidFill>
-                  <a:srgbClr val="A7F3D0"/>
-                </a:solidFill>
-                <a:latin typeface="Helvetica Neue"/>
-              </a:rPr>
-              <a:t>▶ NOTEBOOK</a:t>
-            </a:r>
-          </a:p>
-        </p:txBody>
-      </p:sp>
-      <p:sp>
-        <p:nvSpPr>
-          <p:cNvPr id="18" name="TextBox 17"/>
-          <p:cNvSpPr txBox="1"/>
-          <p:nvPr/>
-        </p:nvSpPr>
-        <p:spPr>
-          <a:xfrm>
-            <a:off x="8431682" y="6451092"/>
-            <a:ext cx="835761" cy="219456"/>
-          </a:xfrm>
-          <a:prstGeom prst="rect">
-            <a:avLst/>
-          </a:prstGeom>
-          <a:noFill/>
-        </p:spPr>
-        <p:txBody>
-          <a:bodyPr wrap="none" lIns="0" rIns="0" tIns="0" bIns="0">
-            <a:spAutoFit/>
-          </a:bodyPr>
-          <a:lstStyle/>
-          <a:p>
-            <a:pPr algn="ctr"/>
-            <a:r>
-              <a:rPr sz="1150" b="1" i="0">
-                <a:solidFill>
                   <a:srgbClr val="FFFFFF"/>
                 </a:solidFill>
                 <a:latin typeface="Helvetica Neue"/>
               </a:rPr>
-              <a:t>CELL 19</a:t>
-            </a:r>
-          </a:p>
-        </p:txBody>
-      </p:sp>
-      <p:sp>
-        <p:nvSpPr>
-          <p:cNvPr id="19" name="TextBox 18"/>
-          <p:cNvSpPr txBox="1"/>
-          <p:nvPr/>
-        </p:nvSpPr>
-        <p:spPr>
-          <a:xfrm>
-            <a:off x="9395460" y="6460236"/>
-            <a:ext cx="2046427" cy="219456"/>
-          </a:xfrm>
-          <a:prstGeom prst="rect">
-            <a:avLst/>
-          </a:prstGeom>
-          <a:noFill/>
-        </p:spPr>
-        <p:txBody>
-          <a:bodyPr wrap="none" lIns="0" rIns="0" tIns="0" bIns="0">
-            <a:spAutoFit/>
-          </a:bodyPr>
-          <a:lstStyle/>
-          <a:p>
-            <a:pPr algn="l"/>
-            <a:r>
-              <a:rPr sz="1050" b="1" i="0">
-                <a:solidFill>
-                  <a:srgbClr val="FFFFFF"/>
-                </a:solidFill>
-                <a:latin typeface="Helvetica Neue"/>
-              </a:rPr>
-              <a:t>the off-topic ticket</a:t>
+              <a:t>Feed it an off-topic ticket</a:t>
             </a:r>
           </a:p>
         </p:txBody>
@@ -15295,8 +15295,8 @@
         </p:nvSpPr>
         <p:spPr>
           <a:xfrm>
-            <a:off x="7616037" y="6345936"/>
-            <a:ext cx="3935577" cy="365760"/>
+            <a:off x="7639812" y="6345936"/>
+            <a:ext cx="3911803" cy="365760"/>
           </a:xfrm>
           <a:prstGeom prst="roundRect">
             <a:avLst>
@@ -15340,8 +15340,8 @@
         </p:nvSpPr>
         <p:spPr>
           <a:xfrm>
-            <a:off x="8731605" y="6396228"/>
-            <a:ext cx="835761" cy="265176"/>
+            <a:off x="8682228" y="6396228"/>
+            <a:ext cx="754380" cy="265176"/>
           </a:xfrm>
           <a:prstGeom prst="roundRect">
             <a:avLst>
@@ -15385,8 +15385,8 @@
         </p:nvSpPr>
         <p:spPr>
           <a:xfrm>
-            <a:off x="7771485" y="6460236"/>
-            <a:ext cx="1024128" cy="219456"/>
+            <a:off x="7795260" y="6460236"/>
+            <a:ext cx="914400" cy="219456"/>
           </a:xfrm>
           <a:prstGeom prst="rect">
             <a:avLst/>
@@ -15401,83 +15401,83 @@
           <a:p>
             <a:pPr algn="l"/>
             <a:r>
+              <a:rPr sz="950" b="1" i="0">
+                <a:solidFill>
+                  <a:srgbClr val="A7F3D0"/>
+                </a:solidFill>
+                <a:latin typeface="Helvetica Neue"/>
+              </a:rPr>
+              <a:t>▶ NOTEBOOK</a:t>
+            </a:r>
+          </a:p>
+        </p:txBody>
+      </p:sp>
+      <p:sp>
+        <p:nvSpPr>
+          <p:cNvPr id="18" name="TextBox 17"/>
+          <p:cNvSpPr txBox="1"/>
+          <p:nvPr/>
+        </p:nvSpPr>
+        <p:spPr>
+          <a:xfrm>
+            <a:off x="8682228" y="6451092"/>
+            <a:ext cx="754380" cy="219456"/>
+          </a:xfrm>
+          <a:prstGeom prst="rect">
+            <a:avLst/>
+          </a:prstGeom>
+          <a:noFill/>
+        </p:spPr>
+        <p:txBody>
+          <a:bodyPr wrap="none" lIns="0" rIns="0" tIns="0" bIns="0">
+            <a:spAutoFit/>
+          </a:bodyPr>
+          <a:lstStyle/>
+          <a:p>
+            <a:pPr algn="ctr"/>
+            <a:r>
+              <a:rPr sz="1100" b="1" i="0">
+                <a:solidFill>
+                  <a:srgbClr val="FFFFFF"/>
+                </a:solidFill>
+                <a:latin typeface="Helvetica Neue"/>
+              </a:rPr>
+              <a:t>STEP 20</a:t>
+            </a:r>
+          </a:p>
+        </p:txBody>
+      </p:sp>
+      <p:sp>
+        <p:nvSpPr>
+          <p:cNvPr id="19" name="TextBox 18"/>
+          <p:cNvSpPr txBox="1"/>
+          <p:nvPr/>
+        </p:nvSpPr>
+        <p:spPr>
+          <a:xfrm>
+            <a:off x="9555480" y="6460236"/>
+            <a:ext cx="1895551" cy="219456"/>
+          </a:xfrm>
+          <a:prstGeom prst="rect">
+            <a:avLst/>
+          </a:prstGeom>
+          <a:noFill/>
+        </p:spPr>
+        <p:txBody>
+          <a:bodyPr wrap="none" lIns="0" rIns="0" tIns="0" bIns="0">
+            <a:spAutoFit/>
+          </a:bodyPr>
+          <a:lstStyle/>
+          <a:p>
+            <a:pPr algn="l"/>
+            <a:r>
               <a:rPr sz="1000" b="1" i="0">
                 <a:solidFill>
-                  <a:srgbClr val="A7F3D0"/>
-                </a:solidFill>
-                <a:latin typeface="Helvetica Neue"/>
-              </a:rPr>
-              <a:t>▶ NOTEBOOK</a:t>
-            </a:r>
-          </a:p>
-        </p:txBody>
-      </p:sp>
-      <p:sp>
-        <p:nvSpPr>
-          <p:cNvPr id="18" name="TextBox 17"/>
-          <p:cNvSpPr txBox="1"/>
-          <p:nvPr/>
-        </p:nvSpPr>
-        <p:spPr>
-          <a:xfrm>
-            <a:off x="8731605" y="6451092"/>
-            <a:ext cx="835761" cy="219456"/>
-          </a:xfrm>
-          <a:prstGeom prst="rect">
-            <a:avLst/>
-          </a:prstGeom>
-          <a:noFill/>
-        </p:spPr>
-        <p:txBody>
-          <a:bodyPr wrap="none" lIns="0" rIns="0" tIns="0" bIns="0">
-            <a:spAutoFit/>
-          </a:bodyPr>
-          <a:lstStyle/>
-          <a:p>
-            <a:pPr algn="ctr"/>
-            <a:r>
-              <a:rPr sz="1150" b="1" i="0">
-                <a:solidFill>
                   <a:srgbClr val="FFFFFF"/>
                 </a:solidFill>
                 <a:latin typeface="Helvetica Neue"/>
               </a:rPr>
-              <a:t>CELL 20</a:t>
-            </a:r>
-          </a:p>
-        </p:txBody>
-      </p:sp>
-      <p:sp>
-        <p:nvSpPr>
-          <p:cNvPr id="19" name="TextBox 18"/>
-          <p:cNvSpPr txBox="1"/>
-          <p:nvPr/>
-        </p:nvSpPr>
-        <p:spPr>
-          <a:xfrm>
-            <a:off x="9695383" y="6460236"/>
-            <a:ext cx="1746504" cy="219456"/>
-          </a:xfrm>
-          <a:prstGeom prst="rect">
-            <a:avLst/>
-          </a:prstGeom>
-          <a:noFill/>
-        </p:spPr>
-        <p:txBody>
-          <a:bodyPr wrap="none" lIns="0" rIns="0" tIns="0" bIns="0">
-            <a:spAutoFit/>
-          </a:bodyPr>
-          <a:lstStyle/>
-          <a:p>
-            <a:pPr algn="l"/>
-            <a:r>
-              <a:rPr sz="1050" b="1" i="0">
-                <a:solidFill>
-                  <a:srgbClr val="FFFFFF"/>
-                </a:solidFill>
-                <a:latin typeface="Helvetica Neue"/>
-              </a:rPr>
-              <a:t>the two defences</a:t>
+              <a:t>Add the two defences</a:t>
             </a:r>
           </a:p>
         </p:txBody>
@@ -16325,8 +16325,8 @@
         </p:nvSpPr>
         <p:spPr>
           <a:xfrm>
-            <a:off x="7016191" y="6345936"/>
-            <a:ext cx="4535424" cy="365760"/>
+            <a:off x="7105802" y="6345936"/>
+            <a:ext cx="4445812" cy="365760"/>
           </a:xfrm>
           <a:prstGeom prst="roundRect">
             <a:avLst>
@@ -16370,8 +16370,8 @@
         </p:nvSpPr>
         <p:spPr>
           <a:xfrm>
-            <a:off x="8131759" y="6396228"/>
-            <a:ext cx="835761" cy="265176"/>
+            <a:off x="8148218" y="6396228"/>
+            <a:ext cx="754380" cy="265176"/>
           </a:xfrm>
           <a:prstGeom prst="roundRect">
             <a:avLst>
@@ -16415,8 +16415,8 @@
         </p:nvSpPr>
         <p:spPr>
           <a:xfrm>
-            <a:off x="7171639" y="6460236"/>
-            <a:ext cx="1024128" cy="219456"/>
+            <a:off x="7261250" y="6460236"/>
+            <a:ext cx="914400" cy="219456"/>
           </a:xfrm>
           <a:prstGeom prst="rect">
             <a:avLst/>
@@ -16431,83 +16431,83 @@
           <a:p>
             <a:pPr algn="l"/>
             <a:r>
+              <a:rPr sz="950" b="1" i="0">
+                <a:solidFill>
+                  <a:srgbClr val="A7F3D0"/>
+                </a:solidFill>
+                <a:latin typeface="Helvetica Neue"/>
+              </a:rPr>
+              <a:t>▶ NOTEBOOK</a:t>
+            </a:r>
+          </a:p>
+        </p:txBody>
+      </p:sp>
+      <p:sp>
+        <p:nvSpPr>
+          <p:cNvPr id="27" name="TextBox 26"/>
+          <p:cNvSpPr txBox="1"/>
+          <p:nvPr/>
+        </p:nvSpPr>
+        <p:spPr>
+          <a:xfrm>
+            <a:off x="8148218" y="6451092"/>
+            <a:ext cx="754380" cy="219456"/>
+          </a:xfrm>
+          <a:prstGeom prst="rect">
+            <a:avLst/>
+          </a:prstGeom>
+          <a:noFill/>
+        </p:spPr>
+        <p:txBody>
+          <a:bodyPr wrap="none" lIns="0" rIns="0" tIns="0" bIns="0">
+            <a:spAutoFit/>
+          </a:bodyPr>
+          <a:lstStyle/>
+          <a:p>
+            <a:pPr algn="ctr"/>
+            <a:r>
+              <a:rPr sz="1100" b="1" i="0">
+                <a:solidFill>
+                  <a:srgbClr val="FFFFFF"/>
+                </a:solidFill>
+                <a:latin typeface="Helvetica Neue"/>
+              </a:rPr>
+              <a:t>STEP 21</a:t>
+            </a:r>
+          </a:p>
+        </p:txBody>
+      </p:sp>
+      <p:sp>
+        <p:nvSpPr>
+          <p:cNvPr id="28" name="TextBox 27"/>
+          <p:cNvSpPr txBox="1"/>
+          <p:nvPr/>
+        </p:nvSpPr>
+        <p:spPr>
+          <a:xfrm>
+            <a:off x="9021470" y="6460236"/>
+            <a:ext cx="2429560" cy="219456"/>
+          </a:xfrm>
+          <a:prstGeom prst="rect">
+            <a:avLst/>
+          </a:prstGeom>
+          <a:noFill/>
+        </p:spPr>
+        <p:txBody>
+          <a:bodyPr wrap="none" lIns="0" rIns="0" tIns="0" bIns="0">
+            <a:spAutoFit/>
+          </a:bodyPr>
+          <a:lstStyle/>
+          <a:p>
+            <a:pPr algn="l"/>
+            <a:r>
               <a:rPr sz="1000" b="1" i="0">
                 <a:solidFill>
-                  <a:srgbClr val="A7F3D0"/>
-                </a:solidFill>
-                <a:latin typeface="Helvetica Neue"/>
-              </a:rPr>
-              <a:t>▶ NOTEBOOK</a:t>
-            </a:r>
-          </a:p>
-        </p:txBody>
-      </p:sp>
-      <p:sp>
-        <p:nvSpPr>
-          <p:cNvPr id="27" name="TextBox 26"/>
-          <p:cNvSpPr txBox="1"/>
-          <p:nvPr/>
-        </p:nvSpPr>
-        <p:spPr>
-          <a:xfrm>
-            <a:off x="8131759" y="6451092"/>
-            <a:ext cx="835761" cy="219456"/>
-          </a:xfrm>
-          <a:prstGeom prst="rect">
-            <a:avLst/>
-          </a:prstGeom>
-          <a:noFill/>
-        </p:spPr>
-        <p:txBody>
-          <a:bodyPr wrap="none" lIns="0" rIns="0" tIns="0" bIns="0">
-            <a:spAutoFit/>
-          </a:bodyPr>
-          <a:lstStyle/>
-          <a:p>
-            <a:pPr algn="ctr"/>
-            <a:r>
-              <a:rPr sz="1150" b="1" i="0">
-                <a:solidFill>
                   <a:srgbClr val="FFFFFF"/>
                 </a:solidFill>
                 <a:latin typeface="Helvetica Neue"/>
               </a:rPr>
-              <a:t>CELL 21</a:t>
-            </a:r>
-          </a:p>
-        </p:txBody>
-      </p:sp>
-      <p:sp>
-        <p:nvSpPr>
-          <p:cNvPr id="28" name="TextBox 27"/>
-          <p:cNvSpPr txBox="1"/>
-          <p:nvPr/>
-        </p:nvSpPr>
-        <p:spPr>
-          <a:xfrm>
-            <a:off x="9095536" y="6460236"/>
-            <a:ext cx="2346350" cy="219456"/>
-          </a:xfrm>
-          <a:prstGeom prst="rect">
-            <a:avLst/>
-          </a:prstGeom>
-          <a:noFill/>
-        </p:spPr>
-        <p:txBody>
-          <a:bodyPr wrap="none" lIns="0" rIns="0" tIns="0" bIns="0">
-            <a:spAutoFit/>
-          </a:bodyPr>
-          <a:lstStyle/>
-          <a:p>
-            <a:pPr algn="l"/>
-            <a:r>
-              <a:rPr sz="1050" b="1" i="0">
-                <a:solidFill>
-                  <a:srgbClr val="FFFFFF"/>
-                </a:solidFill>
-                <a:latin typeface="Helvetica Neue"/>
-              </a:rPr>
-              <a:t>YOUR KNOB: the threshold</a:t>
+              <a:t>YOUR KNOB: set the threshold</a:t>
             </a:r>
           </a:p>
         </p:txBody>
@@ -19243,8 +19243,8 @@
         </p:nvSpPr>
         <p:spPr>
           <a:xfrm>
-            <a:off x="7316114" y="6345936"/>
-            <a:ext cx="4235500" cy="365760"/>
+            <a:off x="7573060" y="6345936"/>
+            <a:ext cx="3978554" cy="365760"/>
           </a:xfrm>
           <a:prstGeom prst="roundRect">
             <a:avLst>
@@ -19288,8 +19288,8 @@
         </p:nvSpPr>
         <p:spPr>
           <a:xfrm>
-            <a:off x="8431682" y="6396228"/>
-            <a:ext cx="760780" cy="265176"/>
+            <a:off x="8615476" y="6396228"/>
+            <a:ext cx="685800" cy="265176"/>
           </a:xfrm>
           <a:prstGeom prst="roundRect">
             <a:avLst>
@@ -19333,8 +19333,8 @@
         </p:nvSpPr>
         <p:spPr>
           <a:xfrm>
-            <a:off x="7471562" y="6460236"/>
-            <a:ext cx="1024128" cy="219456"/>
+            <a:off x="7728508" y="6460236"/>
+            <a:ext cx="914400" cy="219456"/>
           </a:xfrm>
           <a:prstGeom prst="rect">
             <a:avLst/>
@@ -19349,83 +19349,83 @@
           <a:p>
             <a:pPr algn="l"/>
             <a:r>
+              <a:rPr sz="950" b="1" i="0">
+                <a:solidFill>
+                  <a:srgbClr val="A7F3D0"/>
+                </a:solidFill>
+                <a:latin typeface="Helvetica Neue"/>
+              </a:rPr>
+              <a:t>▶ NOTEBOOK</a:t>
+            </a:r>
+          </a:p>
+        </p:txBody>
+      </p:sp>
+      <p:sp>
+        <p:nvSpPr>
+          <p:cNvPr id="18" name="TextBox 17"/>
+          <p:cNvSpPr txBox="1"/>
+          <p:nvPr/>
+        </p:nvSpPr>
+        <p:spPr>
+          <a:xfrm>
+            <a:off x="8615476" y="6451092"/>
+            <a:ext cx="685800" cy="219456"/>
+          </a:xfrm>
+          <a:prstGeom prst="rect">
+            <a:avLst/>
+          </a:prstGeom>
+          <a:noFill/>
+        </p:spPr>
+        <p:txBody>
+          <a:bodyPr wrap="none" lIns="0" rIns="0" tIns="0" bIns="0">
+            <a:spAutoFit/>
+          </a:bodyPr>
+          <a:lstStyle/>
+          <a:p>
+            <a:pPr algn="ctr"/>
+            <a:r>
+              <a:rPr sz="1100" b="1" i="0">
+                <a:solidFill>
+                  <a:srgbClr val="FFFFFF"/>
+                </a:solidFill>
+                <a:latin typeface="Helvetica Neue"/>
+              </a:rPr>
+              <a:t>STEP 6</a:t>
+            </a:r>
+          </a:p>
+        </p:txBody>
+      </p:sp>
+      <p:sp>
+        <p:nvSpPr>
+          <p:cNvPr id="19" name="TextBox 18"/>
+          <p:cNvSpPr txBox="1"/>
+          <p:nvPr/>
+        </p:nvSpPr>
+        <p:spPr>
+          <a:xfrm>
+            <a:off x="9420148" y="6460236"/>
+            <a:ext cx="2030882" cy="219456"/>
+          </a:xfrm>
+          <a:prstGeom prst="rect">
+            <a:avLst/>
+          </a:prstGeom>
+          <a:noFill/>
+        </p:spPr>
+        <p:txBody>
+          <a:bodyPr wrap="none" lIns="0" rIns="0" tIns="0" bIns="0">
+            <a:spAutoFit/>
+          </a:bodyPr>
+          <a:lstStyle/>
+          <a:p>
+            <a:pPr algn="l"/>
+            <a:r>
               <a:rPr sz="1000" b="1" i="0">
                 <a:solidFill>
-                  <a:srgbClr val="A7F3D0"/>
-                </a:solidFill>
-                <a:latin typeface="Helvetica Neue"/>
-              </a:rPr>
-              <a:t>▶ NOTEBOOK</a:t>
-            </a:r>
-          </a:p>
-        </p:txBody>
-      </p:sp>
-      <p:sp>
-        <p:nvSpPr>
-          <p:cNvPr id="18" name="TextBox 17"/>
-          <p:cNvSpPr txBox="1"/>
-          <p:nvPr/>
-        </p:nvSpPr>
-        <p:spPr>
-          <a:xfrm>
-            <a:off x="8431682" y="6451092"/>
-            <a:ext cx="760780" cy="219456"/>
-          </a:xfrm>
-          <a:prstGeom prst="rect">
-            <a:avLst/>
-          </a:prstGeom>
-          <a:noFill/>
-        </p:spPr>
-        <p:txBody>
-          <a:bodyPr wrap="none" lIns="0" rIns="0" tIns="0" bIns="0">
-            <a:spAutoFit/>
-          </a:bodyPr>
-          <a:lstStyle/>
-          <a:p>
-            <a:pPr algn="ctr"/>
-            <a:r>
-              <a:rPr sz="1150" b="1" i="0">
-                <a:solidFill>
                   <a:srgbClr val="FFFFFF"/>
                 </a:solidFill>
                 <a:latin typeface="Helvetica Neue"/>
               </a:rPr>
-              <a:t>CELL 6</a:t>
-            </a:r>
-          </a:p>
-        </p:txBody>
-      </p:sp>
-      <p:sp>
-        <p:nvSpPr>
-          <p:cNvPr id="19" name="TextBox 18"/>
-          <p:cNvSpPr txBox="1"/>
-          <p:nvPr/>
-        </p:nvSpPr>
-        <p:spPr>
-          <a:xfrm>
-            <a:off x="9320479" y="6460236"/>
-            <a:ext cx="2121408" cy="219456"/>
-          </a:xfrm>
-          <a:prstGeom prst="rect">
-            <a:avLst/>
-          </a:prstGeom>
-          <a:noFill/>
-        </p:spPr>
-        <p:txBody>
-          <a:bodyPr wrap="none" lIns="0" rIns="0" tIns="0" bIns="0">
-            <a:spAutoFit/>
-          </a:bodyPr>
-          <a:lstStyle/>
-          <a:p>
-            <a:pPr algn="l"/>
-            <a:r>
-              <a:rPr sz="1050" b="1" i="0">
-                <a:solidFill>
-                  <a:srgbClr val="FFFFFF"/>
-                </a:solidFill>
-                <a:latin typeface="Helvetica Neue"/>
-              </a:rPr>
-              <a:t>text to tokens to ids</a:t>
+              <a:t>Split text into tokens</a:t>
             </a:r>
           </a:p>
         </p:txBody>
@@ -19948,8 +19948,8 @@
         </p:nvSpPr>
         <p:spPr>
           <a:xfrm>
-            <a:off x="6716268" y="6345936"/>
-            <a:ext cx="4835347" cy="365760"/>
+            <a:off x="7172553" y="6345936"/>
+            <a:ext cx="4379061" cy="365760"/>
           </a:xfrm>
           <a:prstGeom prst="roundRect">
             <a:avLst>
@@ -19993,8 +19993,8 @@
         </p:nvSpPr>
         <p:spPr>
           <a:xfrm>
-            <a:off x="7831836" y="6396228"/>
-            <a:ext cx="760780" cy="265176"/>
+            <a:off x="8214969" y="6396228"/>
+            <a:ext cx="685800" cy="265176"/>
           </a:xfrm>
           <a:prstGeom prst="roundRect">
             <a:avLst>
@@ -20038,8 +20038,8 @@
         </p:nvSpPr>
         <p:spPr>
           <a:xfrm>
-            <a:off x="6871716" y="6460236"/>
-            <a:ext cx="1024128" cy="219456"/>
+            <a:off x="7328001" y="6460236"/>
+            <a:ext cx="914400" cy="219456"/>
           </a:xfrm>
           <a:prstGeom prst="rect">
             <a:avLst/>
@@ -20054,83 +20054,83 @@
           <a:p>
             <a:pPr algn="l"/>
             <a:r>
+              <a:rPr sz="950" b="1" i="0">
+                <a:solidFill>
+                  <a:srgbClr val="A7F3D0"/>
+                </a:solidFill>
+                <a:latin typeface="Helvetica Neue"/>
+              </a:rPr>
+              <a:t>▶ NOTEBOOK</a:t>
+            </a:r>
+          </a:p>
+        </p:txBody>
+      </p:sp>
+      <p:sp>
+        <p:nvSpPr>
+          <p:cNvPr id="18" name="TextBox 17"/>
+          <p:cNvSpPr txBox="1"/>
+          <p:nvPr/>
+        </p:nvSpPr>
+        <p:spPr>
+          <a:xfrm>
+            <a:off x="8214969" y="6451092"/>
+            <a:ext cx="685800" cy="219456"/>
+          </a:xfrm>
+          <a:prstGeom prst="rect">
+            <a:avLst/>
+          </a:prstGeom>
+          <a:noFill/>
+        </p:spPr>
+        <p:txBody>
+          <a:bodyPr wrap="none" lIns="0" rIns="0" tIns="0" bIns="0">
+            <a:spAutoFit/>
+          </a:bodyPr>
+          <a:lstStyle/>
+          <a:p>
+            <a:pPr algn="ctr"/>
+            <a:r>
+              <a:rPr sz="1100" b="1" i="0">
+                <a:solidFill>
+                  <a:srgbClr val="FFFFFF"/>
+                </a:solidFill>
+                <a:latin typeface="Helvetica Neue"/>
+              </a:rPr>
+              <a:t>STEP 7</a:t>
+            </a:r>
+          </a:p>
+        </p:txBody>
+      </p:sp>
+      <p:sp>
+        <p:nvSpPr>
+          <p:cNvPr id="19" name="TextBox 18"/>
+          <p:cNvSpPr txBox="1"/>
+          <p:nvPr/>
+        </p:nvSpPr>
+        <p:spPr>
+          <a:xfrm>
+            <a:off x="9019641" y="6460236"/>
+            <a:ext cx="2431389" cy="219456"/>
+          </a:xfrm>
+          <a:prstGeom prst="rect">
+            <a:avLst/>
+          </a:prstGeom>
+          <a:noFill/>
+        </p:spPr>
+        <p:txBody>
+          <a:bodyPr wrap="none" lIns="0" rIns="0" tIns="0" bIns="0">
+            <a:spAutoFit/>
+          </a:bodyPr>
+          <a:lstStyle/>
+          <a:p>
+            <a:pPr algn="l"/>
+            <a:r>
               <a:rPr sz="1000" b="1" i="0">
                 <a:solidFill>
-                  <a:srgbClr val="A7F3D0"/>
-                </a:solidFill>
-                <a:latin typeface="Helvetica Neue"/>
-              </a:rPr>
-              <a:t>▶ NOTEBOOK</a:t>
-            </a:r>
-          </a:p>
-        </p:txBody>
-      </p:sp>
-      <p:sp>
-        <p:nvSpPr>
-          <p:cNvPr id="18" name="TextBox 17"/>
-          <p:cNvSpPr txBox="1"/>
-          <p:nvPr/>
-        </p:nvSpPr>
-        <p:spPr>
-          <a:xfrm>
-            <a:off x="7831836" y="6451092"/>
-            <a:ext cx="760780" cy="219456"/>
-          </a:xfrm>
-          <a:prstGeom prst="rect">
-            <a:avLst/>
-          </a:prstGeom>
-          <a:noFill/>
-        </p:spPr>
-        <p:txBody>
-          <a:bodyPr wrap="none" lIns="0" rIns="0" tIns="0" bIns="0">
-            <a:spAutoFit/>
-          </a:bodyPr>
-          <a:lstStyle/>
-          <a:p>
-            <a:pPr algn="ctr"/>
-            <a:r>
-              <a:rPr sz="1150" b="1" i="0">
-                <a:solidFill>
                   <a:srgbClr val="FFFFFF"/>
                 </a:solidFill>
                 <a:latin typeface="Helvetica Neue"/>
               </a:rPr>
-              <a:t>CELL 7</a:t>
-            </a:r>
-          </a:p>
-        </p:txBody>
-      </p:sp>
-      <p:sp>
-        <p:nvSpPr>
-          <p:cNvPr id="19" name="TextBox 18"/>
-          <p:cNvSpPr txBox="1"/>
-          <p:nvPr/>
-        </p:nvSpPr>
-        <p:spPr>
-          <a:xfrm>
-            <a:off x="8720632" y="6460236"/>
-            <a:ext cx="2721254" cy="219456"/>
-          </a:xfrm>
-          <a:prstGeom prst="rect">
-            <a:avLst/>
-          </a:prstGeom>
-          <a:noFill/>
-        </p:spPr>
-        <p:txBody>
-          <a:bodyPr wrap="none" lIns="0" rIns="0" tIns="0" bIns="0">
-            <a:spAutoFit/>
-          </a:bodyPr>
-          <a:lstStyle/>
-          <a:p>
-            <a:pPr algn="l"/>
-            <a:r>
-              <a:rPr sz="1050" b="1" i="0">
-                <a:solidFill>
-                  <a:srgbClr val="FFFFFF"/>
-                </a:solidFill>
-                <a:latin typeface="Helvetica Neue"/>
-              </a:rPr>
-              <a:t>does your vocabulary survive?</a:t>
+              <a:t>Test your product vocabulary</a:t>
             </a:r>
           </a:p>
         </p:txBody>
@@ -20653,8 +20653,8 @@
         </p:nvSpPr>
         <p:spPr>
           <a:xfrm>
-            <a:off x="7016191" y="6345936"/>
-            <a:ext cx="4535424" cy="365760"/>
+            <a:off x="7239304" y="6345936"/>
+            <a:ext cx="4312310" cy="365760"/>
           </a:xfrm>
           <a:prstGeom prst="roundRect">
             <a:avLst>
@@ -20698,8 +20698,8 @@
         </p:nvSpPr>
         <p:spPr>
           <a:xfrm>
-            <a:off x="8131759" y="6396228"/>
-            <a:ext cx="760780" cy="265176"/>
+            <a:off x="8281720" y="6396228"/>
+            <a:ext cx="685800" cy="265176"/>
           </a:xfrm>
           <a:prstGeom prst="roundRect">
             <a:avLst>
@@ -20743,8 +20743,8 @@
         </p:nvSpPr>
         <p:spPr>
           <a:xfrm>
-            <a:off x="7171639" y="6460236"/>
-            <a:ext cx="1024128" cy="219456"/>
+            <a:off x="7394752" y="6460236"/>
+            <a:ext cx="914400" cy="219456"/>
           </a:xfrm>
           <a:prstGeom prst="rect">
             <a:avLst/>
@@ -20759,83 +20759,83 @@
           <a:p>
             <a:pPr algn="l"/>
             <a:r>
+              <a:rPr sz="950" b="1" i="0">
+                <a:solidFill>
+                  <a:srgbClr val="A7F3D0"/>
+                </a:solidFill>
+                <a:latin typeface="Helvetica Neue"/>
+              </a:rPr>
+              <a:t>▶ NOTEBOOK</a:t>
+            </a:r>
+          </a:p>
+        </p:txBody>
+      </p:sp>
+      <p:sp>
+        <p:nvSpPr>
+          <p:cNvPr id="18" name="TextBox 17"/>
+          <p:cNvSpPr txBox="1"/>
+          <p:nvPr/>
+        </p:nvSpPr>
+        <p:spPr>
+          <a:xfrm>
+            <a:off x="8281720" y="6451092"/>
+            <a:ext cx="685800" cy="219456"/>
+          </a:xfrm>
+          <a:prstGeom prst="rect">
+            <a:avLst/>
+          </a:prstGeom>
+          <a:noFill/>
+        </p:spPr>
+        <p:txBody>
+          <a:bodyPr wrap="none" lIns="0" rIns="0" tIns="0" bIns="0">
+            <a:spAutoFit/>
+          </a:bodyPr>
+          <a:lstStyle/>
+          <a:p>
+            <a:pPr algn="ctr"/>
+            <a:r>
+              <a:rPr sz="1100" b="1" i="0">
+                <a:solidFill>
+                  <a:srgbClr val="FFFFFF"/>
+                </a:solidFill>
+                <a:latin typeface="Helvetica Neue"/>
+              </a:rPr>
+              <a:t>STEP 8</a:t>
+            </a:r>
+          </a:p>
+        </p:txBody>
+      </p:sp>
+      <p:sp>
+        <p:nvSpPr>
+          <p:cNvPr id="19" name="TextBox 18"/>
+          <p:cNvSpPr txBox="1"/>
+          <p:nvPr/>
+        </p:nvSpPr>
+        <p:spPr>
+          <a:xfrm>
+            <a:off x="9086392" y="6460236"/>
+            <a:ext cx="2364638" cy="219456"/>
+          </a:xfrm>
+          <a:prstGeom prst="rect">
+            <a:avLst/>
+          </a:prstGeom>
+          <a:noFill/>
+        </p:spPr>
+        <p:txBody>
+          <a:bodyPr wrap="none" lIns="0" rIns="0" tIns="0" bIns="0">
+            <a:spAutoFit/>
+          </a:bodyPr>
+          <a:lstStyle/>
+          <a:p>
+            <a:pPr algn="l"/>
+            <a:r>
               <a:rPr sz="1000" b="1" i="0">
                 <a:solidFill>
-                  <a:srgbClr val="A7F3D0"/>
-                </a:solidFill>
-                <a:latin typeface="Helvetica Neue"/>
-              </a:rPr>
-              <a:t>▶ NOTEBOOK</a:t>
-            </a:r>
-          </a:p>
-        </p:txBody>
-      </p:sp>
-      <p:sp>
-        <p:nvSpPr>
-          <p:cNvPr id="18" name="TextBox 17"/>
-          <p:cNvSpPr txBox="1"/>
-          <p:nvPr/>
-        </p:nvSpPr>
-        <p:spPr>
-          <a:xfrm>
-            <a:off x="8131759" y="6451092"/>
-            <a:ext cx="760780" cy="219456"/>
-          </a:xfrm>
-          <a:prstGeom prst="rect">
-            <a:avLst/>
-          </a:prstGeom>
-          <a:noFill/>
-        </p:spPr>
-        <p:txBody>
-          <a:bodyPr wrap="none" lIns="0" rIns="0" tIns="0" bIns="0">
-            <a:spAutoFit/>
-          </a:bodyPr>
-          <a:lstStyle/>
-          <a:p>
-            <a:pPr algn="ctr"/>
-            <a:r>
-              <a:rPr sz="1150" b="1" i="0">
-                <a:solidFill>
                   <a:srgbClr val="FFFFFF"/>
                 </a:solidFill>
                 <a:latin typeface="Helvetica Neue"/>
               </a:rPr>
-              <a:t>CELL 8</a:t>
-            </a:r>
-          </a:p>
-        </p:txBody>
-      </p:sp>
-      <p:sp>
-        <p:nvSpPr>
-          <p:cNvPr id="19" name="TextBox 18"/>
-          <p:cNvSpPr txBox="1"/>
-          <p:nvPr/>
-        </p:nvSpPr>
-        <p:spPr>
-          <a:xfrm>
-            <a:off x="9020556" y="6460236"/>
-            <a:ext cx="2421331" cy="219456"/>
-          </a:xfrm>
-          <a:prstGeom prst="rect">
-            <a:avLst/>
-          </a:prstGeom>
-          <a:noFill/>
-        </p:spPr>
-        <p:txBody>
-          <a:bodyPr wrap="none" lIns="0" rIns="0" tIns="0" bIns="0">
-            <a:spAutoFit/>
-          </a:bodyPr>
-          <a:lstStyle/>
-          <a:p>
-            <a:pPr algn="l"/>
-            <a:r>
-              <a:rPr sz="1050" b="1" i="0">
-                <a:solidFill>
-                  <a:srgbClr val="FFFFFF"/>
-                </a:solidFill>
-                <a:latin typeface="Helvetica Neue"/>
-              </a:rPr>
-              <a:t>from tokens to ONE vector</a:t>
+              <a:t>Pool tokens into one vector</a:t>
             </a:r>
           </a:p>
         </p:txBody>
@@ -21393,8 +21393,8 @@
         </p:nvSpPr>
         <p:spPr>
           <a:xfrm>
-            <a:off x="6641287" y="6345936"/>
-            <a:ext cx="4910328" cy="365760"/>
+            <a:off x="7105802" y="6345936"/>
+            <a:ext cx="4445812" cy="365760"/>
           </a:xfrm>
           <a:prstGeom prst="roundRect">
             <a:avLst>
@@ -21438,8 +21438,8 @@
         </p:nvSpPr>
         <p:spPr>
           <a:xfrm>
-            <a:off x="7756855" y="6396228"/>
-            <a:ext cx="760780" cy="265176"/>
+            <a:off x="8148218" y="6396228"/>
+            <a:ext cx="685800" cy="265176"/>
           </a:xfrm>
           <a:prstGeom prst="roundRect">
             <a:avLst>
@@ -21483,8 +21483,8 @@
         </p:nvSpPr>
         <p:spPr>
           <a:xfrm>
-            <a:off x="6796735" y="6460236"/>
-            <a:ext cx="1024128" cy="219456"/>
+            <a:off x="7261250" y="6460236"/>
+            <a:ext cx="914400" cy="219456"/>
           </a:xfrm>
           <a:prstGeom prst="rect">
             <a:avLst/>
@@ -21499,83 +21499,83 @@
           <a:p>
             <a:pPr algn="l"/>
             <a:r>
+              <a:rPr sz="950" b="1" i="0">
+                <a:solidFill>
+                  <a:srgbClr val="A7F3D0"/>
+                </a:solidFill>
+                <a:latin typeface="Helvetica Neue"/>
+              </a:rPr>
+              <a:t>▶ NOTEBOOK</a:t>
+            </a:r>
+          </a:p>
+        </p:txBody>
+      </p:sp>
+      <p:sp>
+        <p:nvSpPr>
+          <p:cNvPr id="19" name="TextBox 18"/>
+          <p:cNvSpPr txBox="1"/>
+          <p:nvPr/>
+        </p:nvSpPr>
+        <p:spPr>
+          <a:xfrm>
+            <a:off x="8148218" y="6451092"/>
+            <a:ext cx="685800" cy="219456"/>
+          </a:xfrm>
+          <a:prstGeom prst="rect">
+            <a:avLst/>
+          </a:prstGeom>
+          <a:noFill/>
+        </p:spPr>
+        <p:txBody>
+          <a:bodyPr wrap="none" lIns="0" rIns="0" tIns="0" bIns="0">
+            <a:spAutoFit/>
+          </a:bodyPr>
+          <a:lstStyle/>
+          <a:p>
+            <a:pPr algn="ctr"/>
+            <a:r>
+              <a:rPr sz="1100" b="1" i="0">
+                <a:solidFill>
+                  <a:srgbClr val="FFFFFF"/>
+                </a:solidFill>
+                <a:latin typeface="Helvetica Neue"/>
+              </a:rPr>
+              <a:t>STEP 9</a:t>
+            </a:r>
+          </a:p>
+        </p:txBody>
+      </p:sp>
+      <p:sp>
+        <p:nvSpPr>
+          <p:cNvPr id="20" name="TextBox 19"/>
+          <p:cNvSpPr txBox="1"/>
+          <p:nvPr/>
+        </p:nvSpPr>
+        <p:spPr>
+          <a:xfrm>
+            <a:off x="8952890" y="6460236"/>
+            <a:ext cx="2498140" cy="219456"/>
+          </a:xfrm>
+          <a:prstGeom prst="rect">
+            <a:avLst/>
+          </a:prstGeom>
+          <a:noFill/>
+        </p:spPr>
+        <p:txBody>
+          <a:bodyPr wrap="none" lIns="0" rIns="0" tIns="0" bIns="0">
+            <a:spAutoFit/>
+          </a:bodyPr>
+          <a:lstStyle/>
+          <a:p>
+            <a:pPr algn="l"/>
+            <a:r>
               <a:rPr sz="1000" b="1" i="0">
                 <a:solidFill>
-                  <a:srgbClr val="A7F3D0"/>
-                </a:solidFill>
-                <a:latin typeface="Helvetica Neue"/>
-              </a:rPr>
-              <a:t>▶ NOTEBOOK</a:t>
-            </a:r>
-          </a:p>
-        </p:txBody>
-      </p:sp>
-      <p:sp>
-        <p:nvSpPr>
-          <p:cNvPr id="19" name="TextBox 18"/>
-          <p:cNvSpPr txBox="1"/>
-          <p:nvPr/>
-        </p:nvSpPr>
-        <p:spPr>
-          <a:xfrm>
-            <a:off x="7756855" y="6451092"/>
-            <a:ext cx="760780" cy="219456"/>
-          </a:xfrm>
-          <a:prstGeom prst="rect">
-            <a:avLst/>
-          </a:prstGeom>
-          <a:noFill/>
-        </p:spPr>
-        <p:txBody>
-          <a:bodyPr wrap="none" lIns="0" rIns="0" tIns="0" bIns="0">
-            <a:spAutoFit/>
-          </a:bodyPr>
-          <a:lstStyle/>
-          <a:p>
-            <a:pPr algn="ctr"/>
-            <a:r>
-              <a:rPr sz="1150" b="1" i="0">
-                <a:solidFill>
                   <a:srgbClr val="FFFFFF"/>
                 </a:solidFill>
                 <a:latin typeface="Helvetica Neue"/>
               </a:rPr>
-              <a:t>CELL 9</a:t>
-            </a:r>
-          </a:p>
-        </p:txBody>
-      </p:sp>
-      <p:sp>
-        <p:nvSpPr>
-          <p:cNvPr id="20" name="TextBox 19"/>
-          <p:cNvSpPr txBox="1"/>
-          <p:nvPr/>
-        </p:nvSpPr>
-        <p:spPr>
-          <a:xfrm>
-            <a:off x="8645652" y="6460236"/>
-            <a:ext cx="2796235" cy="219456"/>
-          </a:xfrm>
-          <a:prstGeom prst="rect">
-            <a:avLst/>
-          </a:prstGeom>
-          <a:noFill/>
-        </p:spPr>
-        <p:txBody>
-          <a:bodyPr wrap="none" lIns="0" rIns="0" tIns="0" bIns="0">
-            <a:spAutoFit/>
-          </a:bodyPr>
-          <a:lstStyle/>
-          <a:p>
-            <a:pPr algn="l"/>
-            <a:r>
-              <a:rPr sz="1050" b="1" i="0">
-                <a:solidFill>
-                  <a:srgbClr val="FFFFFF"/>
-                </a:solidFill>
-                <a:latin typeface="Helvetica Neue"/>
-              </a:rPr>
-              <a:t>what happened inside bert(...)</a:t>
+              <a:t>Watch attention change a word</a:t>
             </a:r>
           </a:p>
         </p:txBody>

</xml_diff>

<commit_message>
Week 7: fix headline/subtitle overlap in the L13 deck
head() placed the subtitle at a fixed y regardless of whether the headline had
wrapped, so four slides had the sub printed on top of the second line. The
headline now auto-fits: when a subtitle is present it shrinks (29pt down to a
21pt floor) until it occupies a single line, and a build-time assertion fails
loudly if one still wraps. One headline too long to shrink was shortened.
Verified: no headline/subtitle collisions across all 21 slides.

Co-Authored-By: Claude Opus 4.8 <noreply@anthropic.com>
</commit_message>
<xml_diff>
--- a/Week 7/L13_Support_Copilot.pptx
+++ b/Week 7/L13_Support_Copilot.pptx
@@ -5839,7 +5839,7 @@
         <p:spPr>
           <a:xfrm>
             <a:off x="640080" y="758952"/>
-            <a:ext cx="7680960" cy="685800"/>
+            <a:ext cx="7680960" cy="704088"/>
           </a:xfrm>
           <a:prstGeom prst="rect">
             <a:avLst/>
@@ -5854,7 +5854,7 @@
           <a:p>
             <a:pPr algn="l"/>
             <a:r>
-              <a:rPr sz="2900" b="1" i="0">
+              <a:rPr sz="2500" b="1" i="0">
                 <a:solidFill>
                   <a:srgbClr val="0F172A"/>
                 </a:solidFill>
@@ -6579,7 +6579,7 @@
         <p:spPr>
           <a:xfrm>
             <a:off x="640080" y="758952"/>
-            <a:ext cx="7680960" cy="685800"/>
+            <a:ext cx="7680960" cy="704088"/>
           </a:xfrm>
           <a:prstGeom prst="rect">
             <a:avLst/>
@@ -7619,7 +7619,7 @@
         <p:spPr>
           <a:xfrm>
             <a:off x="640080" y="758952"/>
-            <a:ext cx="7680960" cy="685800"/>
+            <a:ext cx="7680960" cy="1179576"/>
           </a:xfrm>
           <a:prstGeom prst="rect">
             <a:avLst/>
@@ -8324,7 +8324,7 @@
         <p:spPr>
           <a:xfrm>
             <a:off x="640080" y="758952"/>
-            <a:ext cx="7680960" cy="685800"/>
+            <a:ext cx="7680960" cy="704088"/>
           </a:xfrm>
           <a:prstGeom prst="rect">
             <a:avLst/>
@@ -8339,7 +8339,7 @@
           <a:p>
             <a:pPr algn="l"/>
             <a:r>
-              <a:rPr sz="2900" b="1" i="0">
+              <a:rPr sz="2450" b="1" i="0">
                 <a:solidFill>
                   <a:srgbClr val="0F172A"/>
                 </a:solidFill>
@@ -9099,7 +9099,7 @@
         <p:spPr>
           <a:xfrm>
             <a:off x="640080" y="758952"/>
-            <a:ext cx="7680960" cy="685800"/>
+            <a:ext cx="7680960" cy="1179576"/>
           </a:xfrm>
           <a:prstGeom prst="rect">
             <a:avLst/>
@@ -9804,7 +9804,7 @@
         <p:spPr>
           <a:xfrm>
             <a:off x="640080" y="758952"/>
-            <a:ext cx="7680960" cy="685800"/>
+            <a:ext cx="7680960" cy="704088"/>
           </a:xfrm>
           <a:prstGeom prst="rect">
             <a:avLst/>
@@ -9819,7 +9819,7 @@
           <a:p>
             <a:pPr algn="l"/>
             <a:r>
-              <a:rPr sz="2900" b="1" i="0">
+              <a:rPr sz="2650" b="1" i="0">
                 <a:solidFill>
                   <a:srgbClr val="0F172A"/>
                 </a:solidFill>
@@ -10579,7 +10579,7 @@
         <p:spPr>
           <a:xfrm>
             <a:off x="640080" y="758952"/>
-            <a:ext cx="7680960" cy="685800"/>
+            <a:ext cx="7680960" cy="704088"/>
           </a:xfrm>
           <a:prstGeom prst="rect">
             <a:avLst/>
@@ -11284,7 +11284,7 @@
         <p:spPr>
           <a:xfrm>
             <a:off x="640080" y="758952"/>
-            <a:ext cx="7680960" cy="685800"/>
+            <a:ext cx="7680960" cy="704088"/>
           </a:xfrm>
           <a:prstGeom prst="rect">
             <a:avLst/>
@@ -11864,7 +11864,7 @@
         <p:spPr>
           <a:xfrm>
             <a:off x="640080" y="758952"/>
-            <a:ext cx="7680960" cy="685800"/>
+            <a:ext cx="7680960" cy="1179576"/>
           </a:xfrm>
           <a:prstGeom prst="rect">
             <a:avLst/>
@@ -12409,7 +12409,7 @@
         <p:spPr>
           <a:xfrm>
             <a:off x="640080" y="758952"/>
-            <a:ext cx="10972800" cy="685800"/>
+            <a:ext cx="10972800" cy="704088"/>
           </a:xfrm>
           <a:prstGeom prst="rect">
             <a:avLst/>
@@ -12626,7 +12626,7 @@
         <p:spPr>
           <a:xfrm>
             <a:off x="640080" y="758952"/>
-            <a:ext cx="10972800" cy="685800"/>
+            <a:ext cx="10972800" cy="704088"/>
           </a:xfrm>
           <a:prstGeom prst="rect">
             <a:avLst/>
@@ -13194,7 +13194,7 @@
         <p:spPr>
           <a:xfrm>
             <a:off x="640080" y="758952"/>
-            <a:ext cx="10972800" cy="685800"/>
+            <a:ext cx="10972800" cy="704088"/>
           </a:xfrm>
           <a:prstGeom prst="rect">
             <a:avLst/>
@@ -13376,7 +13376,7 @@
         <p:spPr>
           <a:xfrm>
             <a:off x="640080" y="758952"/>
-            <a:ext cx="10972800" cy="685800"/>
+            <a:ext cx="10972800" cy="704088"/>
           </a:xfrm>
           <a:prstGeom prst="rect">
             <a:avLst/>
@@ -13986,7 +13986,7 @@
         <p:spPr>
           <a:xfrm>
             <a:off x="640080" y="758952"/>
-            <a:ext cx="10972800" cy="685800"/>
+            <a:ext cx="10972800" cy="704088"/>
           </a:xfrm>
           <a:prstGeom prst="rect">
             <a:avLst/>
@@ -14203,7 +14203,7 @@
         <p:spPr>
           <a:xfrm>
             <a:off x="640080" y="758952"/>
-            <a:ext cx="10972800" cy="685800"/>
+            <a:ext cx="10972800" cy="704088"/>
           </a:xfrm>
           <a:prstGeom prst="rect">
             <a:avLst/>
@@ -14973,7 +14973,7 @@
         <p:spPr>
           <a:xfrm>
             <a:off x="640080" y="758952"/>
-            <a:ext cx="10972800" cy="685800"/>
+            <a:ext cx="10972800" cy="704088"/>
           </a:xfrm>
           <a:prstGeom prst="rect">
             <a:avLst/>
@@ -15155,7 +15155,7 @@
         <p:spPr>
           <a:xfrm>
             <a:off x="640080" y="758952"/>
-            <a:ext cx="7680960" cy="685800"/>
+            <a:ext cx="7680960" cy="704088"/>
           </a:xfrm>
           <a:prstGeom prst="rect">
             <a:avLst/>
@@ -15895,7 +15895,7 @@
         <p:spPr>
           <a:xfrm>
             <a:off x="640080" y="758952"/>
-            <a:ext cx="7680960" cy="685800"/>
+            <a:ext cx="7680960" cy="704088"/>
           </a:xfrm>
           <a:prstGeom prst="rect">
             <a:avLst/>
@@ -16635,7 +16635,7 @@
         <p:spPr>
           <a:xfrm>
             <a:off x="640080" y="758952"/>
-            <a:ext cx="7680960" cy="685800"/>
+            <a:ext cx="7680960" cy="704088"/>
           </a:xfrm>
           <a:prstGeom prst="rect">
             <a:avLst/>
@@ -16656,7 +16656,7 @@
                 </a:solidFill>
                 <a:latin typeface="Helvetica Neue"/>
               </a:rPr>
-              <a:t>So how did it do that? Start with the smallest piece.</a:t>
+              <a:t>So how did it do that?</a:t>
             </a:r>
           </a:p>
         </p:txBody>
@@ -16691,7 +16691,7 @@
                 </a:solidFill>
                 <a:latin typeface="Helvetica Neue"/>
               </a:rPr>
-              <a:t>A model cannot read. It can only do arithmetic, so the text has to become numbers.</a:t>
+              <a:t>To answer that we go all the way down: a model cannot read, so the text has to become numbers first.</a:t>
             </a:r>
           </a:p>
         </p:txBody>
@@ -17375,7 +17375,7 @@
         <p:spPr>
           <a:xfrm>
             <a:off x="640080" y="758952"/>
-            <a:ext cx="7680960" cy="685800"/>
+            <a:ext cx="7680960" cy="1179576"/>
           </a:xfrm>
           <a:prstGeom prst="rect">
             <a:avLst/>

</xml_diff>